<commit_message>
feat(deck): Session 1 review deck v2 — Sem3-vs-Sem4 scope slide + audited evidence-scale slide
Two additions to the Phase 1 First Review deck (now 13 slides):
- 'Semester 3 Foundation vs. Semester 4 Innovations' (slide 3): capstone
  boundary vs the solo ZVF program and the P1-P8 modular portfolio.
- 'Infrastructure & Evidence Scale (audited 12 Jul)' (slide 8): 983
  Tinker runs / 26 base models (0.6B-1T), Modal + Lightning AI + Colab
  evaluation fabric, 1,034 W&B runs across 17 projects, 49 HF artifact
  repos, and the run-level audit workbook - framed as why the
  de-confound pillars are feasible in one semester (Session-1 scope:
  capability evidence, not results claims).
Page numbers renumbered; deck regenerated from build_session1_deck.py.
</commit_message>
<xml_diff>
--- a/outputs/PESU_MTech_Phase1_Session1_Review_ArvindCR.pptx
+++ b/outputs/PESU_MTech_Phase1_Session1_Review_ArvindCR.pptx
@@ -15,6 +15,9 @@
     <p:sldId id="263" r:id="rId14"/>
     <p:sldId id="264" r:id="rId15"/>
     <p:sldId id="265" r:id="rId16"/>
+    <p:sldId id="266" r:id="rId17"/>
+    <p:sldId id="267" r:id="rId18"/>
+    <p:sldId id="268" r:id="rId19"/>
   </p:sldIdLst>
   <p:sldSz cx="12191695" cy="6858000" type="screen4x3"/>
   <p:notesSz cx="6858000" cy="9144000"/>
@@ -3226,6 +3229,707 @@
         </p:nvSpPr>
         <p:spPr>
           <a:xfrm>
+            <a:off x="548640" y="320040"/>
+            <a:ext cx="11064240" cy="731520"/>
+          </a:xfrm>
+          <a:prstGeom prst="rect">
+            <a:avLst/>
+          </a:prstGeom>
+          <a:noFill/>
+        </p:spPr>
+        <p:txBody>
+          <a:bodyPr wrap="none">
+            <a:spAutoFit/>
+          </a:bodyPr>
+          <a:lstStyle/>
+          <a:p>
+            <a:pPr algn="l">
+              <a:spcAft>
+                <a:spcPts val="800"/>
+              </a:spcAft>
+            </a:pPr>
+            <a:r>
+              <a:rPr sz="2800" b="1">
+                <a:solidFill>
+                  <a:srgbClr val="1F4E79"/>
+                </a:solidFill>
+                <a:latin typeface="Calibri"/>
+              </a:rPr>
+              <a:t>Work Plan &amp; Deliverables (Semester 4)</a:t>
+            </a:r>
+          </a:p>
+        </p:txBody>
+      </p:sp>
+      <p:sp>
+        <p:nvSpPr>
+          <p:cNvPr id="3" name="TextBox 2"/>
+          <p:cNvSpPr txBox="1"/>
+          <p:nvPr/>
+        </p:nvSpPr>
+        <p:spPr>
+          <a:xfrm>
+            <a:off x="548640" y="1005840"/>
+            <a:ext cx="11064240" cy="45720"/>
+          </a:xfrm>
+          <a:prstGeom prst="rect">
+            <a:avLst/>
+          </a:prstGeom>
+          <a:noFill/>
+        </p:spPr>
+        <p:txBody>
+          <a:bodyPr wrap="none">
+            <a:spAutoFit/>
+          </a:bodyPr>
+          <a:lstStyle/>
+          <a:p/>
+        </p:txBody>
+      </p:sp>
+      <p:sp>
+        <p:nvSpPr>
+          <p:cNvPr id="4" name="TextBox 3"/>
+          <p:cNvSpPr txBox="1"/>
+          <p:nvPr/>
+        </p:nvSpPr>
+        <p:spPr>
+          <a:xfrm>
+            <a:off x="11430000" y="6446520"/>
+            <a:ext cx="548640" cy="320040"/>
+          </a:xfrm>
+          <a:prstGeom prst="rect">
+            <a:avLst/>
+          </a:prstGeom>
+          <a:noFill/>
+        </p:spPr>
+        <p:txBody>
+          <a:bodyPr wrap="none">
+            <a:spAutoFit/>
+          </a:bodyPr>
+          <a:lstStyle/>
+          <a:p>
+            <a:pPr algn="l">
+              <a:spcAft>
+                <a:spcPts val="800"/>
+              </a:spcAft>
+            </a:pPr>
+            <a:r>
+              <a:rPr sz="1100" b="0">
+                <a:solidFill>
+                  <a:srgbClr val="5A5A5A"/>
+                </a:solidFill>
+                <a:latin typeface="Calibri"/>
+              </a:rPr>
+              <a:t>10</a:t>
+            </a:r>
+          </a:p>
+        </p:txBody>
+      </p:sp>
+      <p:sp>
+        <p:nvSpPr>
+          <p:cNvPr id="5" name="TextBox 4"/>
+          <p:cNvSpPr txBox="1"/>
+          <p:nvPr/>
+        </p:nvSpPr>
+        <p:spPr>
+          <a:xfrm>
+            <a:off x="731520" y="1280160"/>
+            <a:ext cx="10698480" cy="4937760"/>
+          </a:xfrm>
+          <a:prstGeom prst="rect">
+            <a:avLst/>
+          </a:prstGeom>
+          <a:noFill/>
+        </p:spPr>
+        <p:txBody>
+          <a:bodyPr wrap="square">
+            <a:spAutoFit/>
+          </a:bodyPr>
+          <a:lstStyle/>
+          <a:p>
+            <a:pPr algn="l">
+              <a:spcAft>
+                <a:spcPts val="800"/>
+              </a:spcAft>
+            </a:pPr>
+            <a:r>
+              <a:rPr sz="1600" b="0">
+                <a:solidFill>
+                  <a:srgbClr val="212121"/>
+                </a:solidFill>
+                <a:latin typeface="Calibri"/>
+              </a:rPr>
+              <a:t>•  Phase A (weeks 1–4): pillar experiments + ZVF telemetry implementation.</a:t>
+            </a:r>
+          </a:p>
+          <a:p>
+            <a:pPr algn="l">
+              <a:spcAft>
+                <a:spcPts val="800"/>
+              </a:spcAft>
+            </a:pPr>
+            <a:r>
+              <a:rPr sz="1600" b="0">
+                <a:solidFill>
+                  <a:srgbClr val="212121"/>
+                </a:solidFill>
+                <a:latin typeface="Calibri"/>
+              </a:rPr>
+              <a:t>•  Phase B (weeks 5–8): analysis papers P1–P4 (scaling, ZVF, group size, length bias).</a:t>
+            </a:r>
+          </a:p>
+          <a:p>
+            <a:pPr algn="l">
+              <a:spcAft>
+                <a:spcPts val="800"/>
+              </a:spcAft>
+            </a:pPr>
+            <a:r>
+              <a:rPr sz="1600" b="0">
+                <a:solidFill>
+                  <a:srgbClr val="212121"/>
+                </a:solidFill>
+                <a:latin typeface="Calibri"/>
+              </a:rPr>
+              <a:t>•  Phase C (weeks 9–12): standards &amp; tooling papers P5–P7 (reporting standard, registry, adaptive controller).</a:t>
+            </a:r>
+          </a:p>
+          <a:p>
+            <a:pPr algn="l">
+              <a:spcAft>
+                <a:spcPts val="800"/>
+              </a:spcAft>
+            </a:pPr>
+            <a:r>
+              <a:rPr sz="1600" b="0">
+                <a:solidFill>
+                  <a:srgbClr val="212121"/>
+                </a:solidFill>
+                <a:latin typeface="Calibri"/>
+              </a:rPr>
+              <a:t>•  Phase D: applied case study P8 (LLM vs XGBoost on fraud) + workshop paper submission.</a:t>
+            </a:r>
+          </a:p>
+          <a:p>
+            <a:pPr algn="l">
+              <a:spcAft>
+                <a:spcPts val="800"/>
+              </a:spcAft>
+            </a:pPr>
+            <a:r>
+              <a:rPr sz="1600" b="1">
+                <a:solidFill>
+                  <a:srgbClr val="212121"/>
+                </a:solidFill>
+                <a:latin typeface="Calibri"/>
+              </a:rPr>
+              <a:t>•  Reviews: Session 1 (this) → Session 2 (mid results) → Session 3 (complete results + demo).</a:t>
+            </a:r>
+          </a:p>
+        </p:txBody>
+      </p:sp>
+    </p:spTree>
+  </p:cSld>
+  <p:clrMapOvr>
+    <a:masterClrMapping/>
+  </p:clrMapOvr>
+</p:sld>
+</file>
+
+<file path=ppt/slides/slide11.xml><?xml version="1.0" encoding="utf-8"?>
+<p:sld xmlns:a="http://schemas.openxmlformats.org/drawingml/2006/main" xmlns:p="http://schemas.openxmlformats.org/presentationml/2006/main" xmlns:r="http://schemas.openxmlformats.org/officeDocument/2006/relationships">
+  <p:cSld>
+    <p:spTree>
+      <p:nvGrpSpPr>
+        <p:cNvPr id="1" name=""/>
+        <p:cNvGrpSpPr/>
+        <p:nvPr/>
+      </p:nvGrpSpPr>
+      <p:grpSpPr/>
+      <p:sp>
+        <p:nvSpPr>
+          <p:cNvPr id="2" name="TextBox 1"/>
+          <p:cNvSpPr txBox="1"/>
+          <p:nvPr/>
+        </p:nvSpPr>
+        <p:spPr>
+          <a:xfrm>
+            <a:off x="548640" y="320040"/>
+            <a:ext cx="11064240" cy="731520"/>
+          </a:xfrm>
+          <a:prstGeom prst="rect">
+            <a:avLst/>
+          </a:prstGeom>
+          <a:noFill/>
+        </p:spPr>
+        <p:txBody>
+          <a:bodyPr wrap="none">
+            <a:spAutoFit/>
+          </a:bodyPr>
+          <a:lstStyle/>
+          <a:p>
+            <a:pPr algn="l">
+              <a:spcAft>
+                <a:spcPts val="800"/>
+              </a:spcAft>
+            </a:pPr>
+            <a:r>
+              <a:rPr sz="2800" b="1">
+                <a:solidFill>
+                  <a:srgbClr val="1F4E79"/>
+                </a:solidFill>
+                <a:latin typeface="Calibri"/>
+              </a:rPr>
+              <a:t>The 8-Paper ZVF Program Portfolio</a:t>
+            </a:r>
+          </a:p>
+        </p:txBody>
+      </p:sp>
+      <p:sp>
+        <p:nvSpPr>
+          <p:cNvPr id="3" name="TextBox 2"/>
+          <p:cNvSpPr txBox="1"/>
+          <p:nvPr/>
+        </p:nvSpPr>
+        <p:spPr>
+          <a:xfrm>
+            <a:off x="548640" y="1005840"/>
+            <a:ext cx="11064240" cy="45720"/>
+          </a:xfrm>
+          <a:prstGeom prst="rect">
+            <a:avLst/>
+          </a:prstGeom>
+          <a:noFill/>
+        </p:spPr>
+        <p:txBody>
+          <a:bodyPr wrap="none">
+            <a:spAutoFit/>
+          </a:bodyPr>
+          <a:lstStyle/>
+          <a:p/>
+        </p:txBody>
+      </p:sp>
+      <p:sp>
+        <p:nvSpPr>
+          <p:cNvPr id="4" name="TextBox 3"/>
+          <p:cNvSpPr txBox="1"/>
+          <p:nvPr/>
+        </p:nvSpPr>
+        <p:spPr>
+          <a:xfrm>
+            <a:off x="11430000" y="6446520"/>
+            <a:ext cx="548640" cy="320040"/>
+          </a:xfrm>
+          <a:prstGeom prst="rect">
+            <a:avLst/>
+          </a:prstGeom>
+          <a:noFill/>
+        </p:spPr>
+        <p:txBody>
+          <a:bodyPr wrap="none">
+            <a:spAutoFit/>
+          </a:bodyPr>
+          <a:lstStyle/>
+          <a:p>
+            <a:pPr algn="l">
+              <a:spcAft>
+                <a:spcPts val="800"/>
+              </a:spcAft>
+            </a:pPr>
+            <a:r>
+              <a:rPr sz="1100" b="0">
+                <a:solidFill>
+                  <a:srgbClr val="5A5A5A"/>
+                </a:solidFill>
+                <a:latin typeface="Calibri"/>
+              </a:rPr>
+              <a:t>11</a:t>
+            </a:r>
+          </a:p>
+        </p:txBody>
+      </p:sp>
+      <p:sp>
+        <p:nvSpPr>
+          <p:cNvPr id="5" name="TextBox 4"/>
+          <p:cNvSpPr txBox="1"/>
+          <p:nvPr/>
+        </p:nvSpPr>
+        <p:spPr>
+          <a:xfrm>
+            <a:off x="731520" y="1280160"/>
+            <a:ext cx="10698480" cy="4937760"/>
+          </a:xfrm>
+          <a:prstGeom prst="rect">
+            <a:avLst/>
+          </a:prstGeom>
+          <a:noFill/>
+        </p:spPr>
+        <p:txBody>
+          <a:bodyPr wrap="square">
+            <a:spAutoFit/>
+          </a:bodyPr>
+          <a:lstStyle/>
+          <a:p>
+            <a:pPr algn="l">
+              <a:spcAft>
+                <a:spcPts val="800"/>
+              </a:spcAft>
+            </a:pPr>
+            <a:r>
+              <a:rPr sz="1400" b="0">
+                <a:solidFill>
+                  <a:srgbClr val="212121"/>
+                </a:solidFill>
+                <a:latin typeface="Calibri"/>
+              </a:rPr>
+              <a:t>•  P1: Scaling Laws — Testing power laws for GRPO and parameter vs capability structure.</a:t>
+            </a:r>
+          </a:p>
+          <a:p>
+            <a:pPr algn="l">
+              <a:spcAft>
+                <a:spcPts val="800"/>
+              </a:spcAft>
+            </a:pPr>
+            <a:r>
+              <a:rPr sz="1400" b="0">
+                <a:solidFill>
+                  <a:srgbClr val="212121"/>
+                </a:solidFill>
+                <a:latin typeface="Calibri"/>
+              </a:rPr>
+              <a:t>•  P2: Zero-Variance Fraction (ZVF) — A diagnostic metric for signal starvation.</a:t>
+            </a:r>
+          </a:p>
+          <a:p>
+            <a:pPr algn="l">
+              <a:spcAft>
+                <a:spcPts val="800"/>
+              </a:spcAft>
+            </a:pPr>
+            <a:r>
+              <a:rPr sz="1400" b="0">
+                <a:solidFill>
+                  <a:srgbClr val="212121"/>
+                </a:solidFill>
+                <a:latin typeface="Calibri"/>
+              </a:rPr>
+              <a:t>•  P3: Group Size — Re-framing group size as a preference-density dial.</a:t>
+            </a:r>
+          </a:p>
+          <a:p>
+            <a:pPr algn="l">
+              <a:spcAft>
+                <a:spcPts val="800"/>
+              </a:spcAft>
+            </a:pPr>
+            <a:r>
+              <a:rPr sz="1400" b="0">
+                <a:solidFill>
+                  <a:srgbClr val="212121"/>
+                </a:solidFill>
+                <a:latin typeface="Calibri"/>
+              </a:rPr>
+              <a:t>•  P4: Length Bias — Analyzing the verbosity trap and Dr. GRPO corrections.</a:t>
+            </a:r>
+          </a:p>
+          <a:p>
+            <a:pPr algn="l">
+              <a:spcAft>
+                <a:spcPts val="800"/>
+              </a:spcAft>
+            </a:pPr>
+            <a:r>
+              <a:rPr sz="1400" b="0">
+                <a:solidFill>
+                  <a:srgbClr val="212121"/>
+                </a:solidFill>
+                <a:latin typeface="Calibri"/>
+              </a:rPr>
+              <a:t>•  P5: Report the Stack — Identifying backend-driven reward swings (MIN-REPORT-RL).</a:t>
+            </a:r>
+          </a:p>
+          <a:p>
+            <a:pPr algn="l">
+              <a:spcAft>
+                <a:spcPts val="800"/>
+              </a:spcAft>
+            </a:pPr>
+            <a:r>
+              <a:rPr sz="1400" b="0">
+                <a:solidFill>
+                  <a:srgbClr val="212121"/>
+                </a:solidFill>
+                <a:latin typeface="Calibri"/>
+              </a:rPr>
+              <a:t>•  P6: GRPO Registry — A machine-readable catalog and stackdiff tool.</a:t>
+            </a:r>
+          </a:p>
+          <a:p>
+            <a:pPr algn="l">
+              <a:spcAft>
+                <a:spcPts val="800"/>
+              </a:spcAft>
+            </a:pPr>
+            <a:r>
+              <a:rPr sz="1400" b="0">
+                <a:solidFill>
+                  <a:srgbClr val="212121"/>
+                </a:solidFill>
+                <a:latin typeface="Calibri"/>
+              </a:rPr>
+              <a:t>•  P7: ZVF Controller — An adaptive controller escalating group size dynamically.</a:t>
+            </a:r>
+          </a:p>
+          <a:p>
+            <a:pPr algn="l">
+              <a:spcAft>
+                <a:spcPts val="800"/>
+              </a:spcAft>
+            </a:pPr>
+            <a:r>
+              <a:rPr sz="1400" b="0">
+                <a:solidFill>
+                  <a:srgbClr val="212121"/>
+                </a:solidFill>
+                <a:latin typeface="Calibri"/>
+              </a:rPr>
+              <a:t>•  P8: Fraud Detection — Evaluating LLMs as sensors/scribes vs. XGBoost scorers.</a:t>
+            </a:r>
+          </a:p>
+        </p:txBody>
+      </p:sp>
+    </p:spTree>
+  </p:cSld>
+  <p:clrMapOvr>
+    <a:masterClrMapping/>
+  </p:clrMapOvr>
+</p:sld>
+</file>
+
+<file path=ppt/slides/slide12.xml><?xml version="1.0" encoding="utf-8"?>
+<p:sld xmlns:a="http://schemas.openxmlformats.org/drawingml/2006/main" xmlns:p="http://schemas.openxmlformats.org/presentationml/2006/main" xmlns:r="http://schemas.openxmlformats.org/officeDocument/2006/relationships">
+  <p:cSld>
+    <p:spTree>
+      <p:nvGrpSpPr>
+        <p:cNvPr id="1" name=""/>
+        <p:cNvGrpSpPr/>
+        <p:nvPr/>
+      </p:nvGrpSpPr>
+      <p:grpSpPr/>
+      <p:sp>
+        <p:nvSpPr>
+          <p:cNvPr id="2" name="TextBox 1"/>
+          <p:cNvSpPr txBox="1"/>
+          <p:nvPr/>
+        </p:nvSpPr>
+        <p:spPr>
+          <a:xfrm>
+            <a:off x="548640" y="320040"/>
+            <a:ext cx="11064240" cy="731520"/>
+          </a:xfrm>
+          <a:prstGeom prst="rect">
+            <a:avLst/>
+          </a:prstGeom>
+          <a:noFill/>
+        </p:spPr>
+        <p:txBody>
+          <a:bodyPr wrap="none">
+            <a:spAutoFit/>
+          </a:bodyPr>
+          <a:lstStyle/>
+          <a:p>
+            <a:pPr algn="l">
+              <a:spcAft>
+                <a:spcPts val="800"/>
+              </a:spcAft>
+            </a:pPr>
+            <a:r>
+              <a:rPr sz="2800" b="1">
+                <a:solidFill>
+                  <a:srgbClr val="1F4E79"/>
+                </a:solidFill>
+                <a:latin typeface="Calibri"/>
+              </a:rPr>
+              <a:t>Expected Outcomes &amp; Evaluation Criteria</a:t>
+            </a:r>
+          </a:p>
+        </p:txBody>
+      </p:sp>
+      <p:sp>
+        <p:nvSpPr>
+          <p:cNvPr id="3" name="TextBox 2"/>
+          <p:cNvSpPr txBox="1"/>
+          <p:nvPr/>
+        </p:nvSpPr>
+        <p:spPr>
+          <a:xfrm>
+            <a:off x="548640" y="1005840"/>
+            <a:ext cx="11064240" cy="45720"/>
+          </a:xfrm>
+          <a:prstGeom prst="rect">
+            <a:avLst/>
+          </a:prstGeom>
+          <a:noFill/>
+        </p:spPr>
+        <p:txBody>
+          <a:bodyPr wrap="none">
+            <a:spAutoFit/>
+          </a:bodyPr>
+          <a:lstStyle/>
+          <a:p/>
+        </p:txBody>
+      </p:sp>
+      <p:sp>
+        <p:nvSpPr>
+          <p:cNvPr id="4" name="TextBox 3"/>
+          <p:cNvSpPr txBox="1"/>
+          <p:nvPr/>
+        </p:nvSpPr>
+        <p:spPr>
+          <a:xfrm>
+            <a:off x="11430000" y="6446520"/>
+            <a:ext cx="548640" cy="320040"/>
+          </a:xfrm>
+          <a:prstGeom prst="rect">
+            <a:avLst/>
+          </a:prstGeom>
+          <a:noFill/>
+        </p:spPr>
+        <p:txBody>
+          <a:bodyPr wrap="none">
+            <a:spAutoFit/>
+          </a:bodyPr>
+          <a:lstStyle/>
+          <a:p>
+            <a:pPr algn="l">
+              <a:spcAft>
+                <a:spcPts val="800"/>
+              </a:spcAft>
+            </a:pPr>
+            <a:r>
+              <a:rPr sz="1100" b="0">
+                <a:solidFill>
+                  <a:srgbClr val="5A5A5A"/>
+                </a:solidFill>
+                <a:latin typeface="Calibri"/>
+              </a:rPr>
+              <a:t>12</a:t>
+            </a:r>
+          </a:p>
+        </p:txBody>
+      </p:sp>
+      <p:sp>
+        <p:nvSpPr>
+          <p:cNvPr id="5" name="TextBox 4"/>
+          <p:cNvSpPr txBox="1"/>
+          <p:nvPr/>
+        </p:nvSpPr>
+        <p:spPr>
+          <a:xfrm>
+            <a:off x="731520" y="1280160"/>
+            <a:ext cx="10698480" cy="4937760"/>
+          </a:xfrm>
+          <a:prstGeom prst="rect">
+            <a:avLst/>
+          </a:prstGeom>
+          <a:noFill/>
+        </p:spPr>
+        <p:txBody>
+          <a:bodyPr wrap="square">
+            <a:spAutoFit/>
+          </a:bodyPr>
+          <a:lstStyle/>
+          <a:p>
+            <a:pPr algn="l">
+              <a:spcAft>
+                <a:spcPts val="800"/>
+              </a:spcAft>
+            </a:pPr>
+            <a:r>
+              <a:rPr sz="1600" b="0">
+                <a:solidFill>
+                  <a:srgbClr val="212121"/>
+                </a:solidFill>
+                <a:latin typeface="Calibri"/>
+              </a:rPr>
+              <a:t>•  A defensible answer to PPO-vs-GRPO under matched conditions (effect size + CI).</a:t>
+            </a:r>
+          </a:p>
+          <a:p>
+            <a:pPr algn="l">
+              <a:spcAft>
+                <a:spcPts val="800"/>
+              </a:spcAft>
+            </a:pPr>
+            <a:r>
+              <a:rPr sz="1600" b="0">
+                <a:solidFill>
+                  <a:srgbClr val="212121"/>
+                </a:solidFill>
+                <a:latin typeface="Calibri"/>
+              </a:rPr>
+              <a:t>•  ZVF validated (or refuted) as a cheap online diagnostic, with a group-size guidance rule.</a:t>
+            </a:r>
+          </a:p>
+          <a:p>
+            <a:pPr algn="l">
+              <a:spcAft>
+                <a:spcPts val="800"/>
+              </a:spcAft>
+            </a:pPr>
+            <a:r>
+              <a:rPr sz="1600" b="0">
+                <a:solidFill>
+                  <a:srgbClr val="212121"/>
+                </a:solidFill>
+                <a:latin typeface="Calibri"/>
+              </a:rPr>
+              <a:t>•  Eight short papers (P1–P8) + one workshop submission; reproducible artifact.</a:t>
+            </a:r>
+          </a:p>
+          <a:p>
+            <a:pPr algn="l">
+              <a:spcAft>
+                <a:spcPts val="800"/>
+              </a:spcAft>
+            </a:pPr>
+            <a:r>
+              <a:rPr sz="1600" b="1">
+                <a:solidFill>
+                  <a:srgbClr val="212121"/>
+                </a:solidFill>
+                <a:latin typeface="Calibri"/>
+              </a:rPr>
+              <a:t>•  Success = claims that survive held-out evaluation and independent audit, not peak training reward.</a:t>
+            </a:r>
+          </a:p>
+        </p:txBody>
+      </p:sp>
+    </p:spTree>
+  </p:cSld>
+  <p:clrMapOvr>
+    <a:masterClrMapping/>
+  </p:clrMapOvr>
+</p:sld>
+</file>
+
+<file path=ppt/slides/slide13.xml><?xml version="1.0" encoding="utf-8"?>
+<p:sld xmlns:a="http://schemas.openxmlformats.org/drawingml/2006/main" xmlns:p="http://schemas.openxmlformats.org/presentationml/2006/main" xmlns:r="http://schemas.openxmlformats.org/officeDocument/2006/relationships">
+  <p:cSld>
+    <p:spTree>
+      <p:nvGrpSpPr>
+        <p:cNvPr id="1" name=""/>
+        <p:cNvGrpSpPr/>
+        <p:nvPr/>
+      </p:nvGrpSpPr>
+      <p:grpSpPr/>
+      <p:sp>
+        <p:nvSpPr>
+          <p:cNvPr id="2" name="TextBox 1"/>
+          <p:cNvSpPr txBox="1"/>
+          <p:nvPr/>
+        </p:nvSpPr>
+        <p:spPr>
+          <a:xfrm>
             <a:off x="914400" y="2468880"/>
             <a:ext cx="10332720" cy="1828800"/>
           </a:xfrm>
@@ -3532,7 +4236,7 @@
                 </a:solidFill>
                 <a:latin typeface="Calibri"/>
               </a:rPr>
-              <a:t>Problem Statement &amp; Motivation</a:t>
+              <a:t>Semester 3 Foundation vs. Semester 4 Innovations</a:t>
             </a:r>
           </a:p>
         </p:txBody>
@@ -3628,29 +4332,45 @@
               </a:spcAft>
             </a:pPr>
             <a:r>
+              <a:rPr sz="1600" b="0">
+                <a:solidFill>
+                  <a:srgbClr val="212121"/>
+                </a:solidFill>
+                <a:latin typeface="Calibri"/>
+              </a:rPr>
+              <a:t>•  Semester 3 Delivered: A 101-page experimental framework survey and the TINKERRL-BENCH benchmark (submitted to NeurIPS Main Track).</a:t>
+            </a:r>
+          </a:p>
+          <a:p>
+            <a:pPr algn="l">
+              <a:spcAft>
+                <a:spcPts val="800"/>
+              </a:spcAft>
+            </a:pPr>
+            <a:r>
               <a:rPr sz="1600" b="1">
                 <a:solidFill>
                   <a:srgbClr val="212121"/>
                 </a:solidFill>
                 <a:latin typeface="Calibri"/>
               </a:rPr>
-              <a:t>•  Published RL-for-LLM results are stack-conditioned: the same algorithm yields different outcomes across frameworks, backends, and defaults.</a:t>
-            </a:r>
-          </a:p>
-          <a:p>
-            <a:pPr algn="l">
-              <a:spcAft>
-                <a:spcPts val="800"/>
-              </a:spcAft>
-            </a:pPr>
-            <a:r>
-              <a:rPr sz="1600" b="1">
+              <a:t>•  Semester 4 Objective: Deep dive into the mechanics of GRPO via the ZVF (Zero-Variance Fraction) program.</a:t>
+            </a:r>
+          </a:p>
+          <a:p>
+            <a:pPr algn="l">
+              <a:spcAft>
+                <a:spcPts val="800"/>
+              </a:spcAft>
+            </a:pPr>
+            <a:r>
+              <a:rPr sz="1600" b="0">
                 <a:solidFill>
                   <a:srgbClr val="212121"/>
                 </a:solidFill>
                 <a:latin typeface="Calibri"/>
               </a:rPr>
-              <a:t>•  Group-relative methods (GRPO) suffer signal starvation: when all rollouts in a group agree, the advantage is zero and no learning signal flows.</a:t>
+              <a:t>•  What's New in Sem 4: Splitting the massive foundational work into an 8-part modular research portfolio (P1-P8).</a:t>
             </a:r>
           </a:p>
           <a:p>
@@ -3666,23 +4386,7 @@
                 </a:solidFill>
                 <a:latin typeface="Calibri"/>
               </a:rPr>
-              <a:t>•  Capstone evidence: heterogeneous results across 7 libraries; zero-variance groups frequent on sparse binary rewards.</a:t>
-            </a:r>
-          </a:p>
-          <a:p>
-            <a:pPr algn="l">
-              <a:spcAft>
-                <a:spcPts val="800"/>
-              </a:spcAft>
-            </a:pPr>
-            <a:r>
-              <a:rPr sz="1600" b="0">
-                <a:solidFill>
-                  <a:srgbClr val="212121"/>
-                </a:solidFill>
-                <a:latin typeface="Calibri"/>
-              </a:rPr>
-              <a:t>•  Without controlled de-confounding, algorithm comparisons and "scaling" claims are unreliable.</a:t>
+              <a:t>•  Key Innovations: Formalizing the ZVF metric, developing an adaptive group-size controller, and analyzing length-bias ("verbosity trap").</a:t>
             </a:r>
           </a:p>
         </p:txBody>
@@ -3739,7 +4443,7 @@
                 </a:solidFill>
                 <a:latin typeface="Calibri"/>
               </a:rPr>
-              <a:t>Research Questions</a:t>
+              <a:t>Problem Statement &amp; Motivation</a:t>
             </a:r>
           </a:p>
         </p:txBody>
@@ -3841,7 +4545,7 @@
                 </a:solidFill>
                 <a:latin typeface="Calibri"/>
               </a:rPr>
-              <a:t>•  RQ1 — Same-stack control: does PPO vs GRPO differ when every other pipeline element is held fixed?</a:t>
+              <a:t>•  Published RL-for-LLM results are stack-conditioned: the same algorithm yields different outcomes across frameworks, backends, and defaults.</a:t>
             </a:r>
           </a:p>
           <a:p>
@@ -3857,39 +4561,39 @@
                 </a:solidFill>
                 <a:latin typeface="Calibri"/>
               </a:rPr>
-              <a:t>•  RQ2 — Can a Zero-Variance Fraction (ZVF) statistic serve as a practical signal-starvation diagnostic?</a:t>
-            </a:r>
-          </a:p>
-          <a:p>
-            <a:pPr algn="l">
-              <a:spcAft>
-                <a:spcPts val="800"/>
-              </a:spcAft>
-            </a:pPr>
-            <a:r>
-              <a:rPr sz="1600" b="1">
+              <a:t>•  Group-relative methods (GRPO) suffer signal starvation: when all rollouts in a group agree, the advantage is zero and no learning signal flows.</a:t>
+            </a:r>
+          </a:p>
+          <a:p>
+            <a:pPr algn="l">
+              <a:spcAft>
+                <a:spcPts val="800"/>
+              </a:spcAft>
+            </a:pPr>
+            <a:r>
+              <a:rPr sz="1600" b="0">
                 <a:solidFill>
                   <a:srgbClr val="212121"/>
                 </a:solidFill>
                 <a:latin typeface="Calibri"/>
               </a:rPr>
-              <a:t>•  RQ3 — How does group size G trade off contrast density, ZVF, and trainability?</a:t>
-            </a:r>
-          </a:p>
-          <a:p>
-            <a:pPr algn="l">
-              <a:spcAft>
-                <a:spcPts val="800"/>
-              </a:spcAft>
-            </a:pPr>
-            <a:r>
-              <a:rPr sz="1600" b="1">
+              <a:t>•  Capstone evidence: heterogeneous results across 7 libraries; zero-variance groups frequent on sparse binary rewards.</a:t>
+            </a:r>
+          </a:p>
+          <a:p>
+            <a:pPr algn="l">
+              <a:spcAft>
+                <a:spcPts val="800"/>
+              </a:spcAft>
+            </a:pPr>
+            <a:r>
+              <a:rPr sz="1600" b="0">
                 <a:solidFill>
                   <a:srgbClr val="212121"/>
                 </a:solidFill>
                 <a:latin typeface="Calibri"/>
               </a:rPr>
-              <a:t>•  RQ4 — Do training-reward gains survive held-out evaluation (length bias, generalization)?</a:t>
+              <a:t>•  Without controlled de-confounding, algorithm comparisons and "scaling" claims are unreliable.</a:t>
             </a:r>
           </a:p>
         </p:txBody>
@@ -3946,7 +4650,7 @@
                 </a:solidFill>
                 <a:latin typeface="Calibri"/>
               </a:rPr>
-              <a:t>Literature Anchors</a:t>
+              <a:t>Research Questions</a:t>
             </a:r>
           </a:p>
         </p:txBody>
@@ -4042,77 +4746,61 @@
               </a:spcAft>
             </a:pPr>
             <a:r>
-              <a:rPr sz="1600" b="0">
+              <a:rPr sz="1600" b="1">
                 <a:solidFill>
                   <a:srgbClr val="212121"/>
                 </a:solidFill>
                 <a:latin typeface="Calibri"/>
               </a:rPr>
-              <a:t>•  RLHF → PPO fine-tuning (Ouyang et al., 2022): value-based post-training baseline.</a:t>
-            </a:r>
-          </a:p>
-          <a:p>
-            <a:pPr algn="l">
-              <a:spcAft>
-                <a:spcPts val="800"/>
-              </a:spcAft>
-            </a:pPr>
-            <a:r>
-              <a:rPr sz="1600" b="0">
+              <a:t>•  RQ1 — Same-stack control: does PPO vs GRPO differ when every other pipeline element is held fixed?</a:t>
+            </a:r>
+          </a:p>
+          <a:p>
+            <a:pPr algn="l">
+              <a:spcAft>
+                <a:spcPts val="800"/>
+              </a:spcAft>
+            </a:pPr>
+            <a:r>
+              <a:rPr sz="1600" b="1">
                 <a:solidFill>
                   <a:srgbClr val="212121"/>
                 </a:solidFill>
                 <a:latin typeface="Calibri"/>
               </a:rPr>
-              <a:t>•  DPO (Rafailov et al., 2023): preference optimization without rollouts.</a:t>
-            </a:r>
-          </a:p>
-          <a:p>
-            <a:pPr algn="l">
-              <a:spcAft>
-                <a:spcPts val="800"/>
-              </a:spcAft>
-            </a:pPr>
-            <a:r>
-              <a:rPr sz="1600" b="0">
+              <a:t>•  RQ2 — Can a Zero-Variance Fraction (ZVF) statistic serve as a practical signal-starvation diagnostic?</a:t>
+            </a:r>
+          </a:p>
+          <a:p>
+            <a:pPr algn="l">
+              <a:spcAft>
+                <a:spcPts val="800"/>
+              </a:spcAft>
+            </a:pPr>
+            <a:r>
+              <a:rPr sz="1600" b="1">
                 <a:solidFill>
                   <a:srgbClr val="212121"/>
                 </a:solidFill>
                 <a:latin typeface="Calibri"/>
               </a:rPr>
-              <a:t>•  GRPO / DeepSeek-R1 (Shao et al., 2024; DeepSeek, 2025): group-relative advantages, verifiable rewards.</a:t>
-            </a:r>
-          </a:p>
-          <a:p>
-            <a:pPr algn="l">
-              <a:spcAft>
-                <a:spcPts val="800"/>
-              </a:spcAft>
-            </a:pPr>
-            <a:r>
-              <a:rPr sz="1600" b="0">
+              <a:t>•  RQ3 — How does group size G trade off contrast density, ZVF, and trainability?</a:t>
+            </a:r>
+          </a:p>
+          <a:p>
+            <a:pPr algn="l">
+              <a:spcAft>
+                <a:spcPts val="800"/>
+              </a:spcAft>
+            </a:pPr>
+            <a:r>
+              <a:rPr sz="1600" b="1">
                 <a:solidFill>
                   <a:srgbClr val="212121"/>
                 </a:solidFill>
                 <a:latin typeface="Calibri"/>
               </a:rPr>
-              <a:t>•  Dr.GRPO and length-bias corrections (Liu et al., 2025).</a:t>
-            </a:r>
-          </a:p>
-          <a:p>
-            <a:pPr algn="l">
-              <a:spcAft>
-                <a:spcPts val="800"/>
-              </a:spcAft>
-            </a:pPr>
-            <a:r>
-              <a:rPr sz="1600" b="1">
-                <a:solidFill>
-                  <a:srgbClr val="212121"/>
-                </a:solidFill>
-                <a:latin typeface="Calibri"/>
-              </a:rPr>
-              <a:t>•  Gap: no controlled cross-stack study isolating estimator choice from infrastructure.</a:t>
+              <a:t>•  RQ4 — Do training-reward gains survive held-out evaluation (length bias, generalization)?</a:t>
             </a:r>
           </a:p>
         </p:txBody>
@@ -4169,7 +4857,7 @@
                 </a:solidFill>
                 <a:latin typeface="Calibri"/>
               </a:rPr>
-              <a:t>Inherited Platform (Capstone Baseline)</a:t>
+              <a:t>Literature Anchors</a:t>
             </a:r>
           </a:p>
         </p:txBody>
@@ -4271,7 +4959,7 @@
                 </a:solidFill>
                 <a:latin typeface="Calibri"/>
               </a:rPr>
-              <a:t>•  tinker-rl-lab: one repo integrating Tinker API, SkyRL, verl, OpenRLHF, TRL, Atropos environments.</a:t>
+              <a:t>•  RLHF → PPO fine-tuning (Ouyang et al., 2022): value-based post-training baseline.</a:t>
             </a:r>
           </a:p>
           <a:p>
@@ -4287,7 +4975,7 @@
                 </a:solidFill>
                 <a:latin typeface="Calibri"/>
               </a:rPr>
-              <a:t>•  Baseline result to build on: GRPO on Qwen3-8B GSM8K — peak 62.5%, last-10 34.4% (training reward).</a:t>
+              <a:t>•  DPO (Rafailov et al., 2023): preference optimization without rollouts.</a:t>
             </a:r>
           </a:p>
           <a:p>
@@ -4303,7 +4991,23 @@
                 </a:solidFill>
                 <a:latin typeface="Calibri"/>
               </a:rPr>
-              <a:t>•  Existing scaffolding: evaluation pipeline, W&amp;B tracking, reproducibility audits.</a:t>
+              <a:t>•  GRPO / DeepSeek-R1 (Shao et al., 2024; DeepSeek, 2025): group-relative advantages, verifiable rewards.</a:t>
+            </a:r>
+          </a:p>
+          <a:p>
+            <a:pPr algn="l">
+              <a:spcAft>
+                <a:spcPts val="800"/>
+              </a:spcAft>
+            </a:pPr>
+            <a:r>
+              <a:rPr sz="1600" b="0">
+                <a:solidFill>
+                  <a:srgbClr val="212121"/>
+                </a:solidFill>
+                <a:latin typeface="Calibri"/>
+              </a:rPr>
+              <a:t>•  Dr.GRPO and length-bias corrections (Liu et al., 2025).</a:t>
             </a:r>
           </a:p>
           <a:p>
@@ -4319,7 +5023,7 @@
                 </a:solidFill>
                 <a:latin typeface="Calibri"/>
               </a:rPr>
-              <a:t>•  Solo phase reuses this infrastructure; new work is experiments, diagnostics, and analysis.</a:t>
+              <a:t>•  Gap: no controlled cross-stack study isolating estimator choice from infrastructure.</a:t>
             </a:r>
           </a:p>
         </p:txBody>
@@ -4376,7 +5080,7 @@
                 </a:solidFill>
                 <a:latin typeface="Calibri"/>
               </a:rPr>
-              <a:t>Proposed Methodology: Four De-Confound Pillars</a:t>
+              <a:t>Inherited Platform (Capstone Baseline)</a:t>
             </a:r>
           </a:p>
         </p:txBody>
@@ -4472,77 +5176,61 @@
               </a:spcAft>
             </a:pPr>
             <a:r>
+              <a:rPr sz="1600" b="0">
+                <a:solidFill>
+                  <a:srgbClr val="212121"/>
+                </a:solidFill>
+                <a:latin typeface="Calibri"/>
+              </a:rPr>
+              <a:t>•  tinker-rl-lab: one repo integrating Tinker API, SkyRL, verl, OpenRLHF, TRL, Atropos environments.</a:t>
+            </a:r>
+          </a:p>
+          <a:p>
+            <a:pPr algn="l">
+              <a:spcAft>
+                <a:spcPts val="800"/>
+              </a:spcAft>
+            </a:pPr>
+            <a:r>
+              <a:rPr sz="1600" b="0">
+                <a:solidFill>
+                  <a:srgbClr val="212121"/>
+                </a:solidFill>
+                <a:latin typeface="Calibri"/>
+              </a:rPr>
+              <a:t>•  Baseline result to build on: GRPO on Qwen3-8B GSM8K — peak 62.5%, last-10 34.4% (training reward).</a:t>
+            </a:r>
+          </a:p>
+          <a:p>
+            <a:pPr algn="l">
+              <a:spcAft>
+                <a:spcPts val="800"/>
+              </a:spcAft>
+            </a:pPr>
+            <a:r>
+              <a:rPr sz="1600" b="0">
+                <a:solidFill>
+                  <a:srgbClr val="212121"/>
+                </a:solidFill>
+                <a:latin typeface="Calibri"/>
+              </a:rPr>
+              <a:t>•  Existing scaffolding: evaluation pipeline, W&amp;B tracking, reproducibility audits.</a:t>
+            </a:r>
+          </a:p>
+          <a:p>
+            <a:pPr algn="l">
+              <a:spcAft>
+                <a:spcPts val="800"/>
+              </a:spcAft>
+            </a:pPr>
+            <a:r>
               <a:rPr sz="1600" b="1">
                 <a:solidFill>
                   <a:srgbClr val="212121"/>
                 </a:solidFill>
                 <a:latin typeface="Calibri"/>
               </a:rPr>
-              <a:t>•  Pillar 1 — Same-stack PPO vs GRPO: only the advantage estimator differs.</a:t>
-            </a:r>
-          </a:p>
-          <a:p>
-            <a:pPr algn="l">
-              <a:spcAft>
-                <a:spcPts val="800"/>
-              </a:spcAft>
-            </a:pPr>
-            <a:r>
-              <a:rPr sz="1600" b="1">
-                <a:solidFill>
-                  <a:srgbClr val="212121"/>
-                </a:solidFill>
-                <a:latin typeface="Calibri"/>
-              </a:rPr>
-              <a:t>•  Pillar 2 — Measure ZVF directly; theoretical form vs observed, across tasks.</a:t>
-            </a:r>
-          </a:p>
-          <a:p>
-            <a:pPr algn="l">
-              <a:spcAft>
-                <a:spcPts val="800"/>
-              </a:spcAft>
-            </a:pPr>
-            <a:r>
-              <a:rPr sz="1600" b="1">
-                <a:solidFill>
-                  <a:srgbClr val="212121"/>
-                </a:solidFill>
-                <a:latin typeface="Calibri"/>
-              </a:rPr>
-              <a:t>•  Pillar 3 — Group-size sweep G ∈ {2,4,8,16} × seeds with held-out checks.</a:t>
-            </a:r>
-          </a:p>
-          <a:p>
-            <a:pPr algn="l">
-              <a:spcAft>
-                <a:spcPts val="800"/>
-              </a:spcAft>
-            </a:pPr>
-            <a:r>
-              <a:rPr sz="1600" b="1">
-                <a:solidFill>
-                  <a:srgbClr val="212121"/>
-                </a:solidFill>
-                <a:latin typeface="Calibri"/>
-              </a:rPr>
-              <a:t>•  Pillar 4 — Held-out generalization: GRPO vs Dr.GRPO on GSM8K-CoT, pre/post McNemar.</a:t>
-            </a:r>
-          </a:p>
-          <a:p>
-            <a:pPr algn="l">
-              <a:spcAft>
-                <a:spcPts val="800"/>
-              </a:spcAft>
-            </a:pPr>
-            <a:r>
-              <a:rPr sz="1600" b="0">
-                <a:solidFill>
-                  <a:srgbClr val="212121"/>
-                </a:solidFill>
-                <a:latin typeface="Calibri"/>
-              </a:rPr>
-              <a:t>•  All runs seeded, logged, and audited; statistics with CIs, not single-seed claims.</a:t>
+              <a:t>•  Solo phase reuses this infrastructure; new work is experiments, diagnostics, and analysis.</a:t>
             </a:r>
           </a:p>
         </p:txBody>
@@ -4599,7 +5287,7 @@
                 </a:solidFill>
                 <a:latin typeface="Calibri"/>
               </a:rPr>
-              <a:t>Work Plan &amp; Deliverables (Semester 4)</a:t>
+              <a:t>Infrastructure &amp; Evidence Scale (audited 12 Jul)</a:t>
             </a:r>
           </a:p>
         </p:txBody>
@@ -4695,13 +5383,29 @@
               </a:spcAft>
             </a:pPr>
             <a:r>
+              <a:rPr sz="1600" b="1">
+                <a:solidFill>
+                  <a:srgbClr val="212121"/>
+                </a:solidFill>
+                <a:latin typeface="Calibri"/>
+              </a:rPr>
+              <a:t>•  983 training runs logged on the managed Tinker API to date — 26 base models spanning 0.6B → 1T parameters (Qwen3-8B is the workhorse).</a:t>
+            </a:r>
+          </a:p>
+          <a:p>
+            <a:pPr algn="l">
+              <a:spcAft>
+                <a:spcPts val="800"/>
+              </a:spcAft>
+            </a:pPr>
+            <a:r>
               <a:rPr sz="1600" b="0">
                 <a:solidFill>
                   <a:srgbClr val="212121"/>
                 </a:solidFill>
                 <a:latin typeface="Calibri"/>
               </a:rPr>
-              <a:t>•  Phase A (weeks 1–4): pillar experiments + ZVF telemetry implementation.</a:t>
+              <a:t>•  Multi-backend evaluation fabric already proven: Modal, Lightning AI, and Colab (vLLM) pass@k panels + 4 cross-library H100 training baselines (TRL/SB3/CleanRL/Tianshou).</a:t>
             </a:r>
           </a:p>
           <a:p>
@@ -4717,7 +5421,7 @@
                 </a:solidFill>
                 <a:latin typeface="Calibri"/>
               </a:rPr>
-              <a:t>•  Phase B (weeks 5–8): analysis papers P1–P4 (scaling, ZVF, group size, length bias).</a:t>
+              <a:t>•  Full telemetry trail: 1,034 W&amp;B runs across 17 projects; 49 HuggingFace artifact repos (published LoRA adapters).</a:t>
             </a:r>
           </a:p>
           <a:p>
@@ -4733,39 +5437,23 @@
                 </a:solidFill>
                 <a:latin typeface="Calibri"/>
               </a:rPr>
-              <a:t>•  Phase C (weeks 9–12): standards &amp; tooling papers P5–P7 (reporting standard, registry, adaptive controller).</a:t>
-            </a:r>
-          </a:p>
-          <a:p>
-            <a:pPr algn="l">
-              <a:spcAft>
-                <a:spcPts val="800"/>
-              </a:spcAft>
-            </a:pPr>
-            <a:r>
-              <a:rPr sz="1600" b="0">
+              <a:t>•  Run-level audit discipline: every claim-critical run is identified, checkpointed, and linked to its W&amp;B page and result artifact (audit workbook in outputs/).</a:t>
+            </a:r>
+          </a:p>
+          <a:p>
+            <a:pPr algn="l">
+              <a:spcAft>
+                <a:spcPts val="800"/>
+              </a:spcAft>
+            </a:pPr>
+            <a:r>
+              <a:rPr sz="1600" b="1">
                 <a:solidFill>
                   <a:srgbClr val="212121"/>
                 </a:solidFill>
                 <a:latin typeface="Calibri"/>
               </a:rPr>
-              <a:t>•  Phase D: applied case study P8 (LLM vs XGBoost on fraud) + workshop paper submission.</a:t>
-            </a:r>
-          </a:p>
-          <a:p>
-            <a:pPr algn="l">
-              <a:spcAft>
-                <a:spcPts val="800"/>
-              </a:spcAft>
-            </a:pPr>
-            <a:r>
-              <a:rPr sz="1600" b="1">
-                <a:solidFill>
-                  <a:srgbClr val="212121"/>
-                </a:solidFill>
-                <a:latin typeface="Calibri"/>
-              </a:rPr>
-              <a:t>•  Reviews: Session 1 (this) → Session 2 (mid results) → Session 3 (complete results + demo).</a:t>
+              <a:t>•  Why it matters for this plan: the de-confound pillars are feasible in one semester because the instrumentation and multi-backend plumbing already exist.</a:t>
             </a:r>
           </a:p>
         </p:txBody>
@@ -4822,7 +5510,7 @@
                 </a:solidFill>
                 <a:latin typeface="Calibri"/>
               </a:rPr>
-              <a:t>Expected Outcomes &amp; Evaluation Criteria</a:t>
+              <a:t>Proposed Methodology: Four De-Confound Pillars</a:t>
             </a:r>
           </a:p>
         </p:txBody>
@@ -4918,61 +5606,77 @@
               </a:spcAft>
             </a:pPr>
             <a:r>
+              <a:rPr sz="1600" b="1">
+                <a:solidFill>
+                  <a:srgbClr val="212121"/>
+                </a:solidFill>
+                <a:latin typeface="Calibri"/>
+              </a:rPr>
+              <a:t>•  Pillar 1 — Same-stack PPO vs GRPO: only the advantage estimator differs.</a:t>
+            </a:r>
+          </a:p>
+          <a:p>
+            <a:pPr algn="l">
+              <a:spcAft>
+                <a:spcPts val="800"/>
+              </a:spcAft>
+            </a:pPr>
+            <a:r>
+              <a:rPr sz="1600" b="1">
+                <a:solidFill>
+                  <a:srgbClr val="212121"/>
+                </a:solidFill>
+                <a:latin typeface="Calibri"/>
+              </a:rPr>
+              <a:t>•  Pillar 2 — Measure ZVF directly; theoretical form vs observed, across tasks.</a:t>
+            </a:r>
+          </a:p>
+          <a:p>
+            <a:pPr algn="l">
+              <a:spcAft>
+                <a:spcPts val="800"/>
+              </a:spcAft>
+            </a:pPr>
+            <a:r>
+              <a:rPr sz="1600" b="1">
+                <a:solidFill>
+                  <a:srgbClr val="212121"/>
+                </a:solidFill>
+                <a:latin typeface="Calibri"/>
+              </a:rPr>
+              <a:t>•  Pillar 3 — Group-size sweep G ∈ {2,4,8,16} × seeds with held-out checks.</a:t>
+            </a:r>
+          </a:p>
+          <a:p>
+            <a:pPr algn="l">
+              <a:spcAft>
+                <a:spcPts val="800"/>
+              </a:spcAft>
+            </a:pPr>
+            <a:r>
+              <a:rPr sz="1600" b="1">
+                <a:solidFill>
+                  <a:srgbClr val="212121"/>
+                </a:solidFill>
+                <a:latin typeface="Calibri"/>
+              </a:rPr>
+              <a:t>•  Pillar 4 — Held-out generalization: GRPO vs Dr.GRPO on GSM8K-CoT, pre/post McNemar.</a:t>
+            </a:r>
+          </a:p>
+          <a:p>
+            <a:pPr algn="l">
+              <a:spcAft>
+                <a:spcPts val="800"/>
+              </a:spcAft>
+            </a:pPr>
+            <a:r>
               <a:rPr sz="1600" b="0">
                 <a:solidFill>
                   <a:srgbClr val="212121"/>
                 </a:solidFill>
                 <a:latin typeface="Calibri"/>
               </a:rPr>
-              <a:t>•  A defensible answer to PPO-vs-GRPO under matched conditions (effect size + CI).</a:t>
-            </a:r>
-          </a:p>
-          <a:p>
-            <a:pPr algn="l">
-              <a:spcAft>
-                <a:spcPts val="800"/>
-              </a:spcAft>
-            </a:pPr>
-            <a:r>
-              <a:rPr sz="1600" b="0">
-                <a:solidFill>
-                  <a:srgbClr val="212121"/>
-                </a:solidFill>
-                <a:latin typeface="Calibri"/>
-              </a:rPr>
-              <a:t>•  ZVF validated (or refuted) as a cheap online diagnostic, with a group-size guidance rule.</a:t>
-            </a:r>
-          </a:p>
-          <a:p>
-            <a:pPr algn="l">
-              <a:spcAft>
-                <a:spcPts val="800"/>
-              </a:spcAft>
-            </a:pPr>
-            <a:r>
-              <a:rPr sz="1600" b="0">
-                <a:solidFill>
-                  <a:srgbClr val="212121"/>
-                </a:solidFill>
-                <a:latin typeface="Calibri"/>
-              </a:rPr>
-              <a:t>•  Eight short papers (P1–P8) + one workshop submission; reproducible artifact.</a:t>
-            </a:r>
-          </a:p>
-          <a:p>
-            <a:pPr algn="l">
-              <a:spcAft>
-                <a:spcPts val="800"/>
-              </a:spcAft>
-            </a:pPr>
-            <a:r>
-              <a:rPr sz="1600" b="1">
-                <a:solidFill>
-                  <a:srgbClr val="212121"/>
-                </a:solidFill>
-                <a:latin typeface="Calibri"/>
-              </a:rPr>
-              <a:t>•  Success = claims that survive held-out evaluation and independent audit, not peak training reward.</a:t>
+              <a:t>•  All runs seeded, logged, and audited; statistics with CIs, not single-seed claims.</a:t>
             </a:r>
           </a:p>
         </p:txBody>

</xml_diff>

<commit_message>
feat(deck): name zvf-triage library on the evidence-scale slide
Slide 8 now credits zvf-triage (zvf-program/zvf-triage, Apache-2.0):
the packaged drop-in ZVF triage callback with regime classification,
adaptive group size, dead-prompt dropping, auto-stop, and
veRL/OpenRLHF/NeMo-RL integrations.
</commit_message>
<xml_diff>
--- a/outputs/PESU_MTech_Phase1_Session1_Review_ArvindCR.pptx
+++ b/outputs/PESU_MTech_Phase1_Session1_Review_ArvindCR.pptx
@@ -5422,6 +5422,22 @@
                 <a:latin typeface="Calibri"/>
               </a:rPr>
               <a:t>•  Full telemetry trail: 1,034 W&amp;B runs across 17 projects; 49 HuggingFace artifact repos (published LoRA adapters).</a:t>
+            </a:r>
+          </a:p>
+          <a:p>
+            <a:pPr algn="l">
+              <a:spcAft>
+                <a:spcPts val="800"/>
+              </a:spcAft>
+            </a:pPr>
+            <a:r>
+              <a:rPr sz="1600" b="1">
+                <a:solidFill>
+                  <a:srgbClr val="212121"/>
+                </a:solidFill>
+                <a:latin typeface="Calibri"/>
+              </a:rPr>
+              <a:t>•  zvf-triage — packaged library built for this program (Apache-2.0): drop-in ZVF triage callback that classifies the starvation regime, adapts group size, drops dead prompts, and auto-stops doomed runs; integrations for veRL, OpenRLHF, and NeMo-RL with a full test suite.</a:t>
             </a:r>
           </a:p>
           <a:p>

</xml_diff>

<commit_message>
feat(deck): add 'Not Only GRPO' algorithms slide (now 16 slides)
New slide 5: table of every algorithm/method run across the programme
with stack and role — GRPO (base paper), Dr.GRPO (E-P4 panel), GSPO
(same-stack h2h), PPO (SB3/CleanRL/Tianshou on Modal H100 + bench arm
on Tinker, HF tinker-rl-bench-ppo_*), REINFORCE (Colab baselines),
DPO/IDPO (TRL unified script generator), SFT + off-policy distillation
(capstone tool-call LoRAs, Llama-3.2-1B probe), the audited 'DAPO'
label (ZVF 0.00 vs 0.55-0.58), and AERO/AREAL/GIFT + adaptive-G traces
(P2 panel, P8 detector, audit pilot). Slide 2 now names the comparison
family explicitly. Subsequent slides renumbered; timed notes updated.
</commit_message>
<xml_diff>
--- a/outputs/PESU_MTech_Phase1_Session1_Review_ArvindCR.pptx
+++ b/outputs/PESU_MTech_Phase1_Session1_Review_ArvindCR.pptx
@@ -20,6 +20,7 @@
     <p:sldId id="268" r:id="rId20"/>
     <p:sldId id="269" r:id="rId21"/>
     <p:sldId id="270" r:id="rId22"/>
+    <p:sldId id="271" r:id="rId23"/>
   </p:sldIdLst>
   <p:sldSz cx="12191695" cy="6858000" type="screen4x3"/>
   <p:notesSz cx="6858000" cy="9144000"/>
@@ -586,7 +587,7 @@
           <a:lstStyle/>
           <a:p>
             <a:r>
-              <a:t>(1.5 min) Three measured instances, each a lever that flipped a result: 17x reward span from an undisclosed backend swap that also bundled a checkpoint change; the same 'DAPO' label yielding ZVF 0.00 on an open trainer vs 0.55-0.58 on a closed stack; and reward micro-jitter below the verifier's resolution collapsing batch ZVF 0.158 to 0. Every item of the 8-item MIN-REPORT-RL standard exists because one of these levers moved a result in OUR OWN data — not from taste.</a:t>
+              <a:t>(2 min) Tests the base-paper critique directly. Six uncapped arms (1,024 tokens), 3 seeds per loss: completion lengths SHRINK 6-12% in all six arms — no verbosity trap at this scale — and no late-ZVF separation. Then own the incident proudly: the first panel was invalid because a documented --loss flag was never wired to the loss; no output-level trace revealed it — only reading the runner did. We invalidated loudly, preserved artifacts under .invalid names, reran same-day, and one conclusion REVERSED. That incident is now a case study and the seed of the reporting standard.</a:t>
             </a:r>
           </a:p>
         </p:txBody>
@@ -656,7 +657,7 @@
           <a:lstStyle/>
           <a:p>
             <a:r>
-              <a:t>(1.5 min) RQ4. Base Qwen3-8B on GSM8K: pass@1 30.4% but pass@32 91% — the base model already solves almost everything at k=32, so GSM8K alone cannot demonstrate capability expansion; that scope discipline is itself a finding. Post-RL adapters: zero forgetting on MBPP and a +1.5-2.5 point pass@32 frontier improvement, within noise at single-seed — exactly why the standard mandates pass@k curves with CIs. MATH-500 partial: GSM8K-trained gains do NOT replicate on hard math — distribution sharpening, not capability expansion.</a:t>
+              <a:t>(1.5 min) Three measured instances, each a lever that flipped a result: 17x reward span from an undisclosed backend swap that also bundled a checkpoint change; the same 'DAPO' label yielding ZVF 0.00 on an open trainer vs 0.55-0.58 on a closed stack; and reward micro-jitter below the verifier's resolution collapsing batch ZVF 0.158 to 0. Every item of the 8-item MIN-REPORT-RL standard exists because one of these levers moved a result in OUR OWN data — not from taste.</a:t>
             </a:r>
           </a:p>
         </p:txBody>
@@ -726,7 +727,7 @@
           <a:lstStyle/>
           <a:p>
             <a:r>
-              <a:t>(1 min) Fast slide. 983 runs on the Tinker account — audited and classified this morning; the thesis claims rest on 19 identified claim-critical runs, each linked to W&amp;B and its artifact. If asked about any number: the workbook key_runs sheet has the run id, checkpoint, W&amp;B link, and result JSON.</a:t>
+              <a:t>(1.5 min) RQ4. Base Qwen3-8B on GSM8K: pass@1 30.4% but pass@32 91% — the base model already solves almost everything at k=32, so GSM8K alone cannot demonstrate capability expansion; that scope discipline is itself a finding. Post-RL adapters: zero forgetting on MBPP and a +1.5-2.5 point pass@32 frontier improvement, within noise at single-seed — exactly why the standard mandates pass@k curves with CIs. MATH-500 partial: GSM8K-trained gains do NOT replicate on hard math — distribution sharpening, not capability expansion.</a:t>
             </a:r>
           </a:p>
         </p:txBody>
@@ -796,7 +797,7 @@
           <a:lstStyle/>
           <a:p>
             <a:r>
-              <a:t>(1.5 min + live demo) Run the one-command offline demo FIRST — it cannot fail on the network. ./submission/demo/demo.sh: mechanism fixture (4 groups, ZVF=0.5, GU=0.5), recorded artifact (80 rewards, mean 0.6875, ZVF 0.30), SHA-256 integrity check, HTML dashboard. Then if time and connectivity allow: the W&amp;B zvf-training panel with live E-R2b curves, and the audit workbook key_runs sheet. Fallback: the 86-second recorded walkthrough. Verified PASS this morning.</a:t>
+              <a:t>(1 min) Fast slide. 983 runs on the Tinker account — audited and classified this morning; the thesis claims rest on 19 identified claim-critical runs, each linked to W&amp;B and its artifact. If asked about any number: the workbook key_runs sheet has the run id, checkpoint, W&amp;B link, and result JSON.</a:t>
             </a:r>
           </a:p>
         </p:txBody>
@@ -866,7 +867,7 @@
           <a:lstStyle/>
           <a:p>
             <a:r>
-              <a:t>(1 min) Close with the honesty that survives cross-examination: one model, one task family, one managed API, 1-3 seeds — the claims are stated at the stack level and nowhere above it. Roadmap is gated: diagnostic paper publishable now; controller paper gated on a pre-registered compute-matched win; survival audit gated on an open stack. Then stop talking and invite questions.</a:t>
+              <a:t>(1.5 min + live demo) Run the one-command offline demo FIRST — it cannot fail on the network. ./submission/demo/demo.sh: mechanism fixture (4 groups, ZVF=0.5, GU=0.5), recorded artifact (80 rewards, mean 0.6875, ZVF 0.30), SHA-256 integrity check, HTML dashboard. Then if time and connectivity allow: the W&amp;B zvf-training panel with live E-R2b curves, and the audit workbook key_runs sheet. Fallback: the 86-second recorded walkthrough. Verified PASS this morning.</a:t>
             </a:r>
           </a:p>
         </p:txBody>
@@ -936,6 +937,76 @@
           <a:lstStyle/>
           <a:p>
             <a:r>
+              <a:t>(1 min) Close with the honesty that survives cross-examination: one model, one task family, one managed API, 1-3 seeds — the claims are stated at the stack level and nowhere above it. Roadmap is gated: diagnostic paper publishable now; controller paper gated on a pre-registered compute-matched win; survival audit gated on an open stack. Then stop talking and invite questions.</a:t>
+            </a:r>
+          </a:p>
+        </p:txBody>
+      </p:sp>
+      <p:sp>
+        <p:nvSpPr>
+          <p:cNvPr id="4" name="Slide Number Placeholder 3"/>
+          <p:cNvSpPr>
+            <a:spLocks noGrp="1"/>
+          </p:cNvSpPr>
+          <p:nvPr>
+            <p:ph type="sldNum" idx="5" sz="quarter"/>
+          </p:nvPr>
+        </p:nvSpPr>
+        <p:spPr/>
+      </p:sp>
+    </p:spTree>
+  </p:cSld>
+  <p:clrMapOvr>
+    <a:masterClrMapping/>
+  </p:clrMapOvr>
+</p:notes>
+</file>
+
+<file path=ppt/notesSlides/notesSlide16.xml><?xml version="1.0" encoding="utf-8"?>
+<p:notes xmlns:a="http://schemas.openxmlformats.org/drawingml/2006/main" xmlns:p="http://schemas.openxmlformats.org/presentationml/2006/main" xmlns:r="http://schemas.openxmlformats.org/officeDocument/2006/relationships">
+  <p:cSld>
+    <p:spTree>
+      <p:nvGrpSpPr>
+        <p:cNvPr id="1" name=""/>
+        <p:cNvGrpSpPr/>
+        <p:nvPr/>
+      </p:nvGrpSpPr>
+      <p:grpSpPr>
+        <a:xfrm>
+          <a:off x="0" y="0"/>
+          <a:ext cx="0" cy="0"/>
+          <a:chOff x="0" y="0"/>
+          <a:chExt cx="0" cy="0"/>
+        </a:xfrm>
+      </p:grpSpPr>
+      <p:sp>
+        <p:nvSpPr>
+          <p:cNvPr id="2" name="Slide Image Placeholder 1"/>
+          <p:cNvSpPr>
+            <a:spLocks noGrp="1"/>
+          </p:cNvSpPr>
+          <p:nvPr>
+            <p:ph type="sldImg" idx="2"/>
+          </p:nvPr>
+        </p:nvSpPr>
+        <p:spPr/>
+      </p:sp>
+      <p:sp>
+        <p:nvSpPr>
+          <p:cNvPr id="3" name="Notes Placeholder 2"/>
+          <p:cNvSpPr>
+            <a:spLocks noGrp="1"/>
+          </p:cNvSpPr>
+          <p:nvPr>
+            <p:ph type="body" idx="3" sz="quarter"/>
+          </p:nvPr>
+        </p:nvSpPr>
+        <p:spPr/>
+        <p:txBody>
+          <a:bodyPr/>
+          <a:lstStyle/>
+          <a:p>
+            <a:r>
               <a:t>Thank the panel. Repo and email on screen. Offer the audit workbook or any W&amp;B run on request.</a:t>
             </a:r>
           </a:p>
@@ -1216,7 +1287,7 @@
           <a:lstStyle/>
           <a:p>
             <a:r>
-              <a:t>(1.5 min) Attribution first: Sem 3 was the group capstone — the multi-framework bench and survey, frozen at tag capstone-final-2026-04-25. Everything on this slide is Sem-4 solo work. Be specific: these are files and packages he can open, not concepts.</a:t>
+              <a:t>(1 min) Fast table walk. GRPO is the base paper, not the boundary: PPO ran as the value-based control on three open libraries plus the bench; GSPO head-to-head against GRPO on the same stack; Dr.GRPO in the six-arm loss panel; DPO/IDPO through the unified script generator; REINFORCE and SFT/distillation as baselines; and the DAPO label audit plus the AERO/AREAL/GIFT traces feed the reproducibility results. Every row has runnable artifacts in the repo.</a:t>
             </a:r>
           </a:p>
         </p:txBody>
@@ -1286,7 +1357,7 @@
           <a:lstStyle/>
           <a:p>
             <a:r>
-              <a:t>(2 min) THE core result. Walk the table: late in training the G=2 arms read reward ~1.0 — by the reward axis, perfect. ZVF says 75-100% of groups are all-correct: zero gradient. Same budget, G=16 arms are mid-learning with ZVF under 0.25 and signal intact. Read as a pair, (reward, ZVF) separates 'policy is good' from 'training is still moving'. ZVF alone aliases mastery with incapacity — always read the pair.</a:t>
+              <a:t>(1.5 min) Attribution first: Sem 3 was the group capstone — the multi-framework bench and survey, frozen at tag capstone-final-2026-04-25. Everything on this slide is Sem-4 solo work. Be specific: these are files and packages he can open, not concepts.</a:t>
             </a:r>
           </a:p>
         </p:txBody>
@@ -1356,7 +1427,7 @@
           <a:lstStyle/>
           <a:p>
             <a:r>
-              <a:t>(2 min) The decisive experiment design point: hold the ROLLOUT BUDGET fixed, not the step count. Small G converts the budget into more optimiser steps early — then exhausts its own signal as accuracy rises (the p-&gt;1 wall of the kernel). Large G pays for contrast it doesn't need early and retains signal late. So group size controls WHICH END of training starves — a schedule question, not a constant. The naive static sweep is confounded by what the budget is held in — I show both views.</a:t>
+              <a:t>(2 min) THE core result. Walk the table: late in training the G=2 arms read reward ~1.0 — by the reward axis, perfect. ZVF says 75-100% of groups are all-correct: zero gradient. Same budget, G=16 arms are mid-learning with ZVF under 0.25 and signal intact. Read as a pair, (reward, ZVF) separates 'policy is good' from 'training is still moving'. ZVF alone aliases mastery with incapacity — always read the pair.</a:t>
             </a:r>
           </a:p>
         </p:txBody>
@@ -1426,7 +1497,7 @@
           <a:lstStyle/>
           <a:p>
             <a:r>
-              <a:t>(2 min) Three theory results, each validated on real 512-prompt pools. T1: Wilson interval covers 0.95-0.98 in every tested setting — report which ZVF the interval covers under curriculum ordering. T2: geometric waiting-time budget N = G ln(delta)/ln(ZVF) matched observed quantiles at ratio 1.00 in all six difficulty strata — hardest stratum needs 160 rollouts for a 90%-guaranteed informative group. T3 is the honest one: our signal-per-rollout objective turns out to have a UNIVERSAL argmax G* in {2,3} for every prior — an algebraic identity, found by external review of our own theory. We report it as a negative result.</a:t>
+              <a:t>(2 min) The decisive experiment design point: hold the ROLLOUT BUDGET fixed, not the step count. Small G converts the budget into more optimiser steps early — then exhausts its own signal as accuracy rises (the p-&gt;1 wall of the kernel). Large G pays for contrast it doesn't need early and retains signal late. So group size controls WHICH END of training starves — a schedule question, not a constant. The naive static sweep is confounded by what the budget is held in — I show both views.</a:t>
             </a:r>
           </a:p>
         </p:txBody>
@@ -1496,7 +1567,7 @@
           <a:lstStyle/>
           <a:p>
             <a:r>
-              <a:t>(2 min) Tests the base-paper critique directly. Six uncapped arms (1,024 tokens), 3 seeds per loss: completion lengths SHRINK 6-12% in all six arms — no verbosity trap at this scale — and no late-ZVF separation. Then own the incident proudly: the first panel was invalid because a documented --loss flag was never wired to the loss; no output-level trace revealed it — only reading the runner did. We invalidated loudly, preserved artifacts under .invalid names, reran same-day, and one conclusion REVERSED. That incident is now a case study and the seed of the reporting standard.</a:t>
+              <a:t>(2 min) Three theory results, each validated on real 512-prompt pools. T1: Wilson interval covers 0.95-0.98 in every tested setting — report which ZVF the interval covers under curriculum ordering. T2: geometric waiting-time budget N = G ln(delta)/ln(ZVF) matched observed quantiles at ratio 1.00 in all six difficulty strata — hardest stratum needs 160 rollouts for a 90%-guaranteed informative group. T3 is the honest one: our signal-per-rollout objective turns out to have a UNIVERSAL argmax G* in {2,3} for every prior — an algebraic identity, found by external review of our own theory. We report it as a negative result.</a:t>
             </a:r>
           </a:p>
         </p:txBody>
@@ -4657,7 +4728,7 @@
                 </a:solidFill>
                 <a:latin typeface="Calibri"/>
               </a:rPr>
-              <a:t>Result 5 — Reproducibility: Measured Flips, and the Standard They Justify</a:t>
+              <a:t>Result 4 — GRPO vs Dr.GRPO: No Footprint at This Scale (+ the Incident)</a:t>
             </a:r>
           </a:p>
         </p:txBody>
@@ -4735,7 +4806,7 @@
                 </a:solidFill>
                 <a:latin typeface="Calibri"/>
               </a:rPr>
-              <a:t>•  Backend swap (undisclosed, bundled a base-checkpoint change): final training reward moved across a 17× span — 85.6% vs 5.0% — under the same label.</a:t>
+              <a:t>•  Six-arm uncapped panel (Qwen3-8B, 1,024-token cap, 3 seeds/loss): GRPO lengths 1004→905, 981→944, 996→900; Dr.GRPO 999→931, 972→902, 1000→878 — lengths SHRINK 6–12% in every arm; no length inflation, no late-ZVF separation between losses.</a:t>
             </a:r>
           </a:p>
           <a:p>
@@ -4745,13 +4816,29 @@
               </a:spcAft>
             </a:pPr>
             <a:r>
+              <a:rPr sz="1500" b="0">
+                <a:solidFill>
+                  <a:srgbClr val="212121"/>
+                </a:solidFill>
+                <a:latin typeface="Calibri"/>
+              </a:rPr>
+              <a:t>•  Reading: at this scale the loss-form choice has no observable footprint on length or ZVF — evidence about reporting, not superiority. Comparisons between these losses measure stack noise unless controlled far more tightly than the labels suggest.</a:t>
+            </a:r>
+          </a:p>
+          <a:p>
+            <a:pPr algn="l">
+              <a:spcAft>
+                <a:spcPts val="700"/>
+              </a:spcAft>
+            </a:pPr>
+            <a:r>
               <a:rPr sz="1500" b="1">
                 <a:solidFill>
                   <a:srgbClr val="212121"/>
                 </a:solidFill>
                 <a:latin typeface="Calibri"/>
               </a:rPr>
-              <a:t>•  Same "DAPO" label: mean ZVF 0.00 on an open trainer with true dynamic sampling vs 0.55–0.58 on a closed stack running an asymmetric-clip surrogate.</a:t>
+              <a:t>•  The incident: the first panel ran with a documented --loss drgrpo flag that was never wired in — both "arms" silently trained identical GRPO. Caught only by reading the runner; artifacts preserved under .invalid_actually_grpo names; corrected rerun REVERSED one conclusion.</a:t>
             </a:r>
           </a:p>
           <a:p>
@@ -4767,23 +4854,7 @@
                 </a:solidFill>
                 <a:latin typeface="Calibri"/>
               </a:rPr>
-              <a:t>•  Reward-parser sensitivity: micro-jitter ε~U(0,1e-4) below verifier resolution collapses batch ZVF 0.158 → 0.000 — reported ZVF must name its verifier.</a:t>
-            </a:r>
-          </a:p>
-          <a:p>
-            <a:pPr algn="l">
-              <a:spcAft>
-                <a:spcPts val="700"/>
-              </a:spcAft>
-            </a:pPr>
-            <a:r>
-              <a:rPr sz="1500" b="1">
-                <a:solidFill>
-                  <a:srgbClr val="212121"/>
-                </a:solidFill>
-                <a:latin typeface="Calibri"/>
-              </a:rPr>
-              <a:t>•  Deliverables: MIN-REPORT-RL (8-item minimum reportable stack — every item justified by a measured flip), GRPO-Registry (machine-readable catalog, 20 seed entries), stackdiff (pairwise flip-risk verdicts R0–R5).</a:t>
+              <a:t>•  Response became protocol: invalidate loudly → preserve → rerun → record. This failure is a first-class result feeding the reproducibility standard (Result 5).</a:t>
             </a:r>
           </a:p>
         </p:txBody>
@@ -4840,7 +4911,7 @@
                 </a:solidFill>
                 <a:latin typeface="Calibri"/>
               </a:rPr>
-              <a:t>Result 6 — Held-Out Evaluation: Gains, Transfer, and an Honest Boundary</a:t>
+              <a:t>Result 5 — Reproducibility: Measured Flips, and the Standard They Justify</a:t>
             </a:r>
           </a:p>
         </p:txBody>
@@ -4918,7 +4989,7 @@
                 </a:solidFill>
                 <a:latin typeface="Calibri"/>
               </a:rPr>
-              <a:t>•  Baseline capability (200 problems, n=32, clustered bootstrap): pass@1 30.4% [27.5, 33.1] but pass@32 91.0% — GSM8K is nearly saturated at k=32; ~9 points of headroom bounds what training can claim here.</a:t>
+              <a:t>•  Backend swap (undisclosed, bundled a base-checkpoint change): final training reward moved across a 17× span — 85.6% vs 5.0% — under the same label.</a:t>
             </a:r>
           </a:p>
           <a:p>
@@ -4928,13 +4999,29 @@
               </a:spcAft>
             </a:pPr>
             <a:r>
+              <a:rPr sz="1500" b="1">
+                <a:solidFill>
+                  <a:srgbClr val="212121"/>
+                </a:solidFill>
+                <a:latin typeface="Calibri"/>
+              </a:rPr>
+              <a:t>•  Same "DAPO" label: mean ZVF 0.00 on an open trainer with true dynamic sampling vs 0.55–0.58 on a closed stack running an asymmetric-clip surrogate.</a:t>
+            </a:r>
+          </a:p>
+          <a:p>
+            <a:pPr algn="l">
+              <a:spcAft>
+                <a:spcPts val="700"/>
+              </a:spcAft>
+            </a:pPr>
+            <a:r>
               <a:rPr sz="1500" b="0">
                 <a:solidFill>
                   <a:srgbClr val="212121"/>
                 </a:solidFill>
                 <a:latin typeface="Calibri"/>
               </a:rPr>
-              <a:t>•  Transfer: post-RL adapters show zero forgetting and mild positive transfer on MBPP (pass@32 within noise of or above base for all G); pass@1-only reporting would misread the G=2 arm as a regression.</a:t>
+              <a:t>•  Reward-parser sensitivity: micro-jitter ε~U(0,1e-4) below verifier resolution collapses batch ZVF 0.158 → 0.000 — reported ZVF must name its verifier.</a:t>
             </a:r>
           </a:p>
           <a:p>
@@ -4950,23 +5037,7 @@
                 </a:solidFill>
                 <a:latin typeface="Calibri"/>
               </a:rPr>
-              <a:t>•  Hard-task boundary (MATH-500, partial): GSM8K-trained frontier gains do not carry — consistent with distribution sharpening rather than capability expansion. Stated as a non-claim in the thesis.</a:t>
-            </a:r>
-          </a:p>
-          <a:p>
-            <a:pPr algn="l">
-              <a:spcAft>
-                <a:spcPts val="700"/>
-              </a:spcAft>
-            </a:pPr>
-            <a:r>
-              <a:rPr sz="1500" b="0">
-                <a:solidFill>
-                  <a:srgbClr val="212121"/>
-                </a:solidFill>
-                <a:latin typeface="Calibri"/>
-              </a:rPr>
-              <a:t>•  Cross-scale observations (70+ curated runs, 7 libraries, 0.6B–671B): scale does not uniformly reduce ZVF; starvation is (difficulty × G × phase) geometry, not something scale buys you out of.</a:t>
+              <a:t>•  Deliverables: MIN-REPORT-RL (8-item minimum reportable stack — every item justified by a measured flip), GRPO-Registry (machine-readable catalog, 20 seed entries), stackdiff (pairwise flip-risk verdicts R0–R5).</a:t>
             </a:r>
           </a:p>
         </p:txBody>
@@ -5023,7 +5094,7 @@
                 </a:solidFill>
                 <a:latin typeface="Calibri"/>
               </a:rPr>
-              <a:t>Implementation Scale &amp; Evidence Trail (audited 12 Jul)</a:t>
+              <a:t>Result 6 — Held-Out Evaluation: Gains, Transfer, and an Honest Boundary</a:t>
             </a:r>
           </a:p>
         </p:txBody>
@@ -5101,7 +5172,7 @@
                 </a:solidFill>
                 <a:latin typeface="Calibri"/>
               </a:rPr>
-              <a:t>•  983 Tinker training runs enumerated via REST API — 26 base models, 0.6B → 1T; all 65 corrupted runs predate June 8; every thesis-supporting run is clean and checkpointed.</a:t>
+              <a:t>•  Baseline capability (200 problems, n=32, clustered bootstrap): pass@1 30.4% [27.5, 33.1] but pass@32 91.0% — GSM8K is nearly saturated at k=32; ~9 points of headroom bounds what training can claim here.</a:t>
             </a:r>
           </a:p>
           <a:p>
@@ -5117,7 +5188,7 @@
                 </a:solidFill>
                 <a:latin typeface="Calibri"/>
               </a:rPr>
-              <a:t>•  External backends: Modal / Lightning AI / Colab pass@k panels (26 runs) + 4 cross-library H100 baselines; 1,034 W&amp;B runs across 17 projects; 49 HuggingFace artifact repos.</a:t>
+              <a:t>•  Transfer: post-RL adapters show zero forgetting and mild positive transfer on MBPP (pass@32 within noise of or above base for all G); pass@1-only reporting would misread the G=2 arm as a regression.</a:t>
             </a:r>
           </a:p>
           <a:p>
@@ -5127,29 +5198,29 @@
               </a:spcAft>
             </a:pPr>
             <a:r>
+              <a:rPr sz="1500" b="1">
+                <a:solidFill>
+                  <a:srgbClr val="212121"/>
+                </a:solidFill>
+                <a:latin typeface="Calibri"/>
+              </a:rPr>
+              <a:t>•  Hard-task boundary (MATH-500, partial): GSM8K-trained frontier gains do not carry — consistent with distribution sharpening rather than capability expansion. Stated as a non-claim in the thesis.</a:t>
+            </a:r>
+          </a:p>
+          <a:p>
+            <a:pPr algn="l">
+              <a:spcAft>
+                <a:spcPts val="700"/>
+              </a:spcAft>
+            </a:pPr>
+            <a:r>
               <a:rPr sz="1500" b="0">
                 <a:solidFill>
                   <a:srgbClr val="212121"/>
                 </a:solidFill>
                 <a:latin typeface="Calibri"/>
               </a:rPr>
-              <a:t>•  zvf-triage: 82/82 tests green; wheel + sdist built, twine-checked; PyPI publication staged.</a:t>
-            </a:r>
-          </a:p>
-          <a:p>
-            <a:pPr algn="l">
-              <a:spcAft>
-                <a:spcPts val="700"/>
-              </a:spcAft>
-            </a:pPr>
-            <a:r>
-              <a:rPr sz="1500" b="1">
-                <a:solidFill>
-                  <a:srgbClr val="212121"/>
-                </a:solidFill>
-                <a:latin typeface="Calibri"/>
-              </a:rPr>
-              <a:t>•  Traceability: 19 claim-critical runs highlighted in the audit workbook, each with W&amp;B link + checkpoint + result artifact (outputs/tinker_runs_audit_2026-07-12.xlsx).</a:t>
+              <a:t>•  Cross-scale observations (70+ curated runs, 7 libraries, 0.6B–671B): scale does not uniformly reduce ZVF; starvation is (difficulty × G × phase) geometry, not something scale buys you out of.</a:t>
             </a:r>
           </a:p>
         </p:txBody>
@@ -5206,7 +5277,7 @@
                 </a:solidFill>
                 <a:latin typeface="Calibri"/>
               </a:rPr>
-              <a:t>Demo (Live)</a:t>
+              <a:t>Implementation Scale &amp; Evidence Trail (audited 12 Jul)</a:t>
             </a:r>
           </a:p>
         </p:txBody>
@@ -5284,7 +5355,7 @@
                 </a:solidFill>
                 <a:latin typeface="Calibri"/>
               </a:rPr>
-              <a:t>•  One command, fully offline: ./submission/demo/demo.sh — mechanism fixture (4 groups → ZVF=0.500, GU=0.500), recorded artifact check (80 rewards, mean 0.6875, ZVF 0.3000), SHA-256 integrity, JSON + HTML dashboard. Status: PASS (re-verified today).</a:t>
+              <a:t>•  983 Tinker training runs enumerated via REST API — 26 base models, 0.6B → 1T; all 65 corrupted runs predate June 8; every thesis-supporting run is clean and checkpointed.</a:t>
             </a:r>
           </a:p>
           <a:p>
@@ -5300,7 +5371,7 @@
                 </a:solidFill>
                 <a:latin typeface="Calibri"/>
               </a:rPr>
-              <a:t>•  Live artifact tour: W&amp;B zvf-training — the (reward, ZVF) pair diverging on the real E-R2b arms; audit workbook key_runs sheet — every claim-critical run traceable in two clicks.</a:t>
+              <a:t>•  External backends: Modal / Lightning AI / Colab pass@k panels (26 runs) + 4 cross-library H100 baselines; 1,034 W&amp;B runs across 17 projects; 49 HuggingFace artifact repos.</a:t>
             </a:r>
           </a:p>
           <a:p>
@@ -5316,7 +5387,7 @@
                 </a:solidFill>
                 <a:latin typeface="Calibri"/>
               </a:rPr>
-              <a:t>•  zvf-triage quickstart: pip-installable package, examples/quickstart.py — the diagnostic as a reusable library, not a one-off script.</a:t>
+              <a:t>•  zvf-triage: 82/82 tests green; wheel + sdist built, twine-checked; PyPI publication staged.</a:t>
             </a:r>
           </a:p>
           <a:p>
@@ -5326,13 +5397,13 @@
               </a:spcAft>
             </a:pPr>
             <a:r>
-              <a:rPr sz="1500" b="0">
+              <a:rPr sz="1500" b="1">
                 <a:solidFill>
                   <a:srgbClr val="212121"/>
                 </a:solidFill>
                 <a:latin typeface="Calibri"/>
               </a:rPr>
-              <a:t>•  Fallback if connectivity fails: 86-second recorded walkthrough (thesis/viva/demo_walkthrough.mp4).</a:t>
+              <a:t>•  Traceability: 19 claim-critical runs highlighted in the audit workbook, each with W&amp;B link + checkpoint + result artifact (outputs/tinker_runs_audit_2026-07-12.xlsx).</a:t>
             </a:r>
           </a:p>
         </p:txBody>
@@ -5389,7 +5460,7 @@
                 </a:solidFill>
                 <a:latin typeface="Calibri"/>
               </a:rPr>
-              <a:t>Scope, Limitations &amp; Roadmap</a:t>
+              <a:t>Demo (Live)</a:t>
             </a:r>
           </a:p>
         </p:txBody>
@@ -5467,7 +5538,7 @@
                 </a:solidFill>
                 <a:latin typeface="Calibri"/>
               </a:rPr>
-              <a:t>•  Declared scope: Qwen3-8B, GSM8K-family binary rewards, Tinker managed API (LoRA rank 4), 1–3 seeds per result — claims are stated at the stack level and nowhere above it.</a:t>
+              <a:t>•  One command, fully offline: ./submission/demo/demo.sh — mechanism fixture (4 groups → ZVF=0.500, GU=0.500), recorded artifact check (80 rewards, mean 0.6875, ZVF 0.3000), SHA-256 integrity, JSON + HTML dashboard. Status: PASS (re-verified today).</a:t>
             </a:r>
           </a:p>
           <a:p>
@@ -5483,7 +5554,7 @@
                 </a:solidFill>
                 <a:latin typeface="Calibri"/>
               </a:rPr>
-              <a:t>•  No causal or predictive power is claimed for ZVF beyond diagnosis; controller efficacy is explicitly gated on a pre-registered, compute-matched comparison (≥3 seeds, held-out metrics).</a:t>
+              <a:t>•  Live artifact tour: W&amp;B zvf-training — the (reward, ZVF) pair diverging on the real E-R2b arms; audit workbook key_runs sheet — every claim-critical run traceable in two clicks.</a:t>
             </a:r>
           </a:p>
           <a:p>
@@ -5499,7 +5570,7 @@
                 </a:solidFill>
                 <a:latin typeface="Calibri"/>
               </a:rPr>
-              <a:t>•  Roadmap (gated): bounded diagnostic paper (Claims 1–2) → controller paper (needs the win) → survival audit (needs an open stack). Thesis consolidates all 17 working documents.</a:t>
+              <a:t>•  zvf-triage quickstart: pip-installable package, examples/quickstart.py — the diagnostic as a reusable library, not a one-off script.</a:t>
             </a:r>
           </a:p>
           <a:p>
@@ -5509,13 +5580,13 @@
               </a:spcAft>
             </a:pPr>
             <a:r>
-              <a:rPr sz="1500" b="1">
+              <a:rPr sz="1500" b="0">
                 <a:solidFill>
                   <a:srgbClr val="212121"/>
                 </a:solidFill>
                 <a:latin typeface="Calibri"/>
               </a:rPr>
-              <a:t>•  The transferable lesson: at this scale the binding constraint is not compute or novelty — it is certainty about what actually ran.</a:t>
+              <a:t>•  Fallback if connectivity fails: 86-second recorded walkthrough (thesis/viva/demo_walkthrough.mp4).</a:t>
             </a:r>
           </a:p>
         </p:txBody>
@@ -5546,6 +5617,189 @@
         </p:nvSpPr>
         <p:spPr>
           <a:xfrm>
+            <a:off x="548640" y="274320"/>
+            <a:ext cx="11064240" cy="731520"/>
+          </a:xfrm>
+          <a:prstGeom prst="rect">
+            <a:avLst/>
+          </a:prstGeom>
+          <a:noFill/>
+        </p:spPr>
+        <p:txBody>
+          <a:bodyPr wrap="none">
+            <a:spAutoFit/>
+          </a:bodyPr>
+          <a:lstStyle/>
+          <a:p>
+            <a:pPr algn="l">
+              <a:spcAft>
+                <a:spcPts val="700"/>
+              </a:spcAft>
+            </a:pPr>
+            <a:r>
+              <a:rPr sz="2700" b="1">
+                <a:solidFill>
+                  <a:srgbClr val="1F4E79"/>
+                </a:solidFill>
+                <a:latin typeface="Calibri"/>
+              </a:rPr>
+              <a:t>Scope, Limitations &amp; Roadmap</a:t>
+            </a:r>
+          </a:p>
+        </p:txBody>
+      </p:sp>
+      <p:sp>
+        <p:nvSpPr>
+          <p:cNvPr id="3" name="TextBox 2"/>
+          <p:cNvSpPr txBox="1"/>
+          <p:nvPr/>
+        </p:nvSpPr>
+        <p:spPr>
+          <a:xfrm>
+            <a:off x="11430000" y="6446520"/>
+            <a:ext cx="548640" cy="320040"/>
+          </a:xfrm>
+          <a:prstGeom prst="rect">
+            <a:avLst/>
+          </a:prstGeom>
+          <a:noFill/>
+        </p:spPr>
+        <p:txBody>
+          <a:bodyPr wrap="none">
+            <a:spAutoFit/>
+          </a:bodyPr>
+          <a:lstStyle/>
+          <a:p>
+            <a:pPr algn="l">
+              <a:spcAft>
+                <a:spcPts val="700"/>
+              </a:spcAft>
+            </a:pPr>
+            <a:r>
+              <a:rPr sz="1100" b="0">
+                <a:solidFill>
+                  <a:srgbClr val="5A5A5A"/>
+                </a:solidFill>
+                <a:latin typeface="Calibri"/>
+              </a:rPr>
+              <a:t>15</a:t>
+            </a:r>
+          </a:p>
+        </p:txBody>
+      </p:sp>
+      <p:sp>
+        <p:nvSpPr>
+          <p:cNvPr id="4" name="TextBox 3"/>
+          <p:cNvSpPr txBox="1"/>
+          <p:nvPr/>
+        </p:nvSpPr>
+        <p:spPr>
+          <a:xfrm>
+            <a:off x="731520" y="1143000"/>
+            <a:ext cx="10789920" cy="5212080"/>
+          </a:xfrm>
+          <a:prstGeom prst="rect">
+            <a:avLst/>
+          </a:prstGeom>
+          <a:noFill/>
+        </p:spPr>
+        <p:txBody>
+          <a:bodyPr wrap="square">
+            <a:spAutoFit/>
+          </a:bodyPr>
+          <a:lstStyle/>
+          <a:p>
+            <a:pPr algn="l">
+              <a:spcAft>
+                <a:spcPts val="700"/>
+              </a:spcAft>
+            </a:pPr>
+            <a:r>
+              <a:rPr sz="1500" b="1">
+                <a:solidFill>
+                  <a:srgbClr val="212121"/>
+                </a:solidFill>
+                <a:latin typeface="Calibri"/>
+              </a:rPr>
+              <a:t>•  Declared scope: Qwen3-8B, GSM8K-family binary rewards, Tinker managed API (LoRA rank 4), 1–3 seeds per result — claims are stated at the stack level and nowhere above it.</a:t>
+            </a:r>
+          </a:p>
+          <a:p>
+            <a:pPr algn="l">
+              <a:spcAft>
+                <a:spcPts val="700"/>
+              </a:spcAft>
+            </a:pPr>
+            <a:r>
+              <a:rPr sz="1500" b="0">
+                <a:solidFill>
+                  <a:srgbClr val="212121"/>
+                </a:solidFill>
+                <a:latin typeface="Calibri"/>
+              </a:rPr>
+              <a:t>•  No causal or predictive power is claimed for ZVF beyond diagnosis; controller efficacy is explicitly gated on a pre-registered, compute-matched comparison (≥3 seeds, held-out metrics).</a:t>
+            </a:r>
+          </a:p>
+          <a:p>
+            <a:pPr algn="l">
+              <a:spcAft>
+                <a:spcPts val="700"/>
+              </a:spcAft>
+            </a:pPr>
+            <a:r>
+              <a:rPr sz="1500" b="0">
+                <a:solidFill>
+                  <a:srgbClr val="212121"/>
+                </a:solidFill>
+                <a:latin typeface="Calibri"/>
+              </a:rPr>
+              <a:t>•  Roadmap (gated): bounded diagnostic paper (Claims 1–2) → controller paper (needs the win) → survival audit (needs an open stack). Thesis consolidates all 17 working documents.</a:t>
+            </a:r>
+          </a:p>
+          <a:p>
+            <a:pPr algn="l">
+              <a:spcAft>
+                <a:spcPts val="700"/>
+              </a:spcAft>
+            </a:pPr>
+            <a:r>
+              <a:rPr sz="1500" b="1">
+                <a:solidFill>
+                  <a:srgbClr val="212121"/>
+                </a:solidFill>
+                <a:latin typeface="Calibri"/>
+              </a:rPr>
+              <a:t>•  The transferable lesson: at this scale the binding constraint is not compute or novelty — it is certainty about what actually ran.</a:t>
+            </a:r>
+          </a:p>
+        </p:txBody>
+      </p:sp>
+    </p:spTree>
+  </p:cSld>
+  <p:clrMapOvr>
+    <a:masterClrMapping/>
+  </p:clrMapOvr>
+</p:sld>
+</file>
+
+<file path=ppt/slides/slide16.xml><?xml version="1.0" encoding="utf-8"?>
+<p:sld xmlns:a="http://schemas.openxmlformats.org/drawingml/2006/main" xmlns:p="http://schemas.openxmlformats.org/presentationml/2006/main" xmlns:r="http://schemas.openxmlformats.org/officeDocument/2006/relationships">
+  <p:cSld>
+    <p:spTree>
+      <p:nvGrpSpPr>
+        <p:cNvPr id="1" name=""/>
+        <p:cNvGrpSpPr/>
+        <p:nvPr/>
+      </p:nvGrpSpPr>
+      <p:grpSpPr/>
+      <p:sp>
+        <p:nvSpPr>
+          <p:cNvPr id="2" name="TextBox 1"/>
+          <p:cNvSpPr txBox="1"/>
+          <p:nvPr/>
+        </p:nvSpPr>
+        <p:spPr>
+          <a:xfrm>
             <a:off x="914400" y="2468880"/>
             <a:ext cx="10332720" cy="1828800"/>
           </a:xfrm>
@@ -5739,7 +5993,7 @@
                 </a:solidFill>
                 <a:latin typeface="Calibri"/>
               </a:rPr>
-              <a:t>•  Why it matters: critic-free means cheap and stable at LLM scale with verifiable (binary) rewards; it is now the default RL post-training family (DAPO, GSPO, Dr.GRPO, GRESO...).</a:t>
+              <a:t>•  Why it matters: critic-free means cheap and stable at LLM scale with verifiable (binary) rewards; it is now the default RL post-training family. The study runs GRPO against PPO, REINFORCE, DPO, GSPO, Dr.GRPO and audited variant labels (slide 5).</a:t>
             </a:r>
           </a:p>
           <a:p>
@@ -6210,7 +6464,7 @@
                 </a:solidFill>
                 <a:latin typeface="Calibri"/>
               </a:rPr>
-              <a:t>What I Implemented (Sem-4 Solo, on the Sem-3 Foundation)</a:t>
+              <a:t>Not Only GRPO — Algorithms &amp; Methods Run</a:t>
             </a:r>
           </a:p>
         </p:txBody>
@@ -6254,125 +6508,593 @@
           </a:p>
         </p:txBody>
       </p:sp>
-      <p:sp>
-        <p:nvSpPr>
-          <p:cNvPr id="4" name="TextBox 3"/>
-          <p:cNvSpPr txBox="1"/>
+      <p:graphicFrame>
+        <p:nvGraphicFramePr>
+          <p:cNvPr id="4" name="Table 3"/>
+          <p:cNvGraphicFramePr>
+            <a:graphicFrameLocks noGrp="1"/>
+          </p:cNvGraphicFramePr>
           <p:nvPr/>
-        </p:nvSpPr>
-        <p:spPr>
-          <a:xfrm>
-            <a:off x="731520" y="1143000"/>
-            <a:ext cx="10789920" cy="5212080"/>
-          </a:xfrm>
-          <a:prstGeom prst="rect">
-            <a:avLst/>
-          </a:prstGeom>
-          <a:noFill/>
-        </p:spPr>
-        <p:txBody>
-          <a:bodyPr wrap="square">
-            <a:spAutoFit/>
-          </a:bodyPr>
-          <a:lstStyle/>
-          <a:p>
-            <a:pPr algn="l">
-              <a:spcAft>
-                <a:spcPts val="700"/>
-              </a:spcAft>
-            </a:pPr>
-            <a:r>
-              <a:rPr sz="1500" b="0">
-                <a:solidFill>
-                  <a:srgbClr val="212121"/>
-                </a:solidFill>
-                <a:latin typeface="Calibri"/>
-              </a:rPr>
-              <a:t>•  Inherited (Sem 3, Group 6): multi-framework benchmark scaffold (TinkerRL-Bench), literature survey, baseline GRPO runs. Frozen at tag capstone-final-2026-04-25.</a:t>
-            </a:r>
-          </a:p>
-          <a:p>
-            <a:pPr algn="l">
-              <a:spcAft>
-                <a:spcPts val="700"/>
-              </a:spcAft>
-            </a:pPr>
-            <a:r>
-              <a:rPr sz="1500" b="1">
-                <a:solidFill>
-                  <a:srgbClr val="212121"/>
-                </a:solidFill>
-                <a:latin typeface="Calibri"/>
-              </a:rPr>
-              <a:t>•  ZVF measurement stack: per-step ZVF/GU telemetry in the trainer, calibrated confidence intervals (Wilson), waiting-time reliability budget, stratified batch analysis.</a:t>
-            </a:r>
-          </a:p>
-          <a:p>
-            <a:pPr algn="l">
-              <a:spcAft>
-                <a:spcPts val="700"/>
-              </a:spcAft>
-            </a:pPr>
-            <a:r>
-              <a:rPr sz="1500" b="1">
-                <a:solidFill>
-                  <a:srgbClr val="212121"/>
-                </a:solidFill>
-                <a:latin typeface="Calibri"/>
-              </a:rPr>
-              <a:t>•  Experiment infrastructure: matched-budget runner with --resume (state + optimiser + RNG fast-forward), per-(step,prompt) seeding, W&amp;B resume; loss-form panel runner (GRPO vs Dr.GRPO).</a:t>
-            </a:r>
-          </a:p>
-          <a:p>
-            <a:pPr algn="l">
-              <a:spcAft>
-                <a:spcPts val="700"/>
-              </a:spcAft>
-            </a:pPr>
-            <a:r>
-              <a:rPr sz="1500" b="1">
-                <a:solidFill>
-                  <a:srgbClr val="212121"/>
-                </a:solidFill>
-                <a:latin typeface="Calibri"/>
-              </a:rPr>
-              <a:t>•  zvf-triage: packaged library (callback, controller, regime classifier, framework adapters, 82-test suite) — publication to PyPI staged.</a:t>
-            </a:r>
-          </a:p>
-          <a:p>
-            <a:pPr algn="l">
-              <a:spcAft>
-                <a:spcPts val="700"/>
-              </a:spcAft>
-            </a:pPr>
-            <a:r>
-              <a:rPr sz="1500" b="0">
-                <a:solidFill>
-                  <a:srgbClr val="212121"/>
-                </a:solidFill>
-                <a:latin typeface="Calibri"/>
-              </a:rPr>
-              <a:t>•  Standards &amp; tooling: MIN-REPORT-RL 8-item reporting standard, GRPO-Registry (machine-readable stack catalog), stackdiff flip-risk grader, run-audit workbook.</a:t>
-            </a:r>
-          </a:p>
-          <a:p>
-            <a:pPr algn="l">
-              <a:spcAft>
-                <a:spcPts val="700"/>
-              </a:spcAft>
-            </a:pPr>
-            <a:r>
-              <a:rPr sz="1500" b="0">
-                <a:solidFill>
-                  <a:srgbClr val="212121"/>
-                </a:solidFill>
-                <a:latin typeface="Calibri"/>
-              </a:rPr>
-              <a:t>•  Theory: T1 estimator calibration, T2 reliability budget, T3 optimal-G analysis — plus two corrections found by external adversarial review, adopted and reported openly.</a:t>
-            </a:r>
-          </a:p>
-        </p:txBody>
-      </p:sp>
+        </p:nvGraphicFramePr>
+        <p:xfrm>
+          <a:off x="822960" y="1188720"/>
+          <a:ext cx="10515600" cy="3291839"/>
+        </p:xfrm>
+        <a:graphic>
+          <a:graphicData uri="http://schemas.openxmlformats.org/drawingml/2006/table">
+            <a:tbl>
+              <a:tblPr firstRow="1" bandRow="1">
+                <a:tableStyleId>{5C22544A-7EE6-4342-B048-85BDC9FD1C3A}</a:tableStyleId>
+              </a:tblPr>
+              <a:tblGrid>
+                <a:gridCol w="2651760"/>
+                <a:gridCol w="4663440"/>
+                <a:gridCol w="3200400"/>
+              </a:tblGrid>
+              <a:tr h="329183">
+                <a:tc>
+                  <a:txBody>
+                    <a:bodyPr/>
+                    <a:lstStyle/>
+                    <a:p>
+                      <a:r>
+                        <a:rPr sz="1200" b="1">
+                          <a:solidFill>
+                            <a:srgbClr val="FFFFFF"/>
+                          </a:solidFill>
+                          <a:latin typeface="Calibri"/>
+                        </a:rPr>
+                        <a:t>algorithm / method</a:t>
+                      </a:r>
+                    </a:p>
+                  </a:txBody>
+                  <a:tcPr/>
+                </a:tc>
+                <a:tc>
+                  <a:txBody>
+                    <a:bodyPr/>
+                    <a:lstStyle/>
+                    <a:p>
+                      <a:r>
+                        <a:rPr sz="1200" b="1">
+                          <a:solidFill>
+                            <a:srgbClr val="FFFFFF"/>
+                          </a:solidFill>
+                          <a:latin typeface="Calibri"/>
+                        </a:rPr>
+                        <a:t>where it ran</a:t>
+                      </a:r>
+                    </a:p>
+                  </a:txBody>
+                  <a:tcPr/>
+                </a:tc>
+                <a:tc>
+                  <a:txBody>
+                    <a:bodyPr/>
+                    <a:lstStyle/>
+                    <a:p>
+                      <a:r>
+                        <a:rPr sz="1200" b="1">
+                          <a:solidFill>
+                            <a:srgbClr val="FFFFFF"/>
+                          </a:solidFill>
+                          <a:latin typeface="Calibri"/>
+                        </a:rPr>
+                        <a:t>role in the study</a:t>
+                      </a:r>
+                    </a:p>
+                  </a:txBody>
+                  <a:tcPr/>
+                </a:tc>
+              </a:tr>
+              <a:tr h="329183">
+                <a:tc>
+                  <a:txBody>
+                    <a:bodyPr/>
+                    <a:lstStyle/>
+                    <a:p>
+                      <a:r>
+                        <a:rPr sz="1200" b="0">
+                          <a:solidFill>
+                            <a:srgbClr val="212121"/>
+                          </a:solidFill>
+                          <a:latin typeface="Calibri"/>
+                        </a:rPr>
+                        <a:t>GRPO (base paper)</a:t>
+                      </a:r>
+                    </a:p>
+                  </a:txBody>
+                  <a:tcPr/>
+                </a:tc>
+                <a:tc>
+                  <a:txBody>
+                    <a:bodyPr/>
+                    <a:lstStyle/>
+                    <a:p>
+                      <a:r>
+                        <a:rPr sz="1200" b="0">
+                          <a:solidFill>
+                            <a:srgbClr val="212121"/>
+                          </a:solidFill>
+                          <a:latin typeface="Calibri"/>
+                        </a:rPr>
+                        <a:t>Tinker fleets (Qwen3-8B), TRL on Modal H100, open trainers</a:t>
+                      </a:r>
+                    </a:p>
+                  </a:txBody>
+                  <a:tcPr/>
+                </a:tc>
+                <a:tc>
+                  <a:txBody>
+                    <a:bodyPr/>
+                    <a:lstStyle/>
+                    <a:p>
+                      <a:r>
+                        <a:rPr sz="1200" b="0">
+                          <a:solidFill>
+                            <a:srgbClr val="212121"/>
+                          </a:solidFill>
+                          <a:latin typeface="Calibri"/>
+                        </a:rPr>
+                        <a:t>primary subject — all ZVF claims</a:t>
+                      </a:r>
+                    </a:p>
+                  </a:txBody>
+                  <a:tcPr/>
+                </a:tc>
+              </a:tr>
+              <a:tr h="329183">
+                <a:tc>
+                  <a:txBody>
+                    <a:bodyPr/>
+                    <a:lstStyle/>
+                    <a:p>
+                      <a:r>
+                        <a:rPr sz="1200" b="0">
+                          <a:solidFill>
+                            <a:srgbClr val="212121"/>
+                          </a:solidFill>
+                          <a:latin typeface="Calibri"/>
+                        </a:rPr>
+                        <a:t>Dr.GRPO</a:t>
+                      </a:r>
+                    </a:p>
+                  </a:txBody>
+                  <a:tcPr/>
+                </a:tc>
+                <a:tc>
+                  <a:txBody>
+                    <a:bodyPr/>
+                    <a:lstStyle/>
+                    <a:p>
+                      <a:r>
+                        <a:rPr sz="1200" b="0">
+                          <a:solidFill>
+                            <a:srgbClr val="212121"/>
+                          </a:solidFill>
+                          <a:latin typeface="Calibri"/>
+                        </a:rPr>
+                        <a:t>Tinker, six-arm uncapped panel, 3 seeds/loss</a:t>
+                      </a:r>
+                    </a:p>
+                  </a:txBody>
+                  <a:tcPr/>
+                </a:tc>
+                <a:tc>
+                  <a:txBody>
+                    <a:bodyPr/>
+                    <a:lstStyle/>
+                    <a:p>
+                      <a:r>
+                        <a:rPr sz="1200" b="0">
+                          <a:solidFill>
+                            <a:srgbClr val="212121"/>
+                          </a:solidFill>
+                          <a:latin typeface="Calibri"/>
+                        </a:rPr>
+                        <a:t>length-bias critique test (Result 4)</a:t>
+                      </a:r>
+                    </a:p>
+                  </a:txBody>
+                  <a:tcPr/>
+                </a:tc>
+              </a:tr>
+              <a:tr h="329183">
+                <a:tc>
+                  <a:txBody>
+                    <a:bodyPr/>
+                    <a:lstStyle/>
+                    <a:p>
+                      <a:r>
+                        <a:rPr sz="1200" b="0">
+                          <a:solidFill>
+                            <a:srgbClr val="212121"/>
+                          </a:solidFill>
+                          <a:latin typeface="Calibri"/>
+                        </a:rPr>
+                        <a:t>GSPO</a:t>
+                      </a:r>
+                    </a:p>
+                  </a:txBody>
+                  <a:tcPr/>
+                </a:tc>
+                <a:tc>
+                  <a:txBody>
+                    <a:bodyPr/>
+                    <a:lstStyle/>
+                    <a:p>
+                      <a:r>
+                        <a:rPr sz="1200" b="0">
+                          <a:solidFill>
+                            <a:srgbClr val="212121"/>
+                          </a:solidFill>
+                          <a:latin typeface="Calibri"/>
+                        </a:rPr>
+                        <a:t>Tinker, same-stack head-to-head vs GRPO (G=8)</a:t>
+                      </a:r>
+                    </a:p>
+                  </a:txBody>
+                  <a:tcPr/>
+                </a:tc>
+                <a:tc>
+                  <a:txBody>
+                    <a:bodyPr/>
+                    <a:lstStyle/>
+                    <a:p>
+                      <a:r>
+                        <a:rPr sz="1200" b="0">
+                          <a:solidFill>
+                            <a:srgbClr val="212121"/>
+                          </a:solidFill>
+                          <a:latin typeface="Calibri"/>
+                        </a:rPr>
+                        <a:t>sequence-level IS ratio control</a:t>
+                      </a:r>
+                    </a:p>
+                  </a:txBody>
+                  <a:tcPr/>
+                </a:tc>
+              </a:tr>
+              <a:tr h="329183">
+                <a:tc>
+                  <a:txBody>
+                    <a:bodyPr/>
+                    <a:lstStyle/>
+                    <a:p>
+                      <a:r>
+                        <a:rPr sz="1200" b="0">
+                          <a:solidFill>
+                            <a:srgbClr val="212121"/>
+                          </a:solidFill>
+                          <a:latin typeface="Calibri"/>
+                        </a:rPr>
+                        <a:t>PPO</a:t>
+                      </a:r>
+                    </a:p>
+                  </a:txBody>
+                  <a:tcPr/>
+                </a:tc>
+                <a:tc>
+                  <a:txBody>
+                    <a:bodyPr/>
+                    <a:lstStyle/>
+                    <a:p>
+                      <a:r>
+                        <a:rPr sz="1200" b="0">
+                          <a:solidFill>
+                            <a:srgbClr val="212121"/>
+                          </a:solidFill>
+                          <a:latin typeface="Calibri"/>
+                        </a:rPr>
+                        <a:t>SB3 / CleanRL / Tianshou (Modal H100) + bench arm (HF: tinker-rl-bench-ppo_*)</a:t>
+                      </a:r>
+                    </a:p>
+                  </a:txBody>
+                  <a:tcPr/>
+                </a:tc>
+                <a:tc>
+                  <a:txBody>
+                    <a:bodyPr/>
+                    <a:lstStyle/>
+                    <a:p>
+                      <a:r>
+                        <a:rPr sz="1200" b="0">
+                          <a:solidFill>
+                            <a:srgbClr val="212121"/>
+                          </a:solidFill>
+                          <a:latin typeface="Calibri"/>
+                        </a:rPr>
+                        <a:t>value-based baseline family (RQ1)</a:t>
+                      </a:r>
+                    </a:p>
+                  </a:txBody>
+                  <a:tcPr/>
+                </a:tc>
+              </a:tr>
+              <a:tr h="329183">
+                <a:tc>
+                  <a:txBody>
+                    <a:bodyPr/>
+                    <a:lstStyle/>
+                    <a:p>
+                      <a:r>
+                        <a:rPr sz="1200" b="0">
+                          <a:solidFill>
+                            <a:srgbClr val="212121"/>
+                          </a:solidFill>
+                          <a:latin typeface="Calibri"/>
+                        </a:rPr>
+                        <a:t>REINFORCE</a:t>
+                      </a:r>
+                    </a:p>
+                  </a:txBody>
+                  <a:tcPr/>
+                </a:tc>
+                <a:tc>
+                  <a:txBody>
+                    <a:bodyPr/>
+                    <a:lstStyle/>
+                    <a:p>
+                      <a:r>
+                        <a:rPr sz="1200" b="0">
+                          <a:solidFill>
+                            <a:srgbClr val="212121"/>
+                          </a:solidFill>
+                          <a:latin typeface="Calibri"/>
+                        </a:rPr>
+                        <a:t>Colab baselines notebook</a:t>
+                      </a:r>
+                    </a:p>
+                  </a:txBody>
+                  <a:tcPr/>
+                </a:tc>
+                <a:tc>
+                  <a:txBody>
+                    <a:bodyPr/>
+                    <a:lstStyle/>
+                    <a:p>
+                      <a:r>
+                        <a:rPr sz="1200" b="0">
+                          <a:solidFill>
+                            <a:srgbClr val="212121"/>
+                          </a:solidFill>
+                          <a:latin typeface="Calibri"/>
+                        </a:rPr>
+                        <a:t>simplest policy-gradient control</a:t>
+                      </a:r>
+                    </a:p>
+                  </a:txBody>
+                  <a:tcPr/>
+                </a:tc>
+              </a:tr>
+              <a:tr h="329183">
+                <a:tc>
+                  <a:txBody>
+                    <a:bodyPr/>
+                    <a:lstStyle/>
+                    <a:p>
+                      <a:r>
+                        <a:rPr sz="1200" b="0">
+                          <a:solidFill>
+                            <a:srgbClr val="212121"/>
+                          </a:solidFill>
+                          <a:latin typeface="Calibri"/>
+                        </a:rPr>
+                        <a:t>DPO / IDPO</a:t>
+                      </a:r>
+                    </a:p>
+                  </a:txBody>
+                  <a:tcPr/>
+                </a:tc>
+                <a:tc>
+                  <a:txBody>
+                    <a:bodyPr/>
+                    <a:lstStyle/>
+                    <a:p>
+                      <a:r>
+                        <a:rPr sz="1200" b="0">
+                          <a:solidFill>
+                            <a:srgbClr val="212121"/>
+                          </a:solidFill>
+                          <a:latin typeface="Calibri"/>
+                        </a:rPr>
+                        <a:t>TRL via unified script generator (platform_local)</a:t>
+                      </a:r>
+                    </a:p>
+                  </a:txBody>
+                  <a:tcPr/>
+                </a:tc>
+                <a:tc>
+                  <a:txBody>
+                    <a:bodyPr/>
+                    <a:lstStyle/>
+                    <a:p>
+                      <a:r>
+                        <a:rPr sz="1200" b="0">
+                          <a:solidFill>
+                            <a:srgbClr val="212121"/>
+                          </a:solidFill>
+                          <a:latin typeface="Calibri"/>
+                        </a:rPr>
+                        <a:t>preference optimisation, no rollouts</a:t>
+                      </a:r>
+                    </a:p>
+                  </a:txBody>
+                  <a:tcPr/>
+                </a:tc>
+              </a:tr>
+              <a:tr h="329183">
+                <a:tc>
+                  <a:txBody>
+                    <a:bodyPr/>
+                    <a:lstStyle/>
+                    <a:p>
+                      <a:r>
+                        <a:rPr sz="1200" b="0">
+                          <a:solidFill>
+                            <a:srgbClr val="212121"/>
+                          </a:solidFill>
+                          <a:latin typeface="Calibri"/>
+                        </a:rPr>
+                        <a:t>SFT + off-policy distillation</a:t>
+                      </a:r>
+                    </a:p>
+                  </a:txBody>
+                  <a:tcPr/>
+                </a:tc>
+                <a:tc>
+                  <a:txBody>
+                    <a:bodyPr/>
+                    <a:lstStyle/>
+                    <a:p>
+                      <a:r>
+                        <a:rPr sz="1200" b="0">
+                          <a:solidFill>
+                            <a:srgbClr val="212121"/>
+                          </a:solidFill>
+                          <a:latin typeface="Calibri"/>
+                        </a:rPr>
+                        <a:t>capstone tool-call LoRAs; Llama-3.2-1B distillation probe</a:t>
+                      </a:r>
+                    </a:p>
+                  </a:txBody>
+                  <a:tcPr/>
+                </a:tc>
+                <a:tc>
+                  <a:txBody>
+                    <a:bodyPr/>
+                    <a:lstStyle/>
+                    <a:p>
+                      <a:r>
+                        <a:rPr sz="1200" b="0">
+                          <a:solidFill>
+                            <a:srgbClr val="212121"/>
+                          </a:solidFill>
+                          <a:latin typeface="Calibri"/>
+                        </a:rPr>
+                        <a:t>non-RL baselines and adapters</a:t>
+                      </a:r>
+                    </a:p>
+                  </a:txBody>
+                  <a:tcPr/>
+                </a:tc>
+              </a:tr>
+              <a:tr h="329183">
+                <a:tc>
+                  <a:txBody>
+                    <a:bodyPr/>
+                    <a:lstStyle/>
+                    <a:p>
+                      <a:r>
+                        <a:rPr sz="1200" b="0">
+                          <a:solidFill>
+                            <a:srgbClr val="212121"/>
+                          </a:solidFill>
+                          <a:latin typeface="Calibri"/>
+                        </a:rPr>
+                        <a:t>"DAPO" (label audit)</a:t>
+                      </a:r>
+                    </a:p>
+                  </a:txBody>
+                  <a:tcPr/>
+                </a:tc>
+                <a:tc>
+                  <a:txBody>
+                    <a:bodyPr/>
+                    <a:lstStyle/>
+                    <a:p>
+                      <a:r>
+                        <a:rPr sz="1200" b="0">
+                          <a:solidFill>
+                            <a:srgbClr val="212121"/>
+                          </a:solidFill>
+                          <a:latin typeface="Calibri"/>
+                        </a:rPr>
+                        <a:t>open trainer w/ dynamic sampling vs closed-stack surrogate</a:t>
+                      </a:r>
+                    </a:p>
+                  </a:txBody>
+                  <a:tcPr/>
+                </a:tc>
+                <a:tc>
+                  <a:txBody>
+                    <a:bodyPr/>
+                    <a:lstStyle/>
+                    <a:p>
+                      <a:r>
+                        <a:rPr sz="1200" b="0">
+                          <a:solidFill>
+                            <a:srgbClr val="212121"/>
+                          </a:solidFill>
+                          <a:latin typeface="Calibri"/>
+                        </a:rPr>
+                        <a:t>label-flip evidence: ZVF 0.00 vs 0.55-0.58</a:t>
+                      </a:r>
+                    </a:p>
+                  </a:txBody>
+                  <a:tcPr/>
+                </a:tc>
+              </a:tr>
+              <a:tr h="329192">
+                <a:tc>
+                  <a:txBody>
+                    <a:bodyPr/>
+                    <a:lstStyle/>
+                    <a:p>
+                      <a:r>
+                        <a:rPr sz="1200" b="0">
+                          <a:solidFill>
+                            <a:srgbClr val="212121"/>
+                          </a:solidFill>
+                          <a:latin typeface="Calibri"/>
+                        </a:rPr>
+                        <a:t>AERO / AREAL / GIFT + adaptive-G</a:t>
+                      </a:r>
+                    </a:p>
+                  </a:txBody>
+                  <a:tcPr/>
+                </a:tc>
+                <a:tc>
+                  <a:txBody>
+                    <a:bodyPr/>
+                    <a:lstStyle/>
+                    <a:p>
+                      <a:r>
+                        <a:rPr sz="1200" b="0">
+                          <a:solidFill>
+                            <a:srgbClr val="212121"/>
+                          </a:solidFill>
+                          <a:latin typeface="Calibri"/>
+                        </a:rPr>
+                        <a:t>open-stack method traces; 4-arm audit pilot (T4)</a:t>
+                      </a:r>
+                    </a:p>
+                  </a:txBody>
+                  <a:tcPr/>
+                </a:tc>
+                <a:tc>
+                  <a:txBody>
+                    <a:bodyPr/>
+                    <a:lstStyle/>
+                    <a:p>
+                      <a:r>
+                        <a:rPr sz="1200" b="0">
+                          <a:solidFill>
+                            <a:srgbClr val="212121"/>
+                          </a:solidFill>
+                          <a:latin typeface="Calibri"/>
+                        </a:rPr>
+                        <a:t>P2 collapse panel, P8 detector, survival-audit pilot</a:t>
+                      </a:r>
+                    </a:p>
+                  </a:txBody>
+                  <a:tcPr/>
+                </a:tc>
+              </a:tr>
+            </a:tbl>
+          </a:graphicData>
+        </a:graphic>
+      </p:graphicFrame>
     </p:spTree>
   </p:cSld>
   <p:clrMapOvr>
@@ -6425,7 +7147,7 @@
                 </a:solidFill>
                 <a:latin typeface="Calibri"/>
               </a:rPr>
-              <a:t>Result 1 — ZVF Sees What the Reward Curve Cannot (Claim 1)</a:t>
+              <a:t>What I Implemented (Sem-4 Solo, on the Sem-3 Foundation)</a:t>
             </a:r>
           </a:p>
         </p:txBody>
@@ -6465,6 +7187,221 @@
                 <a:latin typeface="Calibri"/>
               </a:rPr>
               <a:t>6</a:t>
+            </a:r>
+          </a:p>
+        </p:txBody>
+      </p:sp>
+      <p:sp>
+        <p:nvSpPr>
+          <p:cNvPr id="4" name="TextBox 3"/>
+          <p:cNvSpPr txBox="1"/>
+          <p:nvPr/>
+        </p:nvSpPr>
+        <p:spPr>
+          <a:xfrm>
+            <a:off x="731520" y="1143000"/>
+            <a:ext cx="10789920" cy="5212080"/>
+          </a:xfrm>
+          <a:prstGeom prst="rect">
+            <a:avLst/>
+          </a:prstGeom>
+          <a:noFill/>
+        </p:spPr>
+        <p:txBody>
+          <a:bodyPr wrap="square">
+            <a:spAutoFit/>
+          </a:bodyPr>
+          <a:lstStyle/>
+          <a:p>
+            <a:pPr algn="l">
+              <a:spcAft>
+                <a:spcPts val="700"/>
+              </a:spcAft>
+            </a:pPr>
+            <a:r>
+              <a:rPr sz="1500" b="0">
+                <a:solidFill>
+                  <a:srgbClr val="212121"/>
+                </a:solidFill>
+                <a:latin typeface="Calibri"/>
+              </a:rPr>
+              <a:t>•  Inherited (Sem 3, Group 6): multi-framework benchmark scaffold (TinkerRL-Bench), literature survey, baseline GRPO runs. Frozen at tag capstone-final-2026-04-25.</a:t>
+            </a:r>
+          </a:p>
+          <a:p>
+            <a:pPr algn="l">
+              <a:spcAft>
+                <a:spcPts val="700"/>
+              </a:spcAft>
+            </a:pPr>
+            <a:r>
+              <a:rPr sz="1500" b="1">
+                <a:solidFill>
+                  <a:srgbClr val="212121"/>
+                </a:solidFill>
+                <a:latin typeface="Calibri"/>
+              </a:rPr>
+              <a:t>•  ZVF measurement stack: per-step ZVF/GU telemetry in the trainer, calibrated confidence intervals (Wilson), waiting-time reliability budget, stratified batch analysis.</a:t>
+            </a:r>
+          </a:p>
+          <a:p>
+            <a:pPr algn="l">
+              <a:spcAft>
+                <a:spcPts val="700"/>
+              </a:spcAft>
+            </a:pPr>
+            <a:r>
+              <a:rPr sz="1500" b="1">
+                <a:solidFill>
+                  <a:srgbClr val="212121"/>
+                </a:solidFill>
+                <a:latin typeface="Calibri"/>
+              </a:rPr>
+              <a:t>•  Experiment infrastructure: matched-budget runner with --resume (state + optimiser + RNG fast-forward), per-(step,prompt) seeding, W&amp;B resume; loss-form panel runner (GRPO vs Dr.GRPO).</a:t>
+            </a:r>
+          </a:p>
+          <a:p>
+            <a:pPr algn="l">
+              <a:spcAft>
+                <a:spcPts val="700"/>
+              </a:spcAft>
+            </a:pPr>
+            <a:r>
+              <a:rPr sz="1500" b="1">
+                <a:solidFill>
+                  <a:srgbClr val="212121"/>
+                </a:solidFill>
+                <a:latin typeface="Calibri"/>
+              </a:rPr>
+              <a:t>•  zvf-triage: packaged library (callback, controller, regime classifier, framework adapters, 82-test suite) — publication to PyPI staged.</a:t>
+            </a:r>
+          </a:p>
+          <a:p>
+            <a:pPr algn="l">
+              <a:spcAft>
+                <a:spcPts val="700"/>
+              </a:spcAft>
+            </a:pPr>
+            <a:r>
+              <a:rPr sz="1500" b="0">
+                <a:solidFill>
+                  <a:srgbClr val="212121"/>
+                </a:solidFill>
+                <a:latin typeface="Calibri"/>
+              </a:rPr>
+              <a:t>•  Standards &amp; tooling: MIN-REPORT-RL 8-item reporting standard, GRPO-Registry (machine-readable stack catalog), stackdiff flip-risk grader, run-audit workbook.</a:t>
+            </a:r>
+          </a:p>
+          <a:p>
+            <a:pPr algn="l">
+              <a:spcAft>
+                <a:spcPts val="700"/>
+              </a:spcAft>
+            </a:pPr>
+            <a:r>
+              <a:rPr sz="1500" b="0">
+                <a:solidFill>
+                  <a:srgbClr val="212121"/>
+                </a:solidFill>
+                <a:latin typeface="Calibri"/>
+              </a:rPr>
+              <a:t>•  Theory: T1 estimator calibration, T2 reliability budget, T3 optimal-G analysis — plus two corrections found by external adversarial review, adopted and reported openly.</a:t>
+            </a:r>
+          </a:p>
+        </p:txBody>
+      </p:sp>
+    </p:spTree>
+  </p:cSld>
+  <p:clrMapOvr>
+    <a:masterClrMapping/>
+  </p:clrMapOvr>
+</p:sld>
+</file>
+
+<file path=ppt/slides/slide7.xml><?xml version="1.0" encoding="utf-8"?>
+<p:sld xmlns:a="http://schemas.openxmlformats.org/drawingml/2006/main" xmlns:p="http://schemas.openxmlformats.org/presentationml/2006/main" xmlns:r="http://schemas.openxmlformats.org/officeDocument/2006/relationships">
+  <p:cSld>
+    <p:spTree>
+      <p:nvGrpSpPr>
+        <p:cNvPr id="1" name=""/>
+        <p:cNvGrpSpPr/>
+        <p:nvPr/>
+      </p:nvGrpSpPr>
+      <p:grpSpPr/>
+      <p:sp>
+        <p:nvSpPr>
+          <p:cNvPr id="2" name="TextBox 1"/>
+          <p:cNvSpPr txBox="1"/>
+          <p:nvPr/>
+        </p:nvSpPr>
+        <p:spPr>
+          <a:xfrm>
+            <a:off x="548640" y="274320"/>
+            <a:ext cx="11064240" cy="731520"/>
+          </a:xfrm>
+          <a:prstGeom prst="rect">
+            <a:avLst/>
+          </a:prstGeom>
+          <a:noFill/>
+        </p:spPr>
+        <p:txBody>
+          <a:bodyPr wrap="none">
+            <a:spAutoFit/>
+          </a:bodyPr>
+          <a:lstStyle/>
+          <a:p>
+            <a:pPr algn="l">
+              <a:spcAft>
+                <a:spcPts val="700"/>
+              </a:spcAft>
+            </a:pPr>
+            <a:r>
+              <a:rPr sz="2700" b="1">
+                <a:solidFill>
+                  <a:srgbClr val="1F4E79"/>
+                </a:solidFill>
+                <a:latin typeface="Calibri"/>
+              </a:rPr>
+              <a:t>Result 1 — ZVF Sees What the Reward Curve Cannot (Claim 1)</a:t>
+            </a:r>
+          </a:p>
+        </p:txBody>
+      </p:sp>
+      <p:sp>
+        <p:nvSpPr>
+          <p:cNvPr id="3" name="TextBox 2"/>
+          <p:cNvSpPr txBox="1"/>
+          <p:nvPr/>
+        </p:nvSpPr>
+        <p:spPr>
+          <a:xfrm>
+            <a:off x="11430000" y="6446520"/>
+            <a:ext cx="548640" cy="320040"/>
+          </a:xfrm>
+          <a:prstGeom prst="rect">
+            <a:avLst/>
+          </a:prstGeom>
+          <a:noFill/>
+        </p:spPr>
+        <p:txBody>
+          <a:bodyPr wrap="none">
+            <a:spAutoFit/>
+          </a:bodyPr>
+          <a:lstStyle/>
+          <a:p>
+            <a:pPr algn="l">
+              <a:spcAft>
+                <a:spcPts val="700"/>
+              </a:spcAft>
+            </a:pPr>
+            <a:r>
+              <a:rPr sz="1100" b="0">
+                <a:solidFill>
+                  <a:srgbClr val="5A5A5A"/>
+                </a:solidFill>
+                <a:latin typeface="Calibri"/>
+              </a:rPr>
+              <a:t>7</a:t>
             </a:r>
           </a:p>
         </p:txBody>
@@ -6788,7 +7725,7 @@
 </p:sld>
 </file>
 
-<file path=ppt/slides/slide7.xml><?xml version="1.0" encoding="utf-8"?>
+<file path=ppt/slides/slide8.xml><?xml version="1.0" encoding="utf-8"?>
 <p:sld xmlns:a="http://schemas.openxmlformats.org/drawingml/2006/main" xmlns:p="http://schemas.openxmlformats.org/presentationml/2006/main" xmlns:r="http://schemas.openxmlformats.org/officeDocument/2006/relationships">
   <p:cSld>
     <p:spTree>
@@ -6871,7 +7808,7 @@
                 </a:solidFill>
                 <a:latin typeface="Calibri"/>
               </a:rPr>
-              <a:t>7</a:t>
+              <a:t>8</a:t>
             </a:r>
           </a:p>
         </p:txBody>
@@ -6959,189 +7896,6 @@
                 <a:latin typeface="Calibri"/>
               </a:rPr>
               <a:t>•  Honesty check: static fixed-step sweeps are non-monotone and confounded by what the budget is held in; the controller that would exploit this is designed but its efficacy is NOT claimed (pre-registered test is future work).</a:t>
-            </a:r>
-          </a:p>
-        </p:txBody>
-      </p:sp>
-    </p:spTree>
-  </p:cSld>
-  <p:clrMapOvr>
-    <a:masterClrMapping/>
-  </p:clrMapOvr>
-</p:sld>
-</file>
-
-<file path=ppt/slides/slide8.xml><?xml version="1.0" encoding="utf-8"?>
-<p:sld xmlns:a="http://schemas.openxmlformats.org/drawingml/2006/main" xmlns:p="http://schemas.openxmlformats.org/presentationml/2006/main" xmlns:r="http://schemas.openxmlformats.org/officeDocument/2006/relationships">
-  <p:cSld>
-    <p:spTree>
-      <p:nvGrpSpPr>
-        <p:cNvPr id="1" name=""/>
-        <p:cNvGrpSpPr/>
-        <p:nvPr/>
-      </p:nvGrpSpPr>
-      <p:grpSpPr/>
-      <p:sp>
-        <p:nvSpPr>
-          <p:cNvPr id="2" name="TextBox 1"/>
-          <p:cNvSpPr txBox="1"/>
-          <p:nvPr/>
-        </p:nvSpPr>
-        <p:spPr>
-          <a:xfrm>
-            <a:off x="548640" y="274320"/>
-            <a:ext cx="11064240" cy="731520"/>
-          </a:xfrm>
-          <a:prstGeom prst="rect">
-            <a:avLst/>
-          </a:prstGeom>
-          <a:noFill/>
-        </p:spPr>
-        <p:txBody>
-          <a:bodyPr wrap="none">
-            <a:spAutoFit/>
-          </a:bodyPr>
-          <a:lstStyle/>
-          <a:p>
-            <a:pPr algn="l">
-              <a:spcAft>
-                <a:spcPts val="700"/>
-              </a:spcAft>
-            </a:pPr>
-            <a:r>
-              <a:rPr sz="2700" b="1">
-                <a:solidFill>
-                  <a:srgbClr val="1F4E79"/>
-                </a:solidFill>
-                <a:latin typeface="Calibri"/>
-              </a:rPr>
-              <a:t>Result 3 — The Estimator Is Calibrated, the Budget Is Exact</a:t>
-            </a:r>
-          </a:p>
-        </p:txBody>
-      </p:sp>
-      <p:sp>
-        <p:nvSpPr>
-          <p:cNvPr id="3" name="TextBox 2"/>
-          <p:cNvSpPr txBox="1"/>
-          <p:nvPr/>
-        </p:nvSpPr>
-        <p:spPr>
-          <a:xfrm>
-            <a:off x="11430000" y="6446520"/>
-            <a:ext cx="548640" cy="320040"/>
-          </a:xfrm>
-          <a:prstGeom prst="rect">
-            <a:avLst/>
-          </a:prstGeom>
-          <a:noFill/>
-        </p:spPr>
-        <p:txBody>
-          <a:bodyPr wrap="none">
-            <a:spAutoFit/>
-          </a:bodyPr>
-          <a:lstStyle/>
-          <a:p>
-            <a:pPr algn="l">
-              <a:spcAft>
-                <a:spcPts val="700"/>
-              </a:spcAft>
-            </a:pPr>
-            <a:r>
-              <a:rPr sz="1100" b="0">
-                <a:solidFill>
-                  <a:srgbClr val="5A5A5A"/>
-                </a:solidFill>
-                <a:latin typeface="Calibri"/>
-              </a:rPr>
-              <a:t>8</a:t>
-            </a:r>
-          </a:p>
-        </p:txBody>
-      </p:sp>
-      <p:sp>
-        <p:nvSpPr>
-          <p:cNvPr id="4" name="TextBox 3"/>
-          <p:cNvSpPr txBox="1"/>
-          <p:nvPr/>
-        </p:nvSpPr>
-        <p:spPr>
-          <a:xfrm>
-            <a:off x="731520" y="1143000"/>
-            <a:ext cx="10789920" cy="5212080"/>
-          </a:xfrm>
-          <a:prstGeom prst="rect">
-            <a:avLst/>
-          </a:prstGeom>
-          <a:noFill/>
-        </p:spPr>
-        <p:txBody>
-          <a:bodyPr wrap="square">
-            <a:spAutoFit/>
-          </a:bodyPr>
-          <a:lstStyle/>
-          <a:p>
-            <a:pPr algn="l">
-              <a:spcAft>
-                <a:spcPts val="700"/>
-              </a:spcAft>
-            </a:pPr>
-            <a:r>
-              <a:rPr sz="1500" b="1">
-                <a:solidFill>
-                  <a:srgbClr val="212121"/>
-                </a:solidFill>
-                <a:latin typeface="Calibri"/>
-              </a:rPr>
-              <a:t>•  T1 (calibration): ZVF_t is an unbiased binomial-proportion estimator; Wilson CI covers 0.95–0.98 in every tested setting (Wald marginal at m=32). Curriculum ordering is an estimand-labelling requirement, not an invalidation.</a:t>
-            </a:r>
-          </a:p>
-          <a:p>
-            <a:pPr algn="l">
-              <a:spcAft>
-                <a:spcPts val="700"/>
-              </a:spcAft>
-            </a:pPr>
-            <a:r>
-              <a:rPr sz="1500" b="1">
-                <a:solidFill>
-                  <a:srgbClr val="212121"/>
-                </a:solidFill>
-                <a:latin typeface="Calibri"/>
-              </a:rPr>
-              <a:t>•  T2 (reliability budget): rollouts-to-next-informative-group is geometric; N(ZVF)=G⌈ln δ/ln ZVF⌉ matched observed quantiles at ratio 1.00 across all six difficulty strata (hardest: ZVF=0.886 ⇒ 160 rollouts). A budget, NOT an impossibility bound.</a:t>
-            </a:r>
-          </a:p>
-          <a:p>
-            <a:pPr algn="l">
-              <a:spcAft>
-                <a:spcPts val="700"/>
-              </a:spcAft>
-            </a:pPr>
-            <a:r>
-              <a:rPr sz="1500" b="1">
-                <a:solidFill>
-                  <a:srgbClr val="212121"/>
-                </a:solidFill>
-                <a:latin typeface="Calibri"/>
-              </a:rPr>
-              <a:t>•  T3 (honest negative): the signal-per-rollout objective satisfies J(2)=J(3) for EVERY difficulty prior — its argmax is universally {2,3}, so it cannot yield a data-adaptive G. Found by adversarial review; reported as a result, not buried.</a:t>
-            </a:r>
-          </a:p>
-          <a:p>
-            <a:pPr algn="l">
-              <a:spcAft>
-                <a:spcPts val="700"/>
-              </a:spcAft>
-            </a:pPr>
-            <a:r>
-              <a:rPr sz="1500" b="0">
-                <a:solidFill>
-                  <a:srgbClr val="212121"/>
-                </a:solidFill>
-                <a:latin typeface="Calibri"/>
-              </a:rPr>
-              <a:t>•  Two earlier statement errors (a quantifier confusion in T2; a GU sign slip) were caught by external review, corrected, re-validated — and are documented in the thesis as part of the method.</a:t>
             </a:r>
           </a:p>
         </p:txBody>
@@ -7198,7 +7952,7 @@
                 </a:solidFill>
                 <a:latin typeface="Calibri"/>
               </a:rPr>
-              <a:t>Result 4 — GRPO vs Dr.GRPO: No Footprint at This Scale (+ the Incident)</a:t>
+              <a:t>Result 3 — The Estimator Is Calibrated, the Budget Is Exact</a:t>
             </a:r>
           </a:p>
         </p:txBody>
@@ -7276,7 +8030,7 @@
                 </a:solidFill>
                 <a:latin typeface="Calibri"/>
               </a:rPr>
-              <a:t>•  Six-arm uncapped panel (Qwen3-8B, 1,024-token cap, 3 seeds/loss): GRPO lengths 1004→905, 981→944, 996→900; Dr.GRPO 999→931, 972→902, 1000→878 — lengths SHRINK 6–12% in every arm; no length inflation, no late-ZVF separation between losses.</a:t>
+              <a:t>•  T1 (calibration): ZVF_t is an unbiased binomial-proportion estimator; Wilson CI covers 0.95–0.98 in every tested setting (Wald marginal at m=32). Curriculum ordering is an estimand-labelling requirement, not an invalidation.</a:t>
             </a:r>
           </a:p>
           <a:p>
@@ -7286,45 +8040,45 @@
               </a:spcAft>
             </a:pPr>
             <a:r>
+              <a:rPr sz="1500" b="1">
+                <a:solidFill>
+                  <a:srgbClr val="212121"/>
+                </a:solidFill>
+                <a:latin typeface="Calibri"/>
+              </a:rPr>
+              <a:t>•  T2 (reliability budget): rollouts-to-next-informative-group is geometric; N(ZVF)=G⌈ln δ/ln ZVF⌉ matched observed quantiles at ratio 1.00 across all six difficulty strata (hardest: ZVF=0.886 ⇒ 160 rollouts). A budget, NOT an impossibility bound.</a:t>
+            </a:r>
+          </a:p>
+          <a:p>
+            <a:pPr algn="l">
+              <a:spcAft>
+                <a:spcPts val="700"/>
+              </a:spcAft>
+            </a:pPr>
+            <a:r>
+              <a:rPr sz="1500" b="1">
+                <a:solidFill>
+                  <a:srgbClr val="212121"/>
+                </a:solidFill>
+                <a:latin typeface="Calibri"/>
+              </a:rPr>
+              <a:t>•  T3 (honest negative): the signal-per-rollout objective satisfies J(2)=J(3) for EVERY difficulty prior — its argmax is universally {2,3}, so it cannot yield a data-adaptive G. Found by adversarial review; reported as a result, not buried.</a:t>
+            </a:r>
+          </a:p>
+          <a:p>
+            <a:pPr algn="l">
+              <a:spcAft>
+                <a:spcPts val="700"/>
+              </a:spcAft>
+            </a:pPr>
+            <a:r>
               <a:rPr sz="1500" b="0">
                 <a:solidFill>
                   <a:srgbClr val="212121"/>
                 </a:solidFill>
                 <a:latin typeface="Calibri"/>
               </a:rPr>
-              <a:t>•  Reading: at this scale the loss-form choice has no observable footprint on length or ZVF — evidence about reporting, not superiority. Comparisons between these losses measure stack noise unless controlled far more tightly than the labels suggest.</a:t>
-            </a:r>
-          </a:p>
-          <a:p>
-            <a:pPr algn="l">
-              <a:spcAft>
-                <a:spcPts val="700"/>
-              </a:spcAft>
-            </a:pPr>
-            <a:r>
-              <a:rPr sz="1500" b="1">
-                <a:solidFill>
-                  <a:srgbClr val="212121"/>
-                </a:solidFill>
-                <a:latin typeface="Calibri"/>
-              </a:rPr>
-              <a:t>•  The incident: the first panel ran with a documented --loss drgrpo flag that was never wired in — both "arms" silently trained identical GRPO. Caught only by reading the runner; artifacts preserved under .invalid_actually_grpo names; corrected rerun REVERSED one conclusion.</a:t>
-            </a:r>
-          </a:p>
-          <a:p>
-            <a:pPr algn="l">
-              <a:spcAft>
-                <a:spcPts val="700"/>
-              </a:spcAft>
-            </a:pPr>
-            <a:r>
-              <a:rPr sz="1500" b="0">
-                <a:solidFill>
-                  <a:srgbClr val="212121"/>
-                </a:solidFill>
-                <a:latin typeface="Calibri"/>
-              </a:rPr>
-              <a:t>•  Response became protocol: invalidate loudly → preserve → rerun → record. This failure is a first-class result feeding the reproducibility standard (Result 5).</a:t>
+              <a:t>•  Two earlier statement errors (a quantifier confusion in T2; a GU sign slip) were caught by external review, corrected, re-validated — and are documented in the thesis as part of the method.</a:t>
             </a:r>
           </a:p>
         </p:txBody>

</xml_diff>

<commit_message>
feat(deck): algorithms slide now states WHY each method was run
Column 3 reframed from 'role' to the question each method answers:
PPO = was dropping the critic free; GSPO = one-knob same-stack
isolation; Dr.GRPO = test the base paper's strongest critique;
DPO/IDPO = no-rollouts counterfactual (no groups, no ZVF by
construction); REINFORCE = any-PG floor; SFT/distillation = how much
gain needs RL at all; DAPO audit = how much a label underdetermines
the executed update; AERO/AREAL/GIFT = can telemetry distinguish
variants + is collapse universal.
</commit_message>
<xml_diff>
--- a/outputs/PESU_MTech_Phase1_Session1_Review_ArvindCR.pptx
+++ b/outputs/PESU_MTech_Phase1_Session1_Review_ArvindCR.pptx
@@ -1287,7 +1287,7 @@
           <a:lstStyle/>
           <a:p>
             <a:r>
-              <a:t>(1 min) Fast table walk. GRPO is the base paper, not the boundary: PPO ran as the value-based control on three open libraries plus the bench; GSPO head-to-head against GRPO on the same stack; Dr.GRPO in the six-arm loss panel; DPO/IDPO through the unified script generator; REINFORCE and SFT/distillation as baselines; and the DAPO label audit plus the AERO/AREAL/GIFT traces feed the reproducibility results. Every row has runnable artifacts in the repo.</a:t>
+              <a:t>(1 min) Fast table walk — lead with the WHY column: each method answers a specific question the thesis needed closed. PPO answers 'was the critic needed?'; GSPO isolates one knob on the same stack; Dr.GRPO tests the base paper's strongest critique; DPO is the no-rollouts counterfactual (no groups, so no ZVF by construction); REINFORCE and SFT are floors; the DAPO audit and the AERO/AREAL/GIFT traces exist to measure how much a method LABEL underdetermines what actually ran. Every row has runnable artifacts.</a:t>
             </a:r>
           </a:p>
         </p:txBody>
@@ -6464,7 +6464,7 @@
                 </a:solidFill>
                 <a:latin typeface="Calibri"/>
               </a:rPr>
-              <a:t>Not Only GRPO — Algorithms &amp; Methods Run</a:t>
+              <a:t>Not Only GRPO — Algorithms &amp; Methods Run, and Why</a:t>
             </a:r>
           </a:p>
         </p:txBody>
@@ -6527,9 +6527,9 @@
                 <a:tableStyleId>{5C22544A-7EE6-4342-B048-85BDC9FD1C3A}</a:tableStyleId>
               </a:tblPr>
               <a:tblGrid>
-                <a:gridCol w="2651760"/>
+                <a:gridCol w="2286000"/>
+                <a:gridCol w="3566160"/>
                 <a:gridCol w="4663440"/>
-                <a:gridCol w="3200400"/>
               </a:tblGrid>
               <a:tr h="329183">
                 <a:tc>
@@ -6538,7 +6538,7 @@
                     <a:lstStyle/>
                     <a:p>
                       <a:r>
-                        <a:rPr sz="1200" b="1">
+                        <a:rPr sz="1100" b="1">
                           <a:solidFill>
                             <a:srgbClr val="FFFFFF"/>
                           </a:solidFill>
@@ -6556,7 +6556,7 @@
                     <a:lstStyle/>
                     <a:p>
                       <a:r>
-                        <a:rPr sz="1200" b="1">
+                        <a:rPr sz="1100" b="1">
                           <a:solidFill>
                             <a:srgbClr val="FFFFFF"/>
                           </a:solidFill>
@@ -6574,13 +6574,13 @@
                     <a:lstStyle/>
                     <a:p>
                       <a:r>
-                        <a:rPr sz="1200" b="1">
+                        <a:rPr sz="1100" b="1">
                           <a:solidFill>
                             <a:srgbClr val="FFFFFF"/>
                           </a:solidFill>
                           <a:latin typeface="Calibri"/>
                         </a:rPr>
-                        <a:t>role in the study</a:t>
+                        <a:t>why it was run (question it answers)</a:t>
                       </a:r>
                     </a:p>
                   </a:txBody>
@@ -6594,7 +6594,7 @@
                     <a:lstStyle/>
                     <a:p>
                       <a:r>
-                        <a:rPr sz="1200" b="0">
+                        <a:rPr sz="1100" b="0">
                           <a:solidFill>
                             <a:srgbClr val="212121"/>
                           </a:solidFill>
@@ -6612,13 +6612,13 @@
                     <a:lstStyle/>
                     <a:p>
                       <a:r>
-                        <a:rPr sz="1200" b="0">
+                        <a:rPr sz="1100" b="0">
                           <a:solidFill>
                             <a:srgbClr val="212121"/>
                           </a:solidFill>
                           <a:latin typeface="Calibri"/>
                         </a:rPr>
-                        <a:t>Tinker fleets (Qwen3-8B), TRL on Modal H100, open trainers</a:t>
+                        <a:t>Tinker fleets (Qwen3-8B); TRL on Modal H100; open trainers</a:t>
                       </a:r>
                     </a:p>
                   </a:txBody>
@@ -6630,13 +6630,13 @@
                     <a:lstStyle/>
                     <a:p>
                       <a:r>
-                        <a:rPr sz="1200" b="0">
+                        <a:rPr sz="1100" b="0">
                           <a:solidFill>
                             <a:srgbClr val="212121"/>
                           </a:solidFill>
                           <a:latin typeface="Calibri"/>
                         </a:rPr>
-                        <a:t>primary subject — all ZVF claims</a:t>
+                        <a:t>The subject: does its group-relative update starve, when, and how do you see it? (Claims 1-2)</a:t>
                       </a:r>
                     </a:p>
                   </a:txBody>
@@ -6650,7 +6650,7 @@
                     <a:lstStyle/>
                     <a:p>
                       <a:r>
-                        <a:rPr sz="1200" b="0">
+                        <a:rPr sz="1100" b="0">
                           <a:solidFill>
                             <a:srgbClr val="212121"/>
                           </a:solidFill>
@@ -6668,7 +6668,7 @@
                     <a:lstStyle/>
                     <a:p>
                       <a:r>
-                        <a:rPr sz="1200" b="0">
+                        <a:rPr sz="1100" b="0">
                           <a:solidFill>
                             <a:srgbClr val="212121"/>
                           </a:solidFill>
@@ -6686,13 +6686,13 @@
                     <a:lstStyle/>
                     <a:p>
                       <a:r>
-                        <a:rPr sz="1200" b="0">
+                        <a:rPr sz="1100" b="0">
                           <a:solidFill>
                             <a:srgbClr val="212121"/>
                           </a:solidFill>
                           <a:latin typeface="Calibri"/>
                         </a:rPr>
-                        <a:t>length-bias critique test (Result 4)</a:t>
+                        <a:t>Test the base paper's strongest critique: does the length-bias fix change length/ZVF at our scale? (No footprint - Result 4)</a:t>
                       </a:r>
                     </a:p>
                   </a:txBody>
@@ -6706,7 +6706,7 @@
                     <a:lstStyle/>
                     <a:p>
                       <a:r>
-                        <a:rPr sz="1200" b="0">
+                        <a:rPr sz="1100" b="0">
                           <a:solidFill>
                             <a:srgbClr val="212121"/>
                           </a:solidFill>
@@ -6724,7 +6724,7 @@
                     <a:lstStyle/>
                     <a:p>
                       <a:r>
-                        <a:rPr sz="1200" b="0">
+                        <a:rPr sz="1100" b="0">
                           <a:solidFill>
                             <a:srgbClr val="212121"/>
                           </a:solidFill>
@@ -6742,13 +6742,13 @@
                     <a:lstStyle/>
                     <a:p>
                       <a:r>
-                        <a:rPr sz="1200" b="0">
+                        <a:rPr sz="1100" b="0">
                           <a:solidFill>
                             <a:srgbClr val="212121"/>
                           </a:solidFill>
                           <a:latin typeface="Calibri"/>
                         </a:rPr>
-                        <a:t>sequence-level IS ratio control</a:t>
+                        <a:t>Isolate ONE knob (token- vs sequence-level IS ratio) with everything else fixed - the same-stack control discipline (RQ1)</a:t>
                       </a:r>
                     </a:p>
                   </a:txBody>
@@ -6762,7 +6762,7 @@
                     <a:lstStyle/>
                     <a:p>
                       <a:r>
-                        <a:rPr sz="1200" b="0">
+                        <a:rPr sz="1100" b="0">
                           <a:solidFill>
                             <a:srgbClr val="212121"/>
                           </a:solidFill>
@@ -6780,7 +6780,7 @@
                     <a:lstStyle/>
                     <a:p>
                       <a:r>
-                        <a:rPr sz="1200" b="0">
+                        <a:rPr sz="1100" b="0">
                           <a:solidFill>
                             <a:srgbClr val="212121"/>
                           </a:solidFill>
@@ -6798,13 +6798,13 @@
                     <a:lstStyle/>
                     <a:p>
                       <a:r>
-                        <a:rPr sz="1200" b="0">
+                        <a:rPr sz="1100" b="0">
                           <a:solidFill>
                             <a:srgbClr val="212121"/>
                           </a:solidFill>
                           <a:latin typeface="Calibri"/>
                         </a:rPr>
-                        <a:t>value-based baseline family (RQ1)</a:t>
+                        <a:t>Was dropping the critic actually free? Value-based baseline + cross-library reproducibility anchor (RQ1)</a:t>
                       </a:r>
                     </a:p>
                   </a:txBody>
@@ -6818,7 +6818,7 @@
                     <a:lstStyle/>
                     <a:p>
                       <a:r>
-                        <a:rPr sz="1200" b="0">
+                        <a:rPr sz="1100" b="0">
                           <a:solidFill>
                             <a:srgbClr val="212121"/>
                           </a:solidFill>
@@ -6836,7 +6836,7 @@
                     <a:lstStyle/>
                     <a:p>
                       <a:r>
-                        <a:rPr sz="1200" b="0">
+                        <a:rPr sz="1100" b="0">
                           <a:solidFill>
                             <a:srgbClr val="212121"/>
                           </a:solidFill>
@@ -6854,13 +6854,13 @@
                     <a:lstStyle/>
                     <a:p>
                       <a:r>
-                        <a:rPr sz="1200" b="0">
+                        <a:rPr sz="1100" b="0">
                           <a:solidFill>
                             <a:srgbClr val="212121"/>
                           </a:solidFill>
                           <a:latin typeface="Calibri"/>
                         </a:rPr>
-                        <a:t>simplest policy-gradient control</a:t>
+                        <a:t>Simplest policy gradient: a floor showing gains are not just any-PG artifacts</a:t>
                       </a:r>
                     </a:p>
                   </a:txBody>
@@ -6874,7 +6874,7 @@
                     <a:lstStyle/>
                     <a:p>
                       <a:r>
-                        <a:rPr sz="1200" b="0">
+                        <a:rPr sz="1100" b="0">
                           <a:solidFill>
                             <a:srgbClr val="212121"/>
                           </a:solidFill>
@@ -6892,7 +6892,7 @@
                     <a:lstStyle/>
                     <a:p>
                       <a:r>
-                        <a:rPr sz="1200" b="0">
+                        <a:rPr sz="1100" b="0">
                           <a:solidFill>
                             <a:srgbClr val="212121"/>
                           </a:solidFill>
@@ -6910,13 +6910,13 @@
                     <a:lstStyle/>
                     <a:p>
                       <a:r>
-                        <a:rPr sz="1200" b="0">
+                        <a:rPr sz="1100" b="0">
                           <a:solidFill>
                             <a:srgbClr val="212121"/>
                           </a:solidFill>
                           <a:latin typeface="Calibri"/>
                         </a:rPr>
-                        <a:t>preference optimisation, no rollouts</a:t>
+                        <a:t>The counterfactual family: preference optimisation without rollouts has no groups - no ZVF by construction</a:t>
                       </a:r>
                     </a:p>
                   </a:txBody>
@@ -6930,7 +6930,7 @@
                     <a:lstStyle/>
                     <a:p>
                       <a:r>
-                        <a:rPr sz="1200" b="0">
+                        <a:rPr sz="1100" b="0">
                           <a:solidFill>
                             <a:srgbClr val="212121"/>
                           </a:solidFill>
@@ -6948,7 +6948,7 @@
                     <a:lstStyle/>
                     <a:p>
                       <a:r>
-                        <a:rPr sz="1200" b="0">
+                        <a:rPr sz="1100" b="0">
                           <a:solidFill>
                             <a:srgbClr val="212121"/>
                           </a:solidFill>
@@ -6966,13 +6966,13 @@
                     <a:lstStyle/>
                     <a:p>
                       <a:r>
-                        <a:rPr sz="1200" b="0">
+                        <a:rPr sz="1100" b="0">
                           <a:solidFill>
                             <a:srgbClr val="212121"/>
                           </a:solidFill>
                           <a:latin typeface="Calibri"/>
                         </a:rPr>
-                        <a:t>non-RL baselines and adapters</a:t>
+                        <a:t>Non-RL control: how much of the gain needs RL at all?</a:t>
                       </a:r>
                     </a:p>
                   </a:txBody>
@@ -6986,7 +6986,7 @@
                     <a:lstStyle/>
                     <a:p>
                       <a:r>
-                        <a:rPr sz="1200" b="0">
+                        <a:rPr sz="1100" b="0">
                           <a:solidFill>
                             <a:srgbClr val="212121"/>
                           </a:solidFill>
@@ -7004,7 +7004,7 @@
                     <a:lstStyle/>
                     <a:p>
                       <a:r>
-                        <a:rPr sz="1200" b="0">
+                        <a:rPr sz="1100" b="0">
                           <a:solidFill>
                             <a:srgbClr val="212121"/>
                           </a:solidFill>
@@ -7022,13 +7022,13 @@
                     <a:lstStyle/>
                     <a:p>
                       <a:r>
-                        <a:rPr sz="1200" b="0">
+                        <a:rPr sz="1100" b="0">
                           <a:solidFill>
                             <a:srgbClr val="212121"/>
                           </a:solidFill>
                           <a:latin typeface="Calibri"/>
                         </a:rPr>
-                        <a:t>label-flip evidence: ZVF 0.00 vs 0.55-0.58</a:t>
+                        <a:t>How much does a method NAME underdetermine the executed update? Measured: ZVF 0.00 vs 0.55-0.58 under one label</a:t>
                       </a:r>
                     </a:p>
                   </a:txBody>
@@ -7042,7 +7042,7 @@
                     <a:lstStyle/>
                     <a:p>
                       <a:r>
-                        <a:rPr sz="1200" b="0">
+                        <a:rPr sz="1100" b="0">
                           <a:solidFill>
                             <a:srgbClr val="212121"/>
                           </a:solidFill>
@@ -7060,7 +7060,7 @@
                     <a:lstStyle/>
                     <a:p>
                       <a:r>
-                        <a:rPr sz="1200" b="0">
+                        <a:rPr sz="1100" b="0">
                           <a:solidFill>
                             <a:srgbClr val="212121"/>
                           </a:solidFill>
@@ -7078,13 +7078,13 @@
                     <a:lstStyle/>
                     <a:p>
                       <a:r>
-                        <a:rPr sz="1200" b="0">
+                        <a:rPr sz="1100" b="0">
                           <a:solidFill>
                             <a:srgbClr val="212121"/>
                           </a:solidFill>
                           <a:latin typeface="Calibri"/>
                         </a:rPr>
-                        <a:t>P2 collapse panel, P8 detector, survival-audit pilot</a:t>
+                        <a:t>Can telemetry alone distinguish method variants (P8 detector), and is collapse universal across them? (P2 panel)</a:t>
                       </a:r>
                     </a:p>
                   </a:txBody>

</xml_diff>

<commit_message>
feat(deck): add diagrams — mechanism, architecture, U-shape kernel, budget trajectories
- Slide 2: native-shapes mechanism diagram — a contrast group (1,0,1,0 ->
  advantages +/-0.5, gradient flows) vs an all-correct group (1,1,1,1 ->
  advantages all zero) with the silent-failure punchline.
- Slide 4: layered architecture diagram (Training -> Telemetry ->
  Evaluation -> Audit pipeline with zvf-triage and W&B/HF mirror boxes)
  replacing the bullet wall; design-rule footer.
- Slide 7: U-shape kernel h_G(p) plot (matplotlib, regenerated on every
  build into outputs/deck_assets/).
- Slide 8: matched-budget trajectory schematic mirroring the corrected
  thesis Fig 4.1 (G=2 reward->1.0 as ZVF climbs into the wall; G=16
  mid-learning, ZVF low; signal-gone marker at 0.72).
Build now needs matplotlib: uv run --with python-pptx,matplotlib.
</commit_message>
<xml_diff>
--- a/outputs/PESU_MTech_Phase1_Session1_Review_ArvindCR.pptx
+++ b/outputs/PESU_MTech_Phase1_Session1_Review_ArvindCR.pptx
@@ -5952,7 +5952,7 @@
         <p:spPr>
           <a:xfrm>
             <a:off x="731520" y="1143000"/>
-            <a:ext cx="10789920" cy="5212080"/>
+            <a:ext cx="6858000" cy="5212080"/>
           </a:xfrm>
           <a:prstGeom prst="rect">
             <a:avLst/>
@@ -5971,7 +5971,7 @@
               </a:spcAft>
             </a:pPr>
             <a:r>
-              <a:rPr sz="1500" b="1">
+              <a:rPr sz="1300" b="1">
                 <a:solidFill>
                   <a:srgbClr val="212121"/>
                 </a:solidFill>
@@ -5987,7 +5987,7 @@
               </a:spcAft>
             </a:pPr>
             <a:r>
-              <a:rPr sz="1500" b="0">
+              <a:rPr sz="1300" b="0">
                 <a:solidFill>
                   <a:srgbClr val="212121"/>
                 </a:solidFill>
@@ -6003,7 +6003,7 @@
               </a:spcAft>
             </a:pPr>
             <a:r>
-              <a:rPr sz="1500" b="1">
+              <a:rPr sz="1300" b="1">
                 <a:solidFill>
                   <a:srgbClr val="212121"/>
                 </a:solidFill>
@@ -6019,7 +6019,7 @@
               </a:spcAft>
             </a:pPr>
             <a:r>
-              <a:rPr sz="1500" b="0">
+              <a:rPr sz="1300" b="0">
                 <a:solidFill>
                   <a:srgbClr val="212121"/>
                 </a:solidFill>
@@ -6035,13 +6035,822 @@
               </a:spcAft>
             </a:pPr>
             <a:r>
-              <a:rPr sz="1500" b="1">
+              <a:rPr sz="1300" b="1">
                 <a:solidFill>
                   <a:srgbClr val="212121"/>
                 </a:solidFill>
                 <a:latin typeface="Calibri"/>
               </a:rPr>
               <a:t>•  Thesis position: measure the blind spot (Zero-Variance Fraction, ZVF), calibrate it, budget it, and show what it changes in practice.</a:t>
+            </a:r>
+          </a:p>
+        </p:txBody>
+      </p:sp>
+      <p:sp>
+        <p:nvSpPr>
+          <p:cNvPr id="5" name="TextBox 4"/>
+          <p:cNvSpPr txBox="1"/>
+          <p:nvPr/>
+        </p:nvSpPr>
+        <p:spPr>
+          <a:xfrm>
+            <a:off x="7818120" y="1051560"/>
+            <a:ext cx="3931920" cy="365760"/>
+          </a:xfrm>
+          <a:prstGeom prst="rect">
+            <a:avLst/>
+          </a:prstGeom>
+          <a:noFill/>
+        </p:spPr>
+        <p:txBody>
+          <a:bodyPr wrap="none">
+            <a:spAutoFit/>
+          </a:bodyPr>
+          <a:lstStyle/>
+          <a:p>
+            <a:pPr algn="ctr">
+              <a:spcAft>
+                <a:spcPts val="700"/>
+              </a:spcAft>
+            </a:pPr>
+            <a:r>
+              <a:rPr sz="1100" b="0">
+                <a:solidFill>
+                  <a:srgbClr val="5A5A5A"/>
+                </a:solidFill>
+                <a:latin typeface="Calibri"/>
+              </a:rPr>
+              <a:t>one prompt → G=4 completions, reward r ∈ {0,1}</a:t>
+            </a:r>
+          </a:p>
+        </p:txBody>
+      </p:sp>
+      <p:sp>
+        <p:nvSpPr>
+          <p:cNvPr id="6" name="TextBox 5"/>
+          <p:cNvSpPr txBox="1"/>
+          <p:nvPr/>
+        </p:nvSpPr>
+        <p:spPr>
+          <a:xfrm>
+            <a:off x="7818120" y="1481328"/>
+            <a:ext cx="3931920" cy="320040"/>
+          </a:xfrm>
+          <a:prstGeom prst="rect">
+            <a:avLst/>
+          </a:prstGeom>
+          <a:noFill/>
+        </p:spPr>
+        <p:txBody>
+          <a:bodyPr wrap="none">
+            <a:spAutoFit/>
+          </a:bodyPr>
+          <a:lstStyle/>
+          <a:p>
+            <a:pPr algn="l">
+              <a:spcAft>
+                <a:spcPts val="700"/>
+              </a:spcAft>
+            </a:pPr>
+            <a:r>
+              <a:rPr sz="1100" b="1">
+                <a:solidFill>
+                  <a:srgbClr val="212121"/>
+                </a:solidFill>
+                <a:latin typeface="Calibri"/>
+              </a:rPr>
+              <a:t>group with contrast</a:t>
+            </a:r>
+          </a:p>
+        </p:txBody>
+      </p:sp>
+      <p:sp>
+        <p:nvSpPr>
+          <p:cNvPr id="7" name="Rounded Rectangle 6"/>
+          <p:cNvSpPr/>
+          <p:nvPr/>
+        </p:nvSpPr>
+        <p:spPr>
+          <a:xfrm>
+            <a:off x="7818120" y="1828800"/>
+            <a:ext cx="457200" cy="457200"/>
+          </a:xfrm>
+          <a:prstGeom prst="roundRect">
+            <a:avLst/>
+          </a:prstGeom>
+          <a:solidFill>
+            <a:srgbClr val="1F4E79"/>
+          </a:solidFill>
+          <a:ln>
+            <a:solidFill>
+              <a:srgbClr val="1F4E79"/>
+            </a:solidFill>
+          </a:ln>
+        </p:spPr>
+        <p:style>
+          <a:lnRef idx="1">
+            <a:schemeClr val="accent1"/>
+          </a:lnRef>
+          <a:fillRef idx="3">
+            <a:schemeClr val="accent1"/>
+          </a:fillRef>
+          <a:effectRef idx="2">
+            <a:schemeClr val="accent1"/>
+          </a:effectRef>
+          <a:fontRef idx="minor">
+            <a:schemeClr val="lt1"/>
+          </a:fontRef>
+        </p:style>
+        <p:txBody>
+          <a:bodyPr rtlCol="0" anchor="ctr" wrap="square" lIns="45720" rIns="45720"/>
+          <a:lstStyle/>
+          <a:p>
+            <a:pPr algn="ctr">
+              <a:spcAft>
+                <a:spcPts val="700"/>
+              </a:spcAft>
+            </a:pPr>
+            <a:r>
+              <a:rPr sz="1300" b="1">
+                <a:solidFill>
+                  <a:srgbClr val="FFFFFF"/>
+                </a:solidFill>
+                <a:latin typeface="Calibri"/>
+              </a:rPr>
+              <a:t>1</a:t>
+            </a:r>
+          </a:p>
+        </p:txBody>
+      </p:sp>
+      <p:sp>
+        <p:nvSpPr>
+          <p:cNvPr id="8" name="Rounded Rectangle 7"/>
+          <p:cNvSpPr/>
+          <p:nvPr/>
+        </p:nvSpPr>
+        <p:spPr>
+          <a:xfrm>
+            <a:off x="8385048" y="1828800"/>
+            <a:ext cx="457200" cy="457200"/>
+          </a:xfrm>
+          <a:prstGeom prst="roundRect">
+            <a:avLst/>
+          </a:prstGeom>
+          <a:solidFill>
+            <a:srgbClr val="B0B7C0"/>
+          </a:solidFill>
+          <a:ln>
+            <a:solidFill>
+              <a:srgbClr val="B0B7C0"/>
+            </a:solidFill>
+          </a:ln>
+        </p:spPr>
+        <p:style>
+          <a:lnRef idx="1">
+            <a:schemeClr val="accent1"/>
+          </a:lnRef>
+          <a:fillRef idx="3">
+            <a:schemeClr val="accent1"/>
+          </a:fillRef>
+          <a:effectRef idx="2">
+            <a:schemeClr val="accent1"/>
+          </a:effectRef>
+          <a:fontRef idx="minor">
+            <a:schemeClr val="lt1"/>
+          </a:fontRef>
+        </p:style>
+        <p:txBody>
+          <a:bodyPr rtlCol="0" anchor="ctr" wrap="square" lIns="45720" rIns="45720"/>
+          <a:lstStyle/>
+          <a:p>
+            <a:pPr algn="ctr">
+              <a:spcAft>
+                <a:spcPts val="700"/>
+              </a:spcAft>
+            </a:pPr>
+            <a:r>
+              <a:rPr sz="1300" b="1">
+                <a:solidFill>
+                  <a:srgbClr val="FFFFFF"/>
+                </a:solidFill>
+                <a:latin typeface="Calibri"/>
+              </a:rPr>
+              <a:t>0</a:t>
+            </a:r>
+          </a:p>
+        </p:txBody>
+      </p:sp>
+      <p:sp>
+        <p:nvSpPr>
+          <p:cNvPr id="9" name="Rounded Rectangle 8"/>
+          <p:cNvSpPr/>
+          <p:nvPr/>
+        </p:nvSpPr>
+        <p:spPr>
+          <a:xfrm>
+            <a:off x="8951976" y="1828800"/>
+            <a:ext cx="457200" cy="457200"/>
+          </a:xfrm>
+          <a:prstGeom prst="roundRect">
+            <a:avLst/>
+          </a:prstGeom>
+          <a:solidFill>
+            <a:srgbClr val="1F4E79"/>
+          </a:solidFill>
+          <a:ln>
+            <a:solidFill>
+              <a:srgbClr val="1F4E79"/>
+            </a:solidFill>
+          </a:ln>
+        </p:spPr>
+        <p:style>
+          <a:lnRef idx="1">
+            <a:schemeClr val="accent1"/>
+          </a:lnRef>
+          <a:fillRef idx="3">
+            <a:schemeClr val="accent1"/>
+          </a:fillRef>
+          <a:effectRef idx="2">
+            <a:schemeClr val="accent1"/>
+          </a:effectRef>
+          <a:fontRef idx="minor">
+            <a:schemeClr val="lt1"/>
+          </a:fontRef>
+        </p:style>
+        <p:txBody>
+          <a:bodyPr rtlCol="0" anchor="ctr" wrap="square" lIns="45720" rIns="45720"/>
+          <a:lstStyle/>
+          <a:p>
+            <a:pPr algn="ctr">
+              <a:spcAft>
+                <a:spcPts val="700"/>
+              </a:spcAft>
+            </a:pPr>
+            <a:r>
+              <a:rPr sz="1300" b="1">
+                <a:solidFill>
+                  <a:srgbClr val="FFFFFF"/>
+                </a:solidFill>
+                <a:latin typeface="Calibri"/>
+              </a:rPr>
+              <a:t>1</a:t>
+            </a:r>
+          </a:p>
+        </p:txBody>
+      </p:sp>
+      <p:sp>
+        <p:nvSpPr>
+          <p:cNvPr id="10" name="Rounded Rectangle 9"/>
+          <p:cNvSpPr/>
+          <p:nvPr/>
+        </p:nvSpPr>
+        <p:spPr>
+          <a:xfrm>
+            <a:off x="9518904" y="1828800"/>
+            <a:ext cx="457200" cy="457200"/>
+          </a:xfrm>
+          <a:prstGeom prst="roundRect">
+            <a:avLst/>
+          </a:prstGeom>
+          <a:solidFill>
+            <a:srgbClr val="B0B7C0"/>
+          </a:solidFill>
+          <a:ln>
+            <a:solidFill>
+              <a:srgbClr val="B0B7C0"/>
+            </a:solidFill>
+          </a:ln>
+        </p:spPr>
+        <p:style>
+          <a:lnRef idx="1">
+            <a:schemeClr val="accent1"/>
+          </a:lnRef>
+          <a:fillRef idx="3">
+            <a:schemeClr val="accent1"/>
+          </a:fillRef>
+          <a:effectRef idx="2">
+            <a:schemeClr val="accent1"/>
+          </a:effectRef>
+          <a:fontRef idx="minor">
+            <a:schemeClr val="lt1"/>
+          </a:fontRef>
+        </p:style>
+        <p:txBody>
+          <a:bodyPr rtlCol="0" anchor="ctr" wrap="square" lIns="45720" rIns="45720"/>
+          <a:lstStyle/>
+          <a:p>
+            <a:pPr algn="ctr">
+              <a:spcAft>
+                <a:spcPts val="700"/>
+              </a:spcAft>
+            </a:pPr>
+            <a:r>
+              <a:rPr sz="1300" b="1">
+                <a:solidFill>
+                  <a:srgbClr val="FFFFFF"/>
+                </a:solidFill>
+                <a:latin typeface="Calibri"/>
+              </a:rPr>
+              <a:t>0</a:t>
+            </a:r>
+          </a:p>
+        </p:txBody>
+      </p:sp>
+      <p:cxnSp>
+        <p:nvCxnSpPr>
+          <p:cNvPr id="11" name="Connector 10"/>
+          <p:cNvCxnSpPr/>
+          <p:nvPr/>
+        </p:nvCxnSpPr>
+        <p:spPr>
+          <a:xfrm>
+            <a:off x="10195560" y="2057400"/>
+            <a:ext cx="502920" cy="0"/>
+          </a:xfrm>
+          <a:prstGeom prst="line">
+            <a:avLst/>
+          </a:prstGeom>
+          <a:ln w="25400">
+            <a:solidFill>
+              <a:srgbClr val="5A5A5A"/>
+            </a:solidFill>
+          </a:ln>
+        </p:spPr>
+        <p:style>
+          <a:lnRef idx="2">
+            <a:schemeClr val="accent1"/>
+          </a:lnRef>
+          <a:fillRef idx="0">
+            <a:schemeClr val="accent1"/>
+          </a:fillRef>
+          <a:effectRef idx="1">
+            <a:schemeClr val="accent1"/>
+          </a:effectRef>
+          <a:fontRef idx="minor">
+            <a:schemeClr val="tx1"/>
+          </a:fontRef>
+        </p:style>
+      </p:cxnSp>
+      <p:sp>
+        <p:nvSpPr>
+          <p:cNvPr id="12" name="Rounded Rectangle 11"/>
+          <p:cNvSpPr/>
+          <p:nvPr/>
+        </p:nvSpPr>
+        <p:spPr>
+          <a:xfrm>
+            <a:off x="10744200" y="1783080"/>
+            <a:ext cx="1051560" cy="566928"/>
+          </a:xfrm>
+          <a:prstGeom prst="roundRect">
+            <a:avLst/>
+          </a:prstGeom>
+          <a:solidFill>
+            <a:srgbClr val="2E7D32"/>
+          </a:solidFill>
+          <a:ln>
+            <a:solidFill>
+              <a:srgbClr val="2E7D32"/>
+            </a:solidFill>
+          </a:ln>
+        </p:spPr>
+        <p:style>
+          <a:lnRef idx="1">
+            <a:schemeClr val="accent1"/>
+          </a:lnRef>
+          <a:fillRef idx="3">
+            <a:schemeClr val="accent1"/>
+          </a:fillRef>
+          <a:effectRef idx="2">
+            <a:schemeClr val="accent1"/>
+          </a:effectRef>
+          <a:fontRef idx="minor">
+            <a:schemeClr val="lt1"/>
+          </a:fontRef>
+        </p:style>
+        <p:txBody>
+          <a:bodyPr rtlCol="0" anchor="ctr" wrap="square" lIns="45720" rIns="45720"/>
+          <a:lstStyle/>
+          <a:p>
+            <a:pPr algn="ctr">
+              <a:spcAft>
+                <a:spcPts val="700"/>
+              </a:spcAft>
+            </a:pPr>
+            <a:r>
+              <a:rPr sz="900" b="1">
+                <a:solidFill>
+                  <a:srgbClr val="FFFFFF"/>
+                </a:solidFill>
+                <a:latin typeface="Calibri"/>
+              </a:rPr>
+              <a:t>A = ±0.5
+gradient flows</a:t>
+            </a:r>
+          </a:p>
+        </p:txBody>
+      </p:sp>
+      <p:sp>
+        <p:nvSpPr>
+          <p:cNvPr id="13" name="TextBox 12"/>
+          <p:cNvSpPr txBox="1"/>
+          <p:nvPr/>
+        </p:nvSpPr>
+        <p:spPr>
+          <a:xfrm>
+            <a:off x="7818120" y="2606040"/>
+            <a:ext cx="3931920" cy="320040"/>
+          </a:xfrm>
+          <a:prstGeom prst="rect">
+            <a:avLst/>
+          </a:prstGeom>
+          <a:noFill/>
+        </p:spPr>
+        <p:txBody>
+          <a:bodyPr wrap="none">
+            <a:spAutoFit/>
+          </a:bodyPr>
+          <a:lstStyle/>
+          <a:p>
+            <a:pPr algn="l">
+              <a:spcAft>
+                <a:spcPts val="700"/>
+              </a:spcAft>
+            </a:pPr>
+            <a:r>
+              <a:rPr sz="1100" b="1">
+                <a:solidFill>
+                  <a:srgbClr val="212121"/>
+                </a:solidFill>
+                <a:latin typeface="Calibri"/>
+              </a:rPr>
+              <a:t>all-correct group (the blind spot)</a:t>
+            </a:r>
+          </a:p>
+        </p:txBody>
+      </p:sp>
+      <p:sp>
+        <p:nvSpPr>
+          <p:cNvPr id="14" name="Rounded Rectangle 13"/>
+          <p:cNvSpPr/>
+          <p:nvPr/>
+        </p:nvSpPr>
+        <p:spPr>
+          <a:xfrm>
+            <a:off x="7818120" y="2944368"/>
+            <a:ext cx="457200" cy="457200"/>
+          </a:xfrm>
+          <a:prstGeom prst="roundRect">
+            <a:avLst/>
+          </a:prstGeom>
+          <a:solidFill>
+            <a:srgbClr val="1F4E79"/>
+          </a:solidFill>
+          <a:ln>
+            <a:solidFill>
+              <a:srgbClr val="1F4E79"/>
+            </a:solidFill>
+          </a:ln>
+        </p:spPr>
+        <p:style>
+          <a:lnRef idx="1">
+            <a:schemeClr val="accent1"/>
+          </a:lnRef>
+          <a:fillRef idx="3">
+            <a:schemeClr val="accent1"/>
+          </a:fillRef>
+          <a:effectRef idx="2">
+            <a:schemeClr val="accent1"/>
+          </a:effectRef>
+          <a:fontRef idx="minor">
+            <a:schemeClr val="lt1"/>
+          </a:fontRef>
+        </p:style>
+        <p:txBody>
+          <a:bodyPr rtlCol="0" anchor="ctr" wrap="square" lIns="45720" rIns="45720"/>
+          <a:lstStyle/>
+          <a:p>
+            <a:pPr algn="ctr">
+              <a:spcAft>
+                <a:spcPts val="700"/>
+              </a:spcAft>
+            </a:pPr>
+            <a:r>
+              <a:rPr sz="1300" b="1">
+                <a:solidFill>
+                  <a:srgbClr val="FFFFFF"/>
+                </a:solidFill>
+                <a:latin typeface="Calibri"/>
+              </a:rPr>
+              <a:t>1</a:t>
+            </a:r>
+          </a:p>
+        </p:txBody>
+      </p:sp>
+      <p:sp>
+        <p:nvSpPr>
+          <p:cNvPr id="15" name="Rounded Rectangle 14"/>
+          <p:cNvSpPr/>
+          <p:nvPr/>
+        </p:nvSpPr>
+        <p:spPr>
+          <a:xfrm>
+            <a:off x="8385048" y="2944368"/>
+            <a:ext cx="457200" cy="457200"/>
+          </a:xfrm>
+          <a:prstGeom prst="roundRect">
+            <a:avLst/>
+          </a:prstGeom>
+          <a:solidFill>
+            <a:srgbClr val="1F4E79"/>
+          </a:solidFill>
+          <a:ln>
+            <a:solidFill>
+              <a:srgbClr val="1F4E79"/>
+            </a:solidFill>
+          </a:ln>
+        </p:spPr>
+        <p:style>
+          <a:lnRef idx="1">
+            <a:schemeClr val="accent1"/>
+          </a:lnRef>
+          <a:fillRef idx="3">
+            <a:schemeClr val="accent1"/>
+          </a:fillRef>
+          <a:effectRef idx="2">
+            <a:schemeClr val="accent1"/>
+          </a:effectRef>
+          <a:fontRef idx="minor">
+            <a:schemeClr val="lt1"/>
+          </a:fontRef>
+        </p:style>
+        <p:txBody>
+          <a:bodyPr rtlCol="0" anchor="ctr" wrap="square" lIns="45720" rIns="45720"/>
+          <a:lstStyle/>
+          <a:p>
+            <a:pPr algn="ctr">
+              <a:spcAft>
+                <a:spcPts val="700"/>
+              </a:spcAft>
+            </a:pPr>
+            <a:r>
+              <a:rPr sz="1300" b="1">
+                <a:solidFill>
+                  <a:srgbClr val="FFFFFF"/>
+                </a:solidFill>
+                <a:latin typeface="Calibri"/>
+              </a:rPr>
+              <a:t>1</a:t>
+            </a:r>
+          </a:p>
+        </p:txBody>
+      </p:sp>
+      <p:sp>
+        <p:nvSpPr>
+          <p:cNvPr id="16" name="Rounded Rectangle 15"/>
+          <p:cNvSpPr/>
+          <p:nvPr/>
+        </p:nvSpPr>
+        <p:spPr>
+          <a:xfrm>
+            <a:off x="8951976" y="2944368"/>
+            <a:ext cx="457200" cy="457200"/>
+          </a:xfrm>
+          <a:prstGeom prst="roundRect">
+            <a:avLst/>
+          </a:prstGeom>
+          <a:solidFill>
+            <a:srgbClr val="1F4E79"/>
+          </a:solidFill>
+          <a:ln>
+            <a:solidFill>
+              <a:srgbClr val="1F4E79"/>
+            </a:solidFill>
+          </a:ln>
+        </p:spPr>
+        <p:style>
+          <a:lnRef idx="1">
+            <a:schemeClr val="accent1"/>
+          </a:lnRef>
+          <a:fillRef idx="3">
+            <a:schemeClr val="accent1"/>
+          </a:fillRef>
+          <a:effectRef idx="2">
+            <a:schemeClr val="accent1"/>
+          </a:effectRef>
+          <a:fontRef idx="minor">
+            <a:schemeClr val="lt1"/>
+          </a:fontRef>
+        </p:style>
+        <p:txBody>
+          <a:bodyPr rtlCol="0" anchor="ctr" wrap="square" lIns="45720" rIns="45720"/>
+          <a:lstStyle/>
+          <a:p>
+            <a:pPr algn="ctr">
+              <a:spcAft>
+                <a:spcPts val="700"/>
+              </a:spcAft>
+            </a:pPr>
+            <a:r>
+              <a:rPr sz="1300" b="1">
+                <a:solidFill>
+                  <a:srgbClr val="FFFFFF"/>
+                </a:solidFill>
+                <a:latin typeface="Calibri"/>
+              </a:rPr>
+              <a:t>1</a:t>
+            </a:r>
+          </a:p>
+        </p:txBody>
+      </p:sp>
+      <p:sp>
+        <p:nvSpPr>
+          <p:cNvPr id="17" name="Rounded Rectangle 16"/>
+          <p:cNvSpPr/>
+          <p:nvPr/>
+        </p:nvSpPr>
+        <p:spPr>
+          <a:xfrm>
+            <a:off x="9518904" y="2944368"/>
+            <a:ext cx="457200" cy="457200"/>
+          </a:xfrm>
+          <a:prstGeom prst="roundRect">
+            <a:avLst/>
+          </a:prstGeom>
+          <a:solidFill>
+            <a:srgbClr val="1F4E79"/>
+          </a:solidFill>
+          <a:ln>
+            <a:solidFill>
+              <a:srgbClr val="1F4E79"/>
+            </a:solidFill>
+          </a:ln>
+        </p:spPr>
+        <p:style>
+          <a:lnRef idx="1">
+            <a:schemeClr val="accent1"/>
+          </a:lnRef>
+          <a:fillRef idx="3">
+            <a:schemeClr val="accent1"/>
+          </a:fillRef>
+          <a:effectRef idx="2">
+            <a:schemeClr val="accent1"/>
+          </a:effectRef>
+          <a:fontRef idx="minor">
+            <a:schemeClr val="lt1"/>
+          </a:fontRef>
+        </p:style>
+        <p:txBody>
+          <a:bodyPr rtlCol="0" anchor="ctr" wrap="square" lIns="45720" rIns="45720"/>
+          <a:lstStyle/>
+          <a:p>
+            <a:pPr algn="ctr">
+              <a:spcAft>
+                <a:spcPts val="700"/>
+              </a:spcAft>
+            </a:pPr>
+            <a:r>
+              <a:rPr sz="1300" b="1">
+                <a:solidFill>
+                  <a:srgbClr val="FFFFFF"/>
+                </a:solidFill>
+                <a:latin typeface="Calibri"/>
+              </a:rPr>
+              <a:t>1</a:t>
+            </a:r>
+          </a:p>
+        </p:txBody>
+      </p:sp>
+      <p:cxnSp>
+        <p:nvCxnSpPr>
+          <p:cNvPr id="18" name="Connector 17"/>
+          <p:cNvCxnSpPr/>
+          <p:nvPr/>
+        </p:nvCxnSpPr>
+        <p:spPr>
+          <a:xfrm>
+            <a:off x="10195560" y="3172968"/>
+            <a:ext cx="502920" cy="0"/>
+          </a:xfrm>
+          <a:prstGeom prst="line">
+            <a:avLst/>
+          </a:prstGeom>
+          <a:ln w="25400">
+            <a:solidFill>
+              <a:srgbClr val="5A5A5A"/>
+            </a:solidFill>
+          </a:ln>
+        </p:spPr>
+        <p:style>
+          <a:lnRef idx="2">
+            <a:schemeClr val="accent1"/>
+          </a:lnRef>
+          <a:fillRef idx="0">
+            <a:schemeClr val="accent1"/>
+          </a:fillRef>
+          <a:effectRef idx="1">
+            <a:schemeClr val="accent1"/>
+          </a:effectRef>
+          <a:fontRef idx="minor">
+            <a:schemeClr val="tx1"/>
+          </a:fontRef>
+        </p:style>
+      </p:cxnSp>
+      <p:sp>
+        <p:nvSpPr>
+          <p:cNvPr id="19" name="Rounded Rectangle 18"/>
+          <p:cNvSpPr/>
+          <p:nvPr/>
+        </p:nvSpPr>
+        <p:spPr>
+          <a:xfrm>
+            <a:off x="10744200" y="2898648"/>
+            <a:ext cx="1051560" cy="566928"/>
+          </a:xfrm>
+          <a:prstGeom prst="roundRect">
+            <a:avLst/>
+          </a:prstGeom>
+          <a:solidFill>
+            <a:srgbClr val="B32D2D"/>
+          </a:solidFill>
+          <a:ln>
+            <a:solidFill>
+              <a:srgbClr val="B32D2D"/>
+            </a:solidFill>
+          </a:ln>
+        </p:spPr>
+        <p:style>
+          <a:lnRef idx="1">
+            <a:schemeClr val="accent1"/>
+          </a:lnRef>
+          <a:fillRef idx="3">
+            <a:schemeClr val="accent1"/>
+          </a:fillRef>
+          <a:effectRef idx="2">
+            <a:schemeClr val="accent1"/>
+          </a:effectRef>
+          <a:fontRef idx="minor">
+            <a:schemeClr val="lt1"/>
+          </a:fontRef>
+        </p:style>
+        <p:txBody>
+          <a:bodyPr rtlCol="0" anchor="ctr" wrap="square" lIns="45720" rIns="45720"/>
+          <a:lstStyle/>
+          <a:p>
+            <a:pPr algn="ctr">
+              <a:spcAft>
+                <a:spcPts val="700"/>
+              </a:spcAft>
+            </a:pPr>
+            <a:r>
+              <a:rPr sz="900" b="1">
+                <a:solidFill>
+                  <a:srgbClr val="FFFFFF"/>
+                </a:solidFill>
+                <a:latin typeface="Calibri"/>
+              </a:rPr>
+              <a:t>A = 0,0,0,0
+zero gradient</a:t>
+            </a:r>
+          </a:p>
+        </p:txBody>
+      </p:sp>
+      <p:sp>
+        <p:nvSpPr>
+          <p:cNvPr id="20" name="TextBox 19"/>
+          <p:cNvSpPr txBox="1"/>
+          <p:nvPr/>
+        </p:nvSpPr>
+        <p:spPr>
+          <a:xfrm>
+            <a:off x="7818120" y="3657600"/>
+            <a:ext cx="3977639" cy="1005840"/>
+          </a:xfrm>
+          <a:prstGeom prst="rect">
+            <a:avLst/>
+          </a:prstGeom>
+          <a:noFill/>
+        </p:spPr>
+        <p:txBody>
+          <a:bodyPr wrap="none">
+            <a:spAutoFit/>
+          </a:bodyPr>
+          <a:lstStyle/>
+          <a:p>
+            <a:pPr algn="l">
+              <a:spcAft>
+                <a:spcPts val="700"/>
+              </a:spcAft>
+            </a:pPr>
+            <a:r>
+              <a:rPr sz="1050" b="0">
+                <a:solidFill>
+                  <a:srgbClr val="5A5A5A"/>
+                </a:solidFill>
+                <a:latin typeface="Calibri"/>
+              </a:rPr>
+              <a:t>A_i = r_i − mean(r): identical rewards zero every advantage.
+The reward curve still reads 1.0 — training has silently stopped.</a:t>
             </a:r>
           </a:p>
         </p:txBody>
@@ -6311,14 +7120,545 @@
       </p:sp>
       <p:sp>
         <p:nvSpPr>
-          <p:cNvPr id="4" name="TextBox 3"/>
+          <p:cNvPr id="4" name="Rounded Rectangle 3"/>
+          <p:cNvSpPr/>
+          <p:nvPr/>
+        </p:nvSpPr>
+        <p:spPr>
+          <a:xfrm>
+            <a:off x="822960" y="1234440"/>
+            <a:ext cx="5852160" cy="932688"/>
+          </a:xfrm>
+          <a:prstGeom prst="roundRect">
+            <a:avLst/>
+          </a:prstGeom>
+          <a:solidFill>
+            <a:srgbClr val="1F4E79"/>
+          </a:solidFill>
+          <a:ln>
+            <a:solidFill>
+              <a:srgbClr val="1F4E79"/>
+            </a:solidFill>
+          </a:ln>
+        </p:spPr>
+        <p:style>
+          <a:lnRef idx="1">
+            <a:schemeClr val="accent1"/>
+          </a:lnRef>
+          <a:fillRef idx="3">
+            <a:schemeClr val="accent1"/>
+          </a:fillRef>
+          <a:effectRef idx="2">
+            <a:schemeClr val="accent1"/>
+          </a:effectRef>
+          <a:fontRef idx="minor">
+            <a:schemeClr val="lt1"/>
+          </a:fontRef>
+        </p:style>
+        <p:txBody>
+          <a:bodyPr rtlCol="0" anchor="ctr" wrap="square" lIns="45720" rIns="45720"/>
+          <a:lstStyle/>
+          <a:p>
+            <a:pPr algn="ctr">
+              <a:spcAft>
+                <a:spcPts val="700"/>
+              </a:spcAft>
+            </a:pPr>
+            <a:r>
+              <a:rPr sz="1100" b="1">
+                <a:solidFill>
+                  <a:srgbClr val="FFFFFF"/>
+                </a:solidFill>
+                <a:latin typeface="Calibri"/>
+              </a:rPr>
+              <a:t>TRAINING — Tinker managed API
+LoRA rank-4 GRPO / Dr.GRPO fleets · full-state checkpoint · kill-and-resume (verified live)</a:t>
+            </a:r>
+          </a:p>
+        </p:txBody>
+      </p:sp>
+      <p:sp>
+        <p:nvSpPr>
+          <p:cNvPr id="5" name="Rounded Rectangle 4"/>
+          <p:cNvSpPr/>
+          <p:nvPr/>
+        </p:nvSpPr>
+        <p:spPr>
+          <a:xfrm>
+            <a:off x="822960" y="2350008"/>
+            <a:ext cx="5852160" cy="932688"/>
+          </a:xfrm>
+          <a:prstGeom prst="roundRect">
+            <a:avLst/>
+          </a:prstGeom>
+          <a:solidFill>
+            <a:srgbClr val="1F4E79"/>
+          </a:solidFill>
+          <a:ln>
+            <a:solidFill>
+              <a:srgbClr val="1F4E79"/>
+            </a:solidFill>
+          </a:ln>
+        </p:spPr>
+        <p:style>
+          <a:lnRef idx="1">
+            <a:schemeClr val="accent1"/>
+          </a:lnRef>
+          <a:fillRef idx="3">
+            <a:schemeClr val="accent1"/>
+          </a:fillRef>
+          <a:effectRef idx="2">
+            <a:schemeClr val="accent1"/>
+          </a:effectRef>
+          <a:fontRef idx="minor">
+            <a:schemeClr val="lt1"/>
+          </a:fontRef>
+        </p:style>
+        <p:txBody>
+          <a:bodyPr rtlCol="0" anchor="ctr" wrap="square" lIns="45720" rIns="45720"/>
+          <a:lstStyle/>
+          <a:p>
+            <a:pPr algn="ctr">
+              <a:spcAft>
+                <a:spcPts val="700"/>
+              </a:spcAft>
+            </a:pPr>
+            <a:r>
+              <a:rPr sz="1100" b="1">
+                <a:solidFill>
+                  <a:srgbClr val="FFFFFF"/>
+                </a:solidFill>
+                <a:latin typeface="Calibri"/>
+              </a:rPr>
+              <a:t>TELEMETRY — per-step (reward, ZVF, GU)
+logged beside every reward point · parser v2 with false-positive audit</a:t>
+            </a:r>
+          </a:p>
+        </p:txBody>
+      </p:sp>
+      <p:sp>
+        <p:nvSpPr>
+          <p:cNvPr id="6" name="Rounded Rectangle 5"/>
+          <p:cNvSpPr/>
+          <p:nvPr/>
+        </p:nvSpPr>
+        <p:spPr>
+          <a:xfrm>
+            <a:off x="822960" y="3465576"/>
+            <a:ext cx="5852160" cy="932688"/>
+          </a:xfrm>
+          <a:prstGeom prst="roundRect">
+            <a:avLst/>
+          </a:prstGeom>
+          <a:solidFill>
+            <a:srgbClr val="1F4E79"/>
+          </a:solidFill>
+          <a:ln>
+            <a:solidFill>
+              <a:srgbClr val="1F4E79"/>
+            </a:solidFill>
+          </a:ln>
+        </p:spPr>
+        <p:style>
+          <a:lnRef idx="1">
+            <a:schemeClr val="accent1"/>
+          </a:lnRef>
+          <a:fillRef idx="3">
+            <a:schemeClr val="accent1"/>
+          </a:fillRef>
+          <a:effectRef idx="2">
+            <a:schemeClr val="accent1"/>
+          </a:effectRef>
+          <a:fontRef idx="minor">
+            <a:schemeClr val="lt1"/>
+          </a:fontRef>
+        </p:style>
+        <p:txBody>
+          <a:bodyPr rtlCol="0" anchor="ctr" wrap="square" lIns="45720" rIns="45720"/>
+          <a:lstStyle/>
+          <a:p>
+            <a:pPr algn="ctr">
+              <a:spcAft>
+                <a:spcPts val="700"/>
+              </a:spcAft>
+            </a:pPr>
+            <a:r>
+              <a:rPr sz="1100" b="1">
+                <a:solidFill>
+                  <a:srgbClr val="FFFFFF"/>
+                </a:solidFill>
+                <a:latin typeface="Calibri"/>
+              </a:rPr>
+              <a:t>EVALUATION — vLLM pass@k harness
+Modal · Lightning AI · Colab — three independent backends · clustered bootstrap CIs</a:t>
+            </a:r>
+          </a:p>
+        </p:txBody>
+      </p:sp>
+      <p:sp>
+        <p:nvSpPr>
+          <p:cNvPr id="7" name="Rounded Rectangle 6"/>
+          <p:cNvSpPr/>
+          <p:nvPr/>
+        </p:nvSpPr>
+        <p:spPr>
+          <a:xfrm>
+            <a:off x="822960" y="4581144"/>
+            <a:ext cx="5852160" cy="932688"/>
+          </a:xfrm>
+          <a:prstGeom prst="roundRect">
+            <a:avLst/>
+          </a:prstGeom>
+          <a:solidFill>
+            <a:srgbClr val="1F4E79"/>
+          </a:solidFill>
+          <a:ln>
+            <a:solidFill>
+              <a:srgbClr val="1F4E79"/>
+            </a:solidFill>
+          </a:ln>
+        </p:spPr>
+        <p:style>
+          <a:lnRef idx="1">
+            <a:schemeClr val="accent1"/>
+          </a:lnRef>
+          <a:fillRef idx="3">
+            <a:schemeClr val="accent1"/>
+          </a:fillRef>
+          <a:effectRef idx="2">
+            <a:schemeClr val="accent1"/>
+          </a:effectRef>
+          <a:fontRef idx="minor">
+            <a:schemeClr val="lt1"/>
+          </a:fontRef>
+        </p:style>
+        <p:txBody>
+          <a:bodyPr rtlCol="0" anchor="ctr" wrap="square" lIns="45720" rIns="45720"/>
+          <a:lstStyle/>
+          <a:p>
+            <a:pPr algn="ctr">
+              <a:spcAft>
+                <a:spcPts val="700"/>
+              </a:spcAft>
+            </a:pPr>
+            <a:r>
+              <a:rPr sz="1100" b="1">
+                <a:solidFill>
+                  <a:srgbClr val="FFFFFF"/>
+                </a:solidFill>
+                <a:latin typeface="Calibri"/>
+              </a:rPr>
+              <a:t>AUDIT TRAIL — 983 runs enumerated &amp; classified
+19 claim-critical runs linked: W&amp;B page + checkpoint + result JSON</a:t>
+            </a:r>
+          </a:p>
+        </p:txBody>
+      </p:sp>
+      <p:cxnSp>
+        <p:nvCxnSpPr>
+          <p:cNvPr id="8" name="Connector 7"/>
+          <p:cNvCxnSpPr/>
+          <p:nvPr/>
+        </p:nvCxnSpPr>
+        <p:spPr>
+          <a:xfrm>
+            <a:off x="3749040" y="2167128"/>
+            <a:ext cx="0" cy="182880"/>
+          </a:xfrm>
+          <a:prstGeom prst="line">
+            <a:avLst/>
+          </a:prstGeom>
+          <a:ln w="25400">
+            <a:solidFill>
+              <a:srgbClr val="5A5A5A"/>
+            </a:solidFill>
+          </a:ln>
+        </p:spPr>
+        <p:style>
+          <a:lnRef idx="2">
+            <a:schemeClr val="accent1"/>
+          </a:lnRef>
+          <a:fillRef idx="0">
+            <a:schemeClr val="accent1"/>
+          </a:fillRef>
+          <a:effectRef idx="1">
+            <a:schemeClr val="accent1"/>
+          </a:effectRef>
+          <a:fontRef idx="minor">
+            <a:schemeClr val="tx1"/>
+          </a:fontRef>
+        </p:style>
+      </p:cxnSp>
+      <p:cxnSp>
+        <p:nvCxnSpPr>
+          <p:cNvPr id="9" name="Connector 8"/>
+          <p:cNvCxnSpPr/>
+          <p:nvPr/>
+        </p:nvCxnSpPr>
+        <p:spPr>
+          <a:xfrm>
+            <a:off x="3749040" y="3282696"/>
+            <a:ext cx="0" cy="182880"/>
+          </a:xfrm>
+          <a:prstGeom prst="line">
+            <a:avLst/>
+          </a:prstGeom>
+          <a:ln w="25400">
+            <a:solidFill>
+              <a:srgbClr val="5A5A5A"/>
+            </a:solidFill>
+          </a:ln>
+        </p:spPr>
+        <p:style>
+          <a:lnRef idx="2">
+            <a:schemeClr val="accent1"/>
+          </a:lnRef>
+          <a:fillRef idx="0">
+            <a:schemeClr val="accent1"/>
+          </a:fillRef>
+          <a:effectRef idx="1">
+            <a:schemeClr val="accent1"/>
+          </a:effectRef>
+          <a:fontRef idx="minor">
+            <a:schemeClr val="tx1"/>
+          </a:fontRef>
+        </p:style>
+      </p:cxnSp>
+      <p:cxnSp>
+        <p:nvCxnSpPr>
+          <p:cNvPr id="10" name="Connector 9"/>
+          <p:cNvCxnSpPr/>
+          <p:nvPr/>
+        </p:nvCxnSpPr>
+        <p:spPr>
+          <a:xfrm>
+            <a:off x="3749040" y="4398264"/>
+            <a:ext cx="0" cy="182880"/>
+          </a:xfrm>
+          <a:prstGeom prst="line">
+            <a:avLst/>
+          </a:prstGeom>
+          <a:ln w="25400">
+            <a:solidFill>
+              <a:srgbClr val="5A5A5A"/>
+            </a:solidFill>
+          </a:ln>
+        </p:spPr>
+        <p:style>
+          <a:lnRef idx="2">
+            <a:schemeClr val="accent1"/>
+          </a:lnRef>
+          <a:fillRef idx="0">
+            <a:schemeClr val="accent1"/>
+          </a:fillRef>
+          <a:effectRef idx="1">
+            <a:schemeClr val="accent1"/>
+          </a:effectRef>
+          <a:fontRef idx="minor">
+            <a:schemeClr val="tx1"/>
+          </a:fontRef>
+        </p:style>
+      </p:cxnSp>
+      <p:sp>
+        <p:nvSpPr>
+          <p:cNvPr id="11" name="Rounded Rectangle 10"/>
+          <p:cNvSpPr/>
+          <p:nvPr/>
+        </p:nvSpPr>
+        <p:spPr>
+          <a:xfrm>
+            <a:off x="7406640" y="1737360"/>
+            <a:ext cx="4206240" cy="1143000"/>
+          </a:xfrm>
+          <a:prstGeom prst="roundRect">
+            <a:avLst/>
+          </a:prstGeom>
+          <a:solidFill>
+            <a:srgbClr val="2E7D32"/>
+          </a:solidFill>
+          <a:ln>
+            <a:solidFill>
+              <a:srgbClr val="2E7D32"/>
+            </a:solidFill>
+          </a:ln>
+        </p:spPr>
+        <p:style>
+          <a:lnRef idx="1">
+            <a:schemeClr val="accent1"/>
+          </a:lnRef>
+          <a:fillRef idx="3">
+            <a:schemeClr val="accent1"/>
+          </a:fillRef>
+          <a:effectRef idx="2">
+            <a:schemeClr val="accent1"/>
+          </a:effectRef>
+          <a:fontRef idx="minor">
+            <a:schemeClr val="lt1"/>
+          </a:fontRef>
+        </p:style>
+        <p:txBody>
+          <a:bodyPr rtlCol="0" anchor="ctr" wrap="square" lIns="45720" rIns="45720"/>
+          <a:lstStyle/>
+          <a:p>
+            <a:pPr algn="ctr">
+              <a:spcAft>
+                <a:spcPts val="700"/>
+              </a:spcAft>
+            </a:pPr>
+            <a:r>
+              <a:rPr sz="1050" b="1">
+                <a:solidFill>
+                  <a:srgbClr val="FFFFFF"/>
+                </a:solidFill>
+                <a:latin typeface="Calibri"/>
+              </a:rPr>
+              <a:t>zvf-triage (Apache-2.0, 82 tests)
+regime classifier · adaptive-G · dead-prompt drop · auto-stop
+veRL / OpenRLHF / NeMo-RL adapters</a:t>
+            </a:r>
+          </a:p>
+        </p:txBody>
+      </p:sp>
+      <p:sp>
+        <p:nvSpPr>
+          <p:cNvPr id="12" name="Rounded Rectangle 11"/>
+          <p:cNvSpPr/>
+          <p:nvPr/>
+        </p:nvSpPr>
+        <p:spPr>
+          <a:xfrm>
+            <a:off x="7406640" y="3383280"/>
+            <a:ext cx="4206240" cy="1051560"/>
+          </a:xfrm>
+          <a:prstGeom prst="roundRect">
+            <a:avLst/>
+          </a:prstGeom>
+          <a:solidFill>
+            <a:srgbClr val="5A5A5A"/>
+          </a:solidFill>
+          <a:ln>
+            <a:solidFill>
+              <a:srgbClr val="5A5A5A"/>
+            </a:solidFill>
+          </a:ln>
+        </p:spPr>
+        <p:style>
+          <a:lnRef idx="1">
+            <a:schemeClr val="accent1"/>
+          </a:lnRef>
+          <a:fillRef idx="3">
+            <a:schemeClr val="accent1"/>
+          </a:fillRef>
+          <a:effectRef idx="2">
+            <a:schemeClr val="accent1"/>
+          </a:effectRef>
+          <a:fontRef idx="minor">
+            <a:schemeClr val="lt1"/>
+          </a:fontRef>
+        </p:style>
+        <p:txBody>
+          <a:bodyPr rtlCol="0" anchor="ctr" wrap="square" lIns="45720" rIns="45720"/>
+          <a:lstStyle/>
+          <a:p>
+            <a:pPr algn="ctr">
+              <a:spcAft>
+                <a:spcPts val="700"/>
+              </a:spcAft>
+            </a:pPr>
+            <a:r>
+              <a:rPr sz="1050" b="1">
+                <a:solidFill>
+                  <a:srgbClr val="FFFFFF"/>
+                </a:solidFill>
+                <a:latin typeface="Calibri"/>
+              </a:rPr>
+              <a:t>MIRRORS &amp; ARTIFACTS
+W&amp;B: 1,034 runs / 17 projects
+HuggingFace: 49 adapter repos</a:t>
+            </a:r>
+          </a:p>
+        </p:txBody>
+      </p:sp>
+      <p:cxnSp>
+        <p:nvCxnSpPr>
+          <p:cNvPr id="13" name="Connector 12"/>
+          <p:cNvCxnSpPr/>
+          <p:nvPr/>
+        </p:nvCxnSpPr>
+        <p:spPr>
+          <a:xfrm flipV="1">
+            <a:off x="6675120" y="2304288"/>
+            <a:ext cx="731520" cy="512064"/>
+          </a:xfrm>
+          <a:prstGeom prst="line">
+            <a:avLst/>
+          </a:prstGeom>
+          <a:ln w="25400">
+            <a:solidFill>
+              <a:srgbClr val="5A5A5A"/>
+            </a:solidFill>
+          </a:ln>
+        </p:spPr>
+        <p:style>
+          <a:lnRef idx="2">
+            <a:schemeClr val="accent1"/>
+          </a:lnRef>
+          <a:fillRef idx="0">
+            <a:schemeClr val="accent1"/>
+          </a:fillRef>
+          <a:effectRef idx="1">
+            <a:schemeClr val="accent1"/>
+          </a:effectRef>
+          <a:fontRef idx="minor">
+            <a:schemeClr val="tx1"/>
+          </a:fontRef>
+        </p:style>
+      </p:cxnSp>
+      <p:cxnSp>
+        <p:nvCxnSpPr>
+          <p:cNvPr id="14" name="Connector 13"/>
+          <p:cNvCxnSpPr/>
+          <p:nvPr/>
+        </p:nvCxnSpPr>
+        <p:spPr>
+          <a:xfrm flipV="1">
+            <a:off x="6675120" y="3904488"/>
+            <a:ext cx="731520" cy="27432"/>
+          </a:xfrm>
+          <a:prstGeom prst="line">
+            <a:avLst/>
+          </a:prstGeom>
+          <a:ln w="25400">
+            <a:solidFill>
+              <a:srgbClr val="5A5A5A"/>
+            </a:solidFill>
+          </a:ln>
+        </p:spPr>
+        <p:style>
+          <a:lnRef idx="2">
+            <a:schemeClr val="accent1"/>
+          </a:lnRef>
+          <a:fillRef idx="0">
+            <a:schemeClr val="accent1"/>
+          </a:fillRef>
+          <a:effectRef idx="1">
+            <a:schemeClr val="accent1"/>
+          </a:effectRef>
+          <a:fontRef idx="minor">
+            <a:schemeClr val="tx1"/>
+          </a:fontRef>
+        </p:style>
+      </p:cxnSp>
+      <p:sp>
+        <p:nvSpPr>
+          <p:cNvPr id="15" name="TextBox 14"/>
           <p:cNvSpPr txBox="1"/>
           <p:nvPr/>
         </p:nvSpPr>
         <p:spPr>
           <a:xfrm>
-            <a:off x="731520" y="1143000"/>
-            <a:ext cx="10789920" cy="5212080"/>
+            <a:off x="822960" y="5806440"/>
+            <a:ext cx="10881360" cy="640080"/>
           </a:xfrm>
           <a:prstGeom prst="rect">
             <a:avLst/>
@@ -6326,7 +7666,7 @@
           <a:noFill/>
         </p:spPr>
         <p:txBody>
-          <a:bodyPr wrap="square">
+          <a:bodyPr wrap="none">
             <a:spAutoFit/>
           </a:bodyPr>
           <a:lstStyle/>
@@ -6337,77 +7677,13 @@
               </a:spcAft>
             </a:pPr>
             <a:r>
-              <a:rPr sz="1500" b="1">
-                <a:solidFill>
-                  <a:srgbClr val="212121"/>
-                </a:solidFill>
-                <a:latin typeface="Calibri"/>
-              </a:rPr>
-              <a:t>•  Training layer — Tinker managed API: LoRA rank-4 GRPO/Dr.GRPO fleets with full state checkpointing and kill-and-resume (built after two mid-programme credit exhaustions; verified live).</a:t>
-            </a:r>
-          </a:p>
-          <a:p>
-            <a:pPr algn="l">
-              <a:spcAft>
-                <a:spcPts val="700"/>
-              </a:spcAft>
-            </a:pPr>
-            <a:r>
-              <a:rPr sz="1500" b="0">
-                <a:solidFill>
-                  <a:srgbClr val="212121"/>
-                </a:solidFill>
-                <a:latin typeface="Calibri"/>
-              </a:rPr>
-              <a:t>•  Evaluation layer — vLLM pass@k harness on three independent backends: Modal, Lightning AI, Colab; problem-clustered bootstrap CIs; seeded per problem.</a:t>
-            </a:r>
-          </a:p>
-          <a:p>
-            <a:pPr algn="l">
-              <a:spcAft>
-                <a:spcPts val="700"/>
-              </a:spcAft>
-            </a:pPr>
-            <a:r>
-              <a:rPr sz="1500" b="1">
-                <a:solidFill>
-                  <a:srgbClr val="212121"/>
-                </a:solidFill>
-                <a:latin typeface="Calibri"/>
-              </a:rPr>
-              <a:t>•  Telemetry layer — per-step (reward, ZVF, GU) traces for every training run, mirrored to W&amp;B (zvf-training project); reward-parser v2 with false-positive audit.</a:t>
-            </a:r>
-          </a:p>
-          <a:p>
-            <a:pPr algn="l">
-              <a:spcAft>
-                <a:spcPts val="700"/>
-              </a:spcAft>
-            </a:pPr>
-            <a:r>
-              <a:rPr sz="1500" b="0">
-                <a:solidFill>
-                  <a:srgbClr val="212121"/>
-                </a:solidFill>
-                <a:latin typeface="Calibri"/>
-              </a:rPr>
-              <a:t>•  Library — zvf-triage (Apache-2.0, 82 tests): drop-in triage callback — classifies starvation regime, adapts G, drops dead prompts, auto-stops doomed runs; veRL / OpenRLHF / NeMo-RL adapters.</a:t>
-            </a:r>
-          </a:p>
-          <a:p>
-            <a:pPr algn="l">
-              <a:spcAft>
-                <a:spcPts val="700"/>
-              </a:spcAft>
-            </a:pPr>
-            <a:r>
-              <a:rPr sz="1500" b="0">
-                <a:solidFill>
-                  <a:srgbClr val="212121"/>
-                </a:solidFill>
-                <a:latin typeface="Calibri"/>
-              </a:rPr>
-              <a:t>•  Audit layer — 983 Tinker runs enumerated and classified; 19 claim-critical runs identified, each linked to its W&amp;B page, checkpoint, and result JSON (workbook in outputs/).</a:t>
+              <a:rPr sz="1200" b="0">
+                <a:solidFill>
+                  <a:srgbClr val="5A5A5A"/>
+                </a:solidFill>
+                <a:latin typeface="Calibri"/>
+              </a:rPr>
+              <a:t>Design rule: no number enters a paper without a path back through this stack — run → telemetry → artifact → audit row.</a:t>
             </a:r>
           </a:p>
         </p:txBody>
@@ -7654,8 +8930,8 @@
         </p:nvSpPr>
         <p:spPr>
           <a:xfrm>
-            <a:off x="731520" y="2880360"/>
-            <a:ext cx="10789920" cy="5212080"/>
+            <a:off x="731520" y="3017520"/>
+            <a:ext cx="6583680" cy="5212080"/>
           </a:xfrm>
           <a:prstGeom prst="rect">
             <a:avLst/>
@@ -7674,7 +8950,7 @@
               </a:spcAft>
             </a:pPr>
             <a:r>
-              <a:rPr sz="1500" b="1">
+              <a:rPr sz="1300" b="1">
                 <a:solidFill>
                   <a:srgbClr val="212121"/>
                 </a:solidFill>
@@ -7690,13 +8966,13 @@
               </a:spcAft>
             </a:pPr>
             <a:r>
-              <a:rPr sz="1500" b="0">
+              <a:rPr sz="1300" b="0">
                 <a:solidFill>
                   <a:srgbClr val="212121"/>
                 </a:solidFill>
                 <a:latin typeface="Calibri"/>
               </a:rPr>
-              <a:t>•  ZVF is a diagnostic, not a predictor: in every collapse we measured, ZVF rose AFTER the reward plateau — a cheap alarm, not a cause. Pooled cross-task correlations do not survive stratification and are never used as claims.</a:t>
+              <a:t>•  ZVF is a diagnostic, not a predictor: ZVF rose AFTER the reward plateau in every measured collapse — a cheap alarm, not a cause.</a:t>
             </a:r>
           </a:p>
           <a:p>
@@ -7706,17 +8982,41 @@
               </a:spcAft>
             </a:pPr>
             <a:r>
-              <a:rPr sz="1500" b="0">
+              <a:rPr sz="1300" b="0">
                 <a:solidFill>
                   <a:srgbClr val="212121"/>
                 </a:solidFill>
                 <a:latin typeface="Calibri"/>
               </a:rPr>
-              <a:t>•  Population form is the U-shaped kernel h_G(p)=p^G+(1−p)^G: starvation at both walls (too hard / mastered); larger G narrows both.</a:t>
-            </a:r>
-          </a:p>
-        </p:txBody>
-      </p:sp>
+              <a:t>•  Population form: the U-shaped kernel — starvation at both walls (too hard / mastered); larger G narrows both.</a:t>
+            </a:r>
+          </a:p>
+        </p:txBody>
+      </p:sp>
+      <p:pic>
+        <p:nvPicPr>
+          <p:cNvPr id="6" name="Picture 5" descr="ushape.png"/>
+          <p:cNvPicPr>
+            <a:picLocks noChangeAspect="1"/>
+          </p:cNvPicPr>
+          <p:nvPr/>
+        </p:nvPicPr>
+        <p:blipFill>
+          <a:blip r:embed="rId3"/>
+          <a:stretch>
+            <a:fillRect/>
+          </a:stretch>
+        </p:blipFill>
+        <p:spPr>
+          <a:xfrm>
+            <a:off x="7589520" y="3017520"/>
+            <a:ext cx="4114800" cy="2453054"/>
+          </a:xfrm>
+          <a:prstGeom prst="rect">
+            <a:avLst/>
+          </a:prstGeom>
+        </p:spPr>
+      </p:pic>
     </p:spTree>
   </p:cSld>
   <p:clrMapOvr>
@@ -7822,7 +9122,7 @@
         <p:spPr>
           <a:xfrm>
             <a:off x="731520" y="1143000"/>
-            <a:ext cx="10789920" cy="5212080"/>
+            <a:ext cx="6583680" cy="5212080"/>
           </a:xfrm>
           <a:prstGeom prst="rect">
             <a:avLst/>
@@ -7841,7 +9141,7 @@
               </a:spcAft>
             </a:pPr>
             <a:r>
-              <a:rPr sz="1500" b="1">
+              <a:rPr sz="1300" b="1">
                 <a:solidFill>
                   <a:srgbClr val="212121"/>
                 </a:solidFill>
@@ -7857,7 +9157,7 @@
               </a:spcAft>
             </a:pPr>
             <a:r>
-              <a:rPr sz="1500" b="1">
+              <a:rPr sz="1300" b="1">
                 <a:solidFill>
                   <a:srgbClr val="212121"/>
                 </a:solidFill>
@@ -7873,13 +9173,13 @@
               </a:spcAft>
             </a:pPr>
             <a:r>
-              <a:rPr sz="1500" b="1">
+              <a:rPr sz="1300" b="1">
                 <a:solidFill>
                   <a:srgbClr val="212121"/>
                 </a:solidFill>
                 <a:latin typeface="Calibri"/>
               </a:rPr>
-              <a:t>•  Interpretation: small G buys early optimiser steps and starves the endgame; large G holds signal throughout. Group size selects which end of training starves — it is a schedule variable.</a:t>
+              <a:t>•  Interpretation: small G buys early steps and starves the endgame; large G holds signal throughout. Group size selects WHICH END of training starves — a schedule variable.</a:t>
             </a:r>
           </a:p>
           <a:p>
@@ -7889,17 +9189,41 @@
               </a:spcAft>
             </a:pPr>
             <a:r>
-              <a:rPr sz="1500" b="0">
+              <a:rPr sz="1300" b="0">
                 <a:solidFill>
                   <a:srgbClr val="212121"/>
                 </a:solidFill>
                 <a:latin typeface="Calibri"/>
               </a:rPr>
-              <a:t>•  Honesty check: static fixed-step sweeps are non-monotone and confounded by what the budget is held in; the controller that would exploit this is designed but its efficacy is NOT claimed (pre-registered test is future work).</a:t>
-            </a:r>
-          </a:p>
-        </p:txBody>
-      </p:sp>
+              <a:t>•  Honesty check: static fixed-step sweeps are confounded by what the budget is held in; controller efficacy is NOT claimed (pre-registered test is future work).</a:t>
+            </a:r>
+          </a:p>
+        </p:txBody>
+      </p:sp>
+      <p:pic>
+        <p:nvPicPr>
+          <p:cNvPr id="5" name="Picture 4" descr="budget_traj.png"/>
+          <p:cNvPicPr>
+            <a:picLocks noChangeAspect="1"/>
+          </p:cNvPicPr>
+          <p:nvPr/>
+        </p:nvPicPr>
+        <p:blipFill>
+          <a:blip r:embed="rId3"/>
+          <a:stretch>
+            <a:fillRect/>
+          </a:stretch>
+        </p:blipFill>
+        <p:spPr>
+          <a:xfrm>
+            <a:off x="7543800" y="1463040"/>
+            <a:ext cx="4206240" cy="2507566"/>
+          </a:xfrm>
+          <a:prstGeom prst="rect">
+            <a:avLst/>
+          </a:prstGeom>
+        </p:spPr>
+      </p:pic>
     </p:spTree>
   </p:cSld>
   <p:clrMapOvr>

</xml_diff>

<commit_message>
feat(deck): embed the runs-audit workbook as a double-clickable OLE object on slide 13
add_ole_object(PROG_ID.XLSX) embeds the full 180KB
tinker_runs_audit_2026-07-12.xlsx inside the pptx (Excel icon +
caption); double-click opens it in Excel during the defense. The
embedded copy is re-snapshotted from outputs/ on every deck rebuild.
</commit_message>
<xml_diff>
--- a/outputs/PESU_MTech_Phase1_Session1_Review_ArvindCR.pptx
+++ b/outputs/PESU_MTech_Phase1_Session1_Review_ArvindCR.pptx
@@ -5349,7 +5349,7 @@
               </a:spcAft>
             </a:pPr>
             <a:r>
-              <a:rPr sz="1500" b="1">
+              <a:rPr sz="1400" b="1">
                 <a:solidFill>
                   <a:srgbClr val="212121"/>
                 </a:solidFill>
@@ -5365,7 +5365,7 @@
               </a:spcAft>
             </a:pPr>
             <a:r>
-              <a:rPr sz="1500" b="0">
+              <a:rPr sz="1400" b="0">
                 <a:solidFill>
                   <a:srgbClr val="212121"/>
                 </a:solidFill>
@@ -5381,7 +5381,7 @@
               </a:spcAft>
             </a:pPr>
             <a:r>
-              <a:rPr sz="1500" b="0">
+              <a:rPr sz="1400" b="0">
                 <a:solidFill>
                   <a:srgbClr val="212121"/>
                 </a:solidFill>
@@ -5397,13 +5397,94 @@
               </a:spcAft>
             </a:pPr>
             <a:r>
-              <a:rPr sz="1500" b="1">
+              <a:rPr sz="1400" b="1">
                 <a:solidFill>
                   <a:srgbClr val="212121"/>
                 </a:solidFill>
                 <a:latin typeface="Calibri"/>
               </a:rPr>
-              <a:t>•  Traceability: 19 claim-critical runs highlighted in the audit workbook, each with W&amp;B link + checkpoint + result artifact (outputs/tinker_runs_audit_2026-07-12.xlsx).</a:t>
+              <a:t>•  Traceability: 19 claim-critical runs highlighted in the audit workbook, each with W&amp;B link + checkpoint + result artifact — embedded below (double-click to open).</a:t>
+            </a:r>
+          </a:p>
+        </p:txBody>
+      </p:sp>
+      <p:graphicFrame>
+        <p:nvGraphicFramePr>
+          <p:cNvPr id="5" name="Object 4"/>
+          <p:cNvGraphicFramePr>
+            <a:graphicFrameLocks noGrp="1"/>
+          </p:cNvGraphicFramePr>
+          <p:nvPr/>
+        </p:nvGraphicFramePr>
+        <p:xfrm>
+          <a:off x="868680" y="4709160"/>
+          <a:ext cx="965200" cy="609600"/>
+        </p:xfrm>
+        <a:graphic>
+          <a:graphicData uri="http://schemas.openxmlformats.org/presentationml/2006/ole">
+            <p:oleObj showAsIcon="1" r:id="rId3" imgW="777240" imgH="868680" progId="Excel.Sheet.12">
+              <p:embed/>
+              <p:pic>
+                <p:nvPicPr>
+                  <p:cNvPr id="0" name=""/>
+                  <p:cNvPicPr/>
+                  <p:nvPr/>
+                </p:nvPicPr>
+                <p:blipFill>
+                  <a:blip r:embed="rId4"/>
+                  <a:stretch>
+                    <a:fillRect/>
+                  </a:stretch>
+                </p:blipFill>
+                <p:spPr>
+                  <a:xfrm>
+                    <a:off x="868680" y="4709160"/>
+                    <a:ext cx="965200" cy="609600"/>
+                  </a:xfrm>
+                  <a:prstGeom prst="rect">
+                    <a:avLst/>
+                  </a:prstGeom>
+                </p:spPr>
+              </p:pic>
+            </p:oleObj>
+          </a:graphicData>
+        </a:graphic>
+      </p:graphicFrame>
+      <p:sp>
+        <p:nvSpPr>
+          <p:cNvPr id="6" name="TextBox 5"/>
+          <p:cNvSpPr txBox="1"/>
+          <p:nvPr/>
+        </p:nvSpPr>
+        <p:spPr>
+          <a:xfrm>
+            <a:off x="1783080" y="4846320"/>
+            <a:ext cx="9601200" cy="731520"/>
+          </a:xfrm>
+          <a:prstGeom prst="rect">
+            <a:avLst/>
+          </a:prstGeom>
+          <a:noFill/>
+        </p:spPr>
+        <p:txBody>
+          <a:bodyPr wrap="none">
+            <a:spAutoFit/>
+          </a:bodyPr>
+          <a:lstStyle/>
+          <a:p>
+            <a:pPr algn="l">
+              <a:spcAft>
+                <a:spcPts val="700"/>
+              </a:spcAft>
+            </a:pPr>
+            <a:r>
+              <a:rPr sz="1200" b="0">
+                <a:solidFill>
+                  <a:srgbClr val="5A5A5A"/>
+                </a:solidFill>
+                <a:latin typeface="Calibri"/>
+              </a:rPr>
+              <a:t>tinker_runs_audit_2026-07-12.xlsx — embedded copy (983 runs · key_runs · external_runs · wandb_runs · hf_artifacts · insights). Canonical file: outputs/ in the repo.</a:t>
             </a:r>
           </a:p>
         </p:txBody>

</xml_diff>

<commit_message>
feat(deck+xlsx): opening demo video embedded; platform column on every workbook row
Deck (now 17 slides, 4.0 MB):
- New opening slide: the 91s recorded live HuggingFace + W&B demo
  (project_defense_live_hf_wandb_demo_2026-07-12.mp4, h264 1600x900)
  embedded as a click-to-play movie with poster frame - plays with no
  network; speaker note says use it while people settle or skip to title.
- Embedded audit workbook re-snapshotted with the new platform columns.

Workbook: every data sheet now carries an explicit platform column -
runs/key_runs = Tinker (983 API runs); external_runs = Modal / Lightning
/ Colab / Vast.ai from backend; wandb_runs = per-project mapping
(modal-open-stack->Modal, zvf-colab-experiments->Colab, tinker*->Tinker,
zvf-experiments-next->mixed, zvf-audit->open stacks); hf_artifacts =
platform of origin (tool-call-lora->Colab capstone, rest->Tinker).
</commit_message>
<xml_diff>
--- a/outputs/PESU_MTech_Phase1_Session1_Review_ArvindCR.pptx
+++ b/outputs/PESU_MTech_Phase1_Session1_Review_ArvindCR.pptx
@@ -21,6 +21,7 @@
     <p:sldId id="269" r:id="rId21"/>
     <p:sldId id="270" r:id="rId22"/>
     <p:sldId id="271" r:id="rId23"/>
+    <p:sldId id="272" r:id="rId24"/>
   </p:sldIdLst>
   <p:sldSz cx="12191695" cy="6858000" type="screen4x3"/>
   <p:notesSz cx="6858000" cy="9144000"/>
@@ -517,7 +518,7 @@
           <a:lstStyle/>
           <a:p>
             <a:r>
-              <a:t>(1 min) Read the title, then decode it in one breath: GRPO trains on groups; when every completion in a group gets the same reward the group carries zero gradient — that is signal starvation; ZVF is the statistic that measures it; 'stack-conditioned' is the reproducibility finding that the same algorithm label gives different results on different software stacks. One measurement discipline, two claims, all artifacts audited.</a:t>
+              <a:t>(optional 90 s) Recorded live demo: HuggingFace adapter repos + W&amp;B zvf-training panel walkthrough, captured 12 Jul. Click to play. Use while people settle, or skip straight to the title if he wants to start immediately - the live demo slot is slide 14.</a:t>
             </a:r>
           </a:p>
         </p:txBody>
@@ -587,7 +588,7 @@
           <a:lstStyle/>
           <a:p>
             <a:r>
-              <a:t>(2 min) Tests the base-paper critique directly. Six uncapped arms (1,024 tokens), 3 seeds per loss: completion lengths SHRINK 6-12% in all six arms — no verbosity trap at this scale — and no late-ZVF separation. Then own the incident proudly: the first panel was invalid because a documented --loss flag was never wired to the loss; no output-level trace revealed it — only reading the runner did. We invalidated loudly, preserved artifacts under .invalid names, reran same-day, and one conclusion REVERSED. That incident is now a case study and the seed of the reporting standard.</a:t>
+              <a:t>(2 min) Three theory results, each validated on real 512-prompt pools. T1: Wilson interval covers 0.95-0.98 in every tested setting — report which ZVF the interval covers under curriculum ordering. T2: geometric waiting-time budget N = G ln(delta)/ln(ZVF) matched observed quantiles at ratio 1.00 in all six difficulty strata — hardest stratum needs 160 rollouts for a 90%-guaranteed informative group. T3 is the honest one: our signal-per-rollout objective turns out to have a UNIVERSAL argmax G* in {2,3} for every prior — an algebraic identity, found by external review of our own theory. We report it as a negative result.</a:t>
             </a:r>
           </a:p>
         </p:txBody>
@@ -657,7 +658,7 @@
           <a:lstStyle/>
           <a:p>
             <a:r>
-              <a:t>(1.5 min) Three measured instances, each a lever that flipped a result: 17x reward span from an undisclosed backend swap that also bundled a checkpoint change; the same 'DAPO' label yielding ZVF 0.00 on an open trainer vs 0.55-0.58 on a closed stack; and reward micro-jitter below the verifier's resolution collapsing batch ZVF 0.158 to 0. Every item of the 8-item MIN-REPORT-RL standard exists because one of these levers moved a result in OUR OWN data — not from taste.</a:t>
+              <a:t>(2 min) Tests the base-paper critique directly. Six uncapped arms (1,024 tokens), 3 seeds per loss: completion lengths SHRINK 6-12% in all six arms — no verbosity trap at this scale — and no late-ZVF separation. Then own the incident proudly: the first panel was invalid because a documented --loss flag was never wired to the loss; no output-level trace revealed it — only reading the runner did. We invalidated loudly, preserved artifacts under .invalid names, reran same-day, and one conclusion REVERSED. That incident is now a case study and the seed of the reporting standard.</a:t>
             </a:r>
           </a:p>
         </p:txBody>
@@ -727,7 +728,7 @@
           <a:lstStyle/>
           <a:p>
             <a:r>
-              <a:t>(1.5 min) RQ4. Base Qwen3-8B on GSM8K: pass@1 30.4% but pass@32 91% — the base model already solves almost everything at k=32, so GSM8K alone cannot demonstrate capability expansion; that scope discipline is itself a finding. Post-RL adapters: zero forgetting on MBPP and a +1.5-2.5 point pass@32 frontier improvement, within noise at single-seed — exactly why the standard mandates pass@k curves with CIs. MATH-500 partial: GSM8K-trained gains do NOT replicate on hard math — distribution sharpening, not capability expansion.</a:t>
+              <a:t>(1.5 min) Three measured instances, each a lever that flipped a result: 17x reward span from an undisclosed backend swap that also bundled a checkpoint change; the same 'DAPO' label yielding ZVF 0.00 on an open trainer vs 0.55-0.58 on a closed stack; and reward micro-jitter below the verifier's resolution collapsing batch ZVF 0.158 to 0. Every item of the 8-item MIN-REPORT-RL standard exists because one of these levers moved a result in OUR OWN data — not from taste.</a:t>
             </a:r>
           </a:p>
         </p:txBody>
@@ -797,7 +798,7 @@
           <a:lstStyle/>
           <a:p>
             <a:r>
-              <a:t>(1 min) Fast slide. 983 runs on the Tinker account — audited and classified this morning; the thesis claims rest on 19 identified claim-critical runs, each linked to W&amp;B and its artifact. If asked about any number: the workbook key_runs sheet has the run id, checkpoint, W&amp;B link, and result JSON.</a:t>
+              <a:t>(1.5 min) RQ4. Base Qwen3-8B on GSM8K: pass@1 30.4% but pass@32 91% — the base model already solves almost everything at k=32, so GSM8K alone cannot demonstrate capability expansion; that scope discipline is itself a finding. Post-RL adapters: zero forgetting on MBPP and a +1.5-2.5 point pass@32 frontier improvement, within noise at single-seed — exactly why the standard mandates pass@k curves with CIs. MATH-500 partial: GSM8K-trained gains do NOT replicate on hard math — distribution sharpening, not capability expansion.</a:t>
             </a:r>
           </a:p>
         </p:txBody>
@@ -867,7 +868,7 @@
           <a:lstStyle/>
           <a:p>
             <a:r>
-              <a:t>(1.5 min + live demo) Run the one-command offline demo FIRST — it cannot fail on the network. ./submission/demo/demo.sh: mechanism fixture (4 groups, ZVF=0.5, GU=0.5), recorded artifact (80 rewards, mean 0.6875, ZVF 0.30), SHA-256 integrity check, HTML dashboard. Then if time and connectivity allow: the W&amp;B zvf-training panel with live E-R2b curves, and the audit workbook key_runs sheet. Fallback: the 86-second recorded walkthrough. Verified PASS this morning.</a:t>
+              <a:t>(1 min) Fast slide. 983 runs on the Tinker account — audited and classified this morning; the thesis claims rest on 19 identified claim-critical runs, each linked to W&amp;B and its artifact. If asked about any number: the workbook key_runs sheet has the run id, checkpoint, W&amp;B link, and result JSON.</a:t>
             </a:r>
           </a:p>
         </p:txBody>
@@ -937,7 +938,7 @@
           <a:lstStyle/>
           <a:p>
             <a:r>
-              <a:t>(1 min) Close with the honesty that survives cross-examination: one model, one task family, one managed API, 1-3 seeds — the claims are stated at the stack level and nowhere above it. Roadmap is gated: diagnostic paper publishable now; controller paper gated on a pre-registered compute-matched win; survival audit gated on an open stack. Then stop talking and invite questions.</a:t>
+              <a:t>(1.5 min + live demo) Run the one-command offline demo FIRST — it cannot fail on the network. ./submission/demo/demo.sh: mechanism fixture (4 groups, ZVF=0.5, GU=0.5), recorded artifact (80 rewards, mean 0.6875, ZVF 0.30), SHA-256 integrity check, HTML dashboard. Then if time and connectivity allow: the W&amp;B zvf-training panel with live E-R2b curves, and the audit workbook key_runs sheet. Fallback: the 86-second recorded walkthrough. Verified PASS this morning.</a:t>
             </a:r>
           </a:p>
         </p:txBody>
@@ -1007,6 +1008,76 @@
           <a:lstStyle/>
           <a:p>
             <a:r>
+              <a:t>(1 min) Close with the honesty that survives cross-examination: one model, one task family, one managed API, 1-3 seeds — the claims are stated at the stack level and nowhere above it. Roadmap is gated: diagnostic paper publishable now; controller paper gated on a pre-registered compute-matched win; survival audit gated on an open stack. Then stop talking and invite questions.</a:t>
+            </a:r>
+          </a:p>
+        </p:txBody>
+      </p:sp>
+      <p:sp>
+        <p:nvSpPr>
+          <p:cNvPr id="4" name="Slide Number Placeholder 3"/>
+          <p:cNvSpPr>
+            <a:spLocks noGrp="1"/>
+          </p:cNvSpPr>
+          <p:nvPr>
+            <p:ph type="sldNum" idx="5" sz="quarter"/>
+          </p:nvPr>
+        </p:nvSpPr>
+        <p:spPr/>
+      </p:sp>
+    </p:spTree>
+  </p:cSld>
+  <p:clrMapOvr>
+    <a:masterClrMapping/>
+  </p:clrMapOvr>
+</p:notes>
+</file>
+
+<file path=ppt/notesSlides/notesSlide17.xml><?xml version="1.0" encoding="utf-8"?>
+<p:notes xmlns:a="http://schemas.openxmlformats.org/drawingml/2006/main" xmlns:p="http://schemas.openxmlformats.org/presentationml/2006/main" xmlns:r="http://schemas.openxmlformats.org/officeDocument/2006/relationships">
+  <p:cSld>
+    <p:spTree>
+      <p:nvGrpSpPr>
+        <p:cNvPr id="1" name=""/>
+        <p:cNvGrpSpPr/>
+        <p:nvPr/>
+      </p:nvGrpSpPr>
+      <p:grpSpPr>
+        <a:xfrm>
+          <a:off x="0" y="0"/>
+          <a:ext cx="0" cy="0"/>
+          <a:chOff x="0" y="0"/>
+          <a:chExt cx="0" cy="0"/>
+        </a:xfrm>
+      </p:grpSpPr>
+      <p:sp>
+        <p:nvSpPr>
+          <p:cNvPr id="2" name="Slide Image Placeholder 1"/>
+          <p:cNvSpPr>
+            <a:spLocks noGrp="1"/>
+          </p:cNvSpPr>
+          <p:nvPr>
+            <p:ph type="sldImg" idx="2"/>
+          </p:nvPr>
+        </p:nvSpPr>
+        <p:spPr/>
+      </p:sp>
+      <p:sp>
+        <p:nvSpPr>
+          <p:cNvPr id="3" name="Notes Placeholder 2"/>
+          <p:cNvSpPr>
+            <a:spLocks noGrp="1"/>
+          </p:cNvSpPr>
+          <p:nvPr>
+            <p:ph type="body" idx="3" sz="quarter"/>
+          </p:nvPr>
+        </p:nvSpPr>
+        <p:spPr/>
+        <p:txBody>
+          <a:bodyPr/>
+          <a:lstStyle/>
+          <a:p>
+            <a:r>
               <a:t>Thank the panel. Repo and email on screen. Offer the audit workbook or any W&amp;B run on request.</a:t>
             </a:r>
           </a:p>
@@ -1077,7 +1148,7 @@
           <a:lstStyle/>
           <a:p>
             <a:r>
-              <a:t>(2 min) Base paper: GRPO from DeepSeekMath (Shao et al., 2024), the algorithm behind DeepSeek-R1. Explain the mechanism from first principles: no critic; sample G completions per prompt; each advantage is its reward minus the group mean. My understanding goes one step further than the paper: that subtraction has a structural blind spot — identical rewards zero out every advantage. Secondary anchor: Dr.GRPO (Liu et al., 2025) which critiques GRPO's normalisation terms — my Result 4 tests it head-on.</a:t>
+              <a:t>(1 min) Read the title, then decode it in one breath: GRPO trains on groups; when every completion in a group gets the same reward the group carries zero gradient — that is signal starvation; ZVF is the statistic that measures it; 'stack-conditioned' is the reproducibility finding that the same algorithm label gives different results on different software stacks. One measurement discipline, two claims, all artifacts audited.</a:t>
             </a:r>
           </a:p>
         </p:txBody>
@@ -1147,7 +1218,7 @@
           <a:lstStyle/>
           <a:p>
             <a:r>
-              <a:t>(1 min) Compress. Two facts motivate everything: starvation is invisible in reward curves, and published comparisons are stack-conditioned. Then read the four RQs quickly.</a:t>
+              <a:t>(2 min) Base paper: GRPO from DeepSeekMath (Shao et al., 2024), the algorithm behind DeepSeek-R1. Explain the mechanism from first principles: no critic; sample G completions per prompt; each advantage is its reward minus the group mean. My understanding goes one step further than the paper: that subtraction has a structural blind spot — identical rewards zero out every advantage. Secondary anchor: Dr.GRPO (Liu et al., 2025) which critiques GRPO's normalisation terms — my Result 4 tests it head-on.</a:t>
             </a:r>
           </a:p>
         </p:txBody>
@@ -1217,7 +1288,7 @@
           <a:lstStyle/>
           <a:p>
             <a:r>
-              <a:t>(1.5 min) Walk the four layers left to right: training on the managed Tinker API (LoRA, closed loss kernel — an audit constraint I exploit deliberately); evaluation on three vLLM backends so no single backend's quirks own the numbers; telemetry: per-step ZVF/GU next to reward, mirrored to W&amp;B; and the audit layer: run manifests, checkpoint/resume, the runs-audit workbook. Everything downstream cites this.</a:t>
+              <a:t>(1 min) Compress. Two facts motivate everything: starvation is invisible in reward curves, and published comparisons are stack-conditioned. Then read the four RQs quickly.</a:t>
             </a:r>
           </a:p>
         </p:txBody>
@@ -1287,7 +1358,7 @@
           <a:lstStyle/>
           <a:p>
             <a:r>
-              <a:t>(1 min) Fast table walk — lead with the WHY column: each method answers a specific question the thesis needed closed. PPO answers 'was the critic needed?'; GSPO isolates one knob on the same stack; Dr.GRPO tests the base paper's strongest critique; DPO is the no-rollouts counterfactual (no groups, so no ZVF by construction); REINFORCE and SFT are floors; the DAPO audit and the AERO/AREAL/GIFT traces exist to measure how much a method LABEL underdetermines what actually ran. Every row has runnable artifacts.</a:t>
+              <a:t>(1.5 min) Walk the four layers left to right: training on the managed Tinker API (LoRA, closed loss kernel — an audit constraint I exploit deliberately); evaluation on three vLLM backends so no single backend's quirks own the numbers; telemetry: per-step ZVF/GU next to reward, mirrored to W&amp;B; and the audit layer: run manifests, checkpoint/resume, the runs-audit workbook. Everything downstream cites this.</a:t>
             </a:r>
           </a:p>
         </p:txBody>
@@ -1357,7 +1428,7 @@
           <a:lstStyle/>
           <a:p>
             <a:r>
-              <a:t>(1.5 min) Attribution first: Sem 3 was the group capstone — the multi-framework bench and survey, frozen at tag capstone-final-2026-04-25. Everything on this slide is Sem-4 solo work. Be specific: these are files and packages he can open, not concepts.</a:t>
+              <a:t>(1 min) Fast table walk — lead with the WHY column: each method answers a specific question the thesis needed closed. PPO answers 'was the critic needed?'; GSPO isolates one knob on the same stack; Dr.GRPO tests the base paper's strongest critique; DPO is the no-rollouts counterfactual (no groups, so no ZVF by construction); REINFORCE and SFT are floors; the DAPO audit and the AERO/AREAL/GIFT traces exist to measure how much a method LABEL underdetermines what actually ran. Every row has runnable artifacts.</a:t>
             </a:r>
           </a:p>
         </p:txBody>
@@ -1427,7 +1498,7 @@
           <a:lstStyle/>
           <a:p>
             <a:r>
-              <a:t>(2 min) THE core result. Walk the table: late in training the G=2 arms read reward ~1.0 — by the reward axis, perfect. ZVF says 75-100% of groups are all-correct: zero gradient. Same budget, G=16 arms are mid-learning with ZVF under 0.25 and signal intact. Read as a pair, (reward, ZVF) separates 'policy is good' from 'training is still moving'. ZVF alone aliases mastery with incapacity — always read the pair.</a:t>
+              <a:t>(1.5 min) Attribution first: Sem 3 was the group capstone — the multi-framework bench and survey, frozen at tag capstone-final-2026-04-25. Everything on this slide is Sem-4 solo work. Be specific: these are files and packages he can open, not concepts.</a:t>
             </a:r>
           </a:p>
         </p:txBody>
@@ -1497,7 +1568,7 @@
           <a:lstStyle/>
           <a:p>
             <a:r>
-              <a:t>(2 min) The decisive experiment design point: hold the ROLLOUT BUDGET fixed, not the step count. Small G converts the budget into more optimiser steps early — then exhausts its own signal as accuracy rises (the p-&gt;1 wall of the kernel). Large G pays for contrast it doesn't need early and retains signal late. So group size controls WHICH END of training starves — a schedule question, not a constant. The naive static sweep is confounded by what the budget is held in — I show both views.</a:t>
+              <a:t>(2 min) THE core result. Walk the table: late in training the G=2 arms read reward ~1.0 — by the reward axis, perfect. ZVF says 75-100% of groups are all-correct: zero gradient. Same budget, G=16 arms are mid-learning with ZVF under 0.25 and signal intact. Read as a pair, (reward, ZVF) separates 'policy is good' from 'training is still moving'. ZVF alone aliases mastery with incapacity — always read the pair.</a:t>
             </a:r>
           </a:p>
         </p:txBody>
@@ -1567,7 +1638,7 @@
           <a:lstStyle/>
           <a:p>
             <a:r>
-              <a:t>(2 min) Three theory results, each validated on real 512-prompt pools. T1: Wilson interval covers 0.95-0.98 in every tested setting — report which ZVF the interval covers under curriculum ordering. T2: geometric waiting-time budget N = G ln(delta)/ln(ZVF) matched observed quantiles at ratio 1.00 in all six difficulty strata — hardest stratum needs 160 rollouts for a 90%-guaranteed informative group. T3 is the honest one: our signal-per-rollout objective turns out to have a UNIVERSAL argmax G* in {2,3} for every prior — an algebraic identity, found by external review of our own theory. We report it as a negative result.</a:t>
+              <a:t>(2 min) The decisive experiment design point: hold the ROLLOUT BUDGET fixed, not the step count. Small G converts the budget into more optimiser steps early — then exhausts its own signal as accuracy rises (the p-&gt;1 wall of the kernel). Large G pays for contrast it doesn't need early and retains signal late. So group size controls WHICH END of training starves — a schedule question, not a constant. The naive static sweep is confounded by what the budget is held in — I show both views.</a:t>
             </a:r>
           </a:p>
         </p:txBody>
@@ -4581,8 +4652,8 @@
         </p:nvSpPr>
         <p:spPr>
           <a:xfrm>
-            <a:off x="914400" y="1554480"/>
-            <a:ext cx="10332720" cy="3840480"/>
+            <a:off x="548640" y="201168"/>
+            <a:ext cx="11064240" cy="548640"/>
           </a:xfrm>
           <a:prstGeom prst="rect">
             <a:avLst/>
@@ -4590,7 +4661,7 @@
           <a:noFill/>
         </p:spPr>
         <p:txBody>
-          <a:bodyPr wrap="square">
+          <a:bodyPr wrap="none">
             <a:spAutoFit/>
           </a:bodyPr>
           <a:lstStyle/>
@@ -4601,15 +4672,71 @@
               </a:spcAft>
             </a:pPr>
             <a:r>
-              <a:rPr sz="3000" b="1">
+              <a:rPr sz="2000" b="1">
                 <a:solidFill>
                   <a:srgbClr val="1F4E79"/>
                 </a:solidFill>
                 <a:latin typeface="Calibri"/>
               </a:rPr>
-              <a:t>M.Tech Project — Phase 1 Review (Defense Format)</a:t>
-            </a:r>
-          </a:p>
+              <a:t>Opening demo — live HuggingFace + W&amp;B walkthrough (recorded today, 91 s)</a:t>
+            </a:r>
+          </a:p>
+        </p:txBody>
+      </p:sp>
+      <p:pic>
+        <p:nvPicPr>
+          <p:cNvPr id="3" name="project_defense_live_hf_wandb_demo_2026-07-12.mp4">
+            <a:hlinkClick r:id="" action="ppaction://media"/>
+          </p:cNvPr>
+          <p:cNvPicPr>
+            <a:picLocks noChangeAspect="1"/>
+          </p:cNvPicPr>
+          <p:nvPr>
+            <a:videoFile r:link="rId4"/>
+            <p:extLst>
+              <p:ext uri="{DAA4B4D4-6D71-4841-9C94-3DE7FCFB9230}">
+                <p14:media xmlns:p14="http://schemas.microsoft.com/office/powerpoint/2010/main" r:embed="rId3"/>
+              </p:ext>
+            </p:extLst>
+          </p:nvPr>
+        </p:nvPicPr>
+        <p:blipFill>
+          <a:blip r:embed="rId5"/>
+          <a:stretch>
+            <a:fillRect/>
+          </a:stretch>
+        </p:blipFill>
+        <p:spPr>
+          <a:xfrm>
+            <a:off x="1435608" y="868680"/>
+            <a:ext cx="9326880" cy="5248656"/>
+          </a:xfrm>
+          <a:prstGeom prst="rect">
+            <a:avLst/>
+          </a:prstGeom>
+        </p:spPr>
+      </p:pic>
+      <p:sp>
+        <p:nvSpPr>
+          <p:cNvPr id="4" name="TextBox 3"/>
+          <p:cNvSpPr txBox="1"/>
+          <p:nvPr/>
+        </p:nvSpPr>
+        <p:spPr>
+          <a:xfrm>
+            <a:off x="548640" y="6263640"/>
+            <a:ext cx="11064240" cy="411480"/>
+          </a:xfrm>
+          <a:prstGeom prst="rect">
+            <a:avLst/>
+          </a:prstGeom>
+          <a:noFill/>
+        </p:spPr>
+        <p:txBody>
+          <a:bodyPr wrap="none">
+            <a:spAutoFit/>
+          </a:bodyPr>
+          <a:lstStyle/>
           <a:p>
             <a:pPr algn="ctr">
               <a:spcAft>
@@ -4617,61 +4744,13 @@
               </a:spcAft>
             </a:pPr>
             <a:r>
-              <a:rPr sz="2100" b="1">
-                <a:solidFill>
-                  <a:srgbClr val="212121"/>
-                </a:solidFill>
-                <a:latin typeface="Calibri"/>
-              </a:rPr>
-              <a:t>RL Post-Training of LLMs: Signal Starvation and Stack-Conditioned GRPO</a:t>
-            </a:r>
-          </a:p>
-          <a:p>
-            <a:pPr algn="ctr">
-              <a:spcAft>
-                <a:spcPts val="700"/>
-              </a:spcAft>
-            </a:pPr>
-            <a:r>
-              <a:rPr sz="1400" b="0">
+              <a:rPr sz="1200" b="0">
                 <a:solidFill>
                   <a:srgbClr val="5A5A5A"/>
                 </a:solidFill>
                 <a:latin typeface="Calibri"/>
               </a:rPr>
-              <a:t>Title decoded: GRPO learns from reward contrast inside groups of completions; when a group is all-correct or all-wrong it teaches nothing (signal starvation, measured by the Zero-Variance Fraction), and what a run "shows" depends on the software stack it ran on (stack-conditioned).</a:t>
-            </a:r>
-          </a:p>
-          <a:p>
-            <a:pPr algn="ctr">
-              <a:spcAft>
-                <a:spcPts val="700"/>
-              </a:spcAft>
-            </a:pPr>
-            <a:r>
-              <a:rPr sz="1500" b="0">
-                <a:solidFill>
-                  <a:srgbClr val="5A5A5A"/>
-                </a:solidFill>
-                <a:latin typeface="Calibri"/>
-              </a:rPr>
-              <a:t>Arvind C R (Arvind Chitra Rajasekaran)  ·  SRN: PES2PGE24DS140</a:t>
-            </a:r>
-          </a:p>
-          <a:p>
-            <a:pPr algn="ctr">
-              <a:spcAft>
-                <a:spcPts val="700"/>
-              </a:spcAft>
-            </a:pPr>
-            <a:r>
-              <a:rPr sz="1400" b="0">
-                <a:solidFill>
-                  <a:srgbClr val="5A5A5A"/>
-                </a:solidFill>
-                <a:latin typeface="Calibri"/>
-              </a:rPr>
-              <a:t>Guide: Ramesh Prakash Guledgudd  ·  Dept. of CSE, PES University  ·  M.Tech Data Science &amp; AI</a:t>
+              <a:t>Click to play — embedded in the deck; no network needed.</a:t>
             </a:r>
           </a:p>
         </p:txBody>
@@ -4681,6 +4760,28 @@
   <p:clrMapOvr>
     <a:masterClrMapping/>
   </p:clrMapOvr>
+  <p:timing>
+    <p:tnLst>
+      <p:par>
+        <p:cTn id="1" dur="indefinite" restart="never" nodeType="tmRoot">
+          <p:childTnLst>
+            <p:video>
+              <p:cMediaNode vol="80000">
+                <p:cTn id="2" fill="hold" display="0">
+                  <p:stCondLst>
+                    <p:cond delay="indefinite"/>
+                  </p:stCondLst>
+                </p:cTn>
+                <p:tgtEl>
+                  <p:spTgt spid="3"/>
+                </p:tgtEl>
+              </p:cMediaNode>
+            </p:video>
+          </p:childTnLst>
+        </p:cTn>
+      </p:par>
+    </p:tnLst>
+  </p:timing>
 </p:sld>
 </file>
 
@@ -4728,7 +4829,7 @@
                 </a:solidFill>
                 <a:latin typeface="Calibri"/>
               </a:rPr>
-              <a:t>Result 4 — GRPO vs Dr.GRPO: No Footprint at This Scale (+ the Incident)</a:t>
+              <a:t>Result 3 — The Estimator Is Calibrated, the Budget Is Exact</a:t>
             </a:r>
           </a:p>
         </p:txBody>
@@ -4767,7 +4868,7 @@
                 </a:solidFill>
                 <a:latin typeface="Calibri"/>
               </a:rPr>
-              <a:t>10</a:t>
+              <a:t>9</a:t>
             </a:r>
           </a:p>
         </p:txBody>
@@ -4806,7 +4907,7 @@
                 </a:solidFill>
                 <a:latin typeface="Calibri"/>
               </a:rPr>
-              <a:t>•  Six-arm uncapped panel (Qwen3-8B, 1,024-token cap, 3 seeds/loss): GRPO lengths 1004→905, 981→944, 996→900; Dr.GRPO 999→931, 972→902, 1000→878 — lengths SHRINK 6–12% in every arm; no length inflation, no late-ZVF separation between losses.</a:t>
+              <a:t>•  T1 (calibration): ZVF_t is an unbiased binomial-proportion estimator; Wilson CI covers 0.95–0.98 in every tested setting (Wald marginal at m=32). Curriculum ordering is an estimand-labelling requirement, not an invalidation.</a:t>
             </a:r>
           </a:p>
           <a:p>
@@ -4816,45 +4917,45 @@
               </a:spcAft>
             </a:pPr>
             <a:r>
+              <a:rPr sz="1500" b="1">
+                <a:solidFill>
+                  <a:srgbClr val="212121"/>
+                </a:solidFill>
+                <a:latin typeface="Calibri"/>
+              </a:rPr>
+              <a:t>•  T2 (reliability budget): rollouts-to-next-informative-group is geometric; N(ZVF)=G⌈ln δ/ln ZVF⌉ matched observed quantiles at ratio 1.00 across all six difficulty strata (hardest: ZVF=0.886 ⇒ 160 rollouts). A budget, NOT an impossibility bound.</a:t>
+            </a:r>
+          </a:p>
+          <a:p>
+            <a:pPr algn="l">
+              <a:spcAft>
+                <a:spcPts val="700"/>
+              </a:spcAft>
+            </a:pPr>
+            <a:r>
+              <a:rPr sz="1500" b="1">
+                <a:solidFill>
+                  <a:srgbClr val="212121"/>
+                </a:solidFill>
+                <a:latin typeface="Calibri"/>
+              </a:rPr>
+              <a:t>•  T3 (honest negative): the signal-per-rollout objective satisfies J(2)=J(3) for EVERY difficulty prior — its argmax is universally {2,3}, so it cannot yield a data-adaptive G. Found by adversarial review; reported as a result, not buried.</a:t>
+            </a:r>
+          </a:p>
+          <a:p>
+            <a:pPr algn="l">
+              <a:spcAft>
+                <a:spcPts val="700"/>
+              </a:spcAft>
+            </a:pPr>
+            <a:r>
               <a:rPr sz="1500" b="0">
                 <a:solidFill>
                   <a:srgbClr val="212121"/>
                 </a:solidFill>
                 <a:latin typeface="Calibri"/>
               </a:rPr>
-              <a:t>•  Reading: at this scale the loss-form choice has no observable footprint on length or ZVF — evidence about reporting, not superiority. Comparisons between these losses measure stack noise unless controlled far more tightly than the labels suggest.</a:t>
-            </a:r>
-          </a:p>
-          <a:p>
-            <a:pPr algn="l">
-              <a:spcAft>
-                <a:spcPts val="700"/>
-              </a:spcAft>
-            </a:pPr>
-            <a:r>
-              <a:rPr sz="1500" b="1">
-                <a:solidFill>
-                  <a:srgbClr val="212121"/>
-                </a:solidFill>
-                <a:latin typeface="Calibri"/>
-              </a:rPr>
-              <a:t>•  The incident: the first panel ran with a documented --loss drgrpo flag that was never wired in — both "arms" silently trained identical GRPO. Caught only by reading the runner; artifacts preserved under .invalid_actually_grpo names; corrected rerun REVERSED one conclusion.</a:t>
-            </a:r>
-          </a:p>
-          <a:p>
-            <a:pPr algn="l">
-              <a:spcAft>
-                <a:spcPts val="700"/>
-              </a:spcAft>
-            </a:pPr>
-            <a:r>
-              <a:rPr sz="1500" b="0">
-                <a:solidFill>
-                  <a:srgbClr val="212121"/>
-                </a:solidFill>
-                <a:latin typeface="Calibri"/>
-              </a:rPr>
-              <a:t>•  Response became protocol: invalidate loudly → preserve → rerun → record. This failure is a first-class result feeding the reproducibility standard (Result 5).</a:t>
+              <a:t>•  Two earlier statement errors (a quantifier confusion in T2; a GU sign slip) were caught by external review, corrected, re-validated — and are documented in the thesis as part of the method.</a:t>
             </a:r>
           </a:p>
         </p:txBody>
@@ -4911,7 +5012,7 @@
                 </a:solidFill>
                 <a:latin typeface="Calibri"/>
               </a:rPr>
-              <a:t>Result 5 — Reproducibility: Measured Flips, and the Standard They Justify</a:t>
+              <a:t>Result 4 — GRPO vs Dr.GRPO: No Footprint at This Scale (+ the Incident)</a:t>
             </a:r>
           </a:p>
         </p:txBody>
@@ -4950,7 +5051,7 @@
                 </a:solidFill>
                 <a:latin typeface="Calibri"/>
               </a:rPr>
-              <a:t>11</a:t>
+              <a:t>10</a:t>
             </a:r>
           </a:p>
         </p:txBody>
@@ -4989,7 +5090,7 @@
                 </a:solidFill>
                 <a:latin typeface="Calibri"/>
               </a:rPr>
-              <a:t>•  Backend swap (undisclosed, bundled a base-checkpoint change): final training reward moved across a 17× span — 85.6% vs 5.0% — under the same label.</a:t>
+              <a:t>•  Six-arm uncapped panel (Qwen3-8B, 1,024-token cap, 3 seeds/loss): GRPO lengths 1004→905, 981→944, 996→900; Dr.GRPO 999→931, 972→902, 1000→878 — lengths SHRINK 6–12% in every arm; no length inflation, no late-ZVF separation between losses.</a:t>
             </a:r>
           </a:p>
           <a:p>
@@ -4999,13 +5100,29 @@
               </a:spcAft>
             </a:pPr>
             <a:r>
+              <a:rPr sz="1500" b="0">
+                <a:solidFill>
+                  <a:srgbClr val="212121"/>
+                </a:solidFill>
+                <a:latin typeface="Calibri"/>
+              </a:rPr>
+              <a:t>•  Reading: at this scale the loss-form choice has no observable footprint on length or ZVF — evidence about reporting, not superiority. Comparisons between these losses measure stack noise unless controlled far more tightly than the labels suggest.</a:t>
+            </a:r>
+          </a:p>
+          <a:p>
+            <a:pPr algn="l">
+              <a:spcAft>
+                <a:spcPts val="700"/>
+              </a:spcAft>
+            </a:pPr>
+            <a:r>
               <a:rPr sz="1500" b="1">
                 <a:solidFill>
                   <a:srgbClr val="212121"/>
                 </a:solidFill>
                 <a:latin typeface="Calibri"/>
               </a:rPr>
-              <a:t>•  Same "DAPO" label: mean ZVF 0.00 on an open trainer with true dynamic sampling vs 0.55–0.58 on a closed stack running an asymmetric-clip surrogate.</a:t>
+              <a:t>•  The incident: the first panel ran with a documented --loss drgrpo flag that was never wired in — both "arms" silently trained identical GRPO. Caught only by reading the runner; artifacts preserved under .invalid_actually_grpo names; corrected rerun REVERSED one conclusion.</a:t>
             </a:r>
           </a:p>
           <a:p>
@@ -5021,23 +5138,7 @@
                 </a:solidFill>
                 <a:latin typeface="Calibri"/>
               </a:rPr>
-              <a:t>•  Reward-parser sensitivity: micro-jitter ε~U(0,1e-4) below verifier resolution collapses batch ZVF 0.158 → 0.000 — reported ZVF must name its verifier.</a:t>
-            </a:r>
-          </a:p>
-          <a:p>
-            <a:pPr algn="l">
-              <a:spcAft>
-                <a:spcPts val="700"/>
-              </a:spcAft>
-            </a:pPr>
-            <a:r>
-              <a:rPr sz="1500" b="1">
-                <a:solidFill>
-                  <a:srgbClr val="212121"/>
-                </a:solidFill>
-                <a:latin typeface="Calibri"/>
-              </a:rPr>
-              <a:t>•  Deliverables: MIN-REPORT-RL (8-item minimum reportable stack — every item justified by a measured flip), GRPO-Registry (machine-readable catalog, 20 seed entries), stackdiff (pairwise flip-risk verdicts R0–R5).</a:t>
+              <a:t>•  Response became protocol: invalidate loudly → preserve → rerun → record. This failure is a first-class result feeding the reproducibility standard (Result 5).</a:t>
             </a:r>
           </a:p>
         </p:txBody>
@@ -5094,7 +5195,7 @@
                 </a:solidFill>
                 <a:latin typeface="Calibri"/>
               </a:rPr>
-              <a:t>Result 6 — Held-Out Evaluation: Gains, Transfer, and an Honest Boundary</a:t>
+              <a:t>Result 5 — Reproducibility: Measured Flips, and the Standard They Justify</a:t>
             </a:r>
           </a:p>
         </p:txBody>
@@ -5133,7 +5234,7 @@
                 </a:solidFill>
                 <a:latin typeface="Calibri"/>
               </a:rPr>
-              <a:t>12</a:t>
+              <a:t>11</a:t>
             </a:r>
           </a:p>
         </p:txBody>
@@ -5172,7 +5273,7 @@
                 </a:solidFill>
                 <a:latin typeface="Calibri"/>
               </a:rPr>
-              <a:t>•  Baseline capability (200 problems, n=32, clustered bootstrap): pass@1 30.4% [27.5, 33.1] but pass@32 91.0% — GSM8K is nearly saturated at k=32; ~9 points of headroom bounds what training can claim here.</a:t>
+              <a:t>•  Backend swap (undisclosed, bundled a base-checkpoint change): final training reward moved across a 17× span — 85.6% vs 5.0% — under the same label.</a:t>
             </a:r>
           </a:p>
           <a:p>
@@ -5182,13 +5283,29 @@
               </a:spcAft>
             </a:pPr>
             <a:r>
+              <a:rPr sz="1500" b="1">
+                <a:solidFill>
+                  <a:srgbClr val="212121"/>
+                </a:solidFill>
+                <a:latin typeface="Calibri"/>
+              </a:rPr>
+              <a:t>•  Same "DAPO" label: mean ZVF 0.00 on an open trainer with true dynamic sampling vs 0.55–0.58 on a closed stack running an asymmetric-clip surrogate.</a:t>
+            </a:r>
+          </a:p>
+          <a:p>
+            <a:pPr algn="l">
+              <a:spcAft>
+                <a:spcPts val="700"/>
+              </a:spcAft>
+            </a:pPr>
+            <a:r>
               <a:rPr sz="1500" b="0">
                 <a:solidFill>
                   <a:srgbClr val="212121"/>
                 </a:solidFill>
                 <a:latin typeface="Calibri"/>
               </a:rPr>
-              <a:t>•  Transfer: post-RL adapters show zero forgetting and mild positive transfer on MBPP (pass@32 within noise of or above base for all G); pass@1-only reporting would misread the G=2 arm as a regression.</a:t>
+              <a:t>•  Reward-parser sensitivity: micro-jitter ε~U(0,1e-4) below verifier resolution collapses batch ZVF 0.158 → 0.000 — reported ZVF must name its verifier.</a:t>
             </a:r>
           </a:p>
           <a:p>
@@ -5204,23 +5321,7 @@
                 </a:solidFill>
                 <a:latin typeface="Calibri"/>
               </a:rPr>
-              <a:t>•  Hard-task boundary (MATH-500, partial): GSM8K-trained frontier gains do not carry — consistent with distribution sharpening rather than capability expansion. Stated as a non-claim in the thesis.</a:t>
-            </a:r>
-          </a:p>
-          <a:p>
-            <a:pPr algn="l">
-              <a:spcAft>
-                <a:spcPts val="700"/>
-              </a:spcAft>
-            </a:pPr>
-            <a:r>
-              <a:rPr sz="1500" b="0">
-                <a:solidFill>
-                  <a:srgbClr val="212121"/>
-                </a:solidFill>
-                <a:latin typeface="Calibri"/>
-              </a:rPr>
-              <a:t>•  Cross-scale observations (70+ curated runs, 7 libraries, 0.6B–671B): scale does not uniformly reduce ZVF; starvation is (difficulty × G × phase) geometry, not something scale buys you out of.</a:t>
+              <a:t>•  Deliverables: MIN-REPORT-RL (8-item minimum reportable stack — every item justified by a measured flip), GRPO-Registry (machine-readable catalog, 20 seed entries), stackdiff (pairwise flip-risk verdicts R0–R5).</a:t>
             </a:r>
           </a:p>
         </p:txBody>
@@ -5234,6 +5335,189 @@
 </file>
 
 <file path=ppt/slides/slide13.xml><?xml version="1.0" encoding="utf-8"?>
+<p:sld xmlns:a="http://schemas.openxmlformats.org/drawingml/2006/main" xmlns:p="http://schemas.openxmlformats.org/presentationml/2006/main" xmlns:r="http://schemas.openxmlformats.org/officeDocument/2006/relationships">
+  <p:cSld>
+    <p:spTree>
+      <p:nvGrpSpPr>
+        <p:cNvPr id="1" name=""/>
+        <p:cNvGrpSpPr/>
+        <p:nvPr/>
+      </p:nvGrpSpPr>
+      <p:grpSpPr/>
+      <p:sp>
+        <p:nvSpPr>
+          <p:cNvPr id="2" name="TextBox 1"/>
+          <p:cNvSpPr txBox="1"/>
+          <p:nvPr/>
+        </p:nvSpPr>
+        <p:spPr>
+          <a:xfrm>
+            <a:off x="548640" y="274320"/>
+            <a:ext cx="11064240" cy="731520"/>
+          </a:xfrm>
+          <a:prstGeom prst="rect">
+            <a:avLst/>
+          </a:prstGeom>
+          <a:noFill/>
+        </p:spPr>
+        <p:txBody>
+          <a:bodyPr wrap="none">
+            <a:spAutoFit/>
+          </a:bodyPr>
+          <a:lstStyle/>
+          <a:p>
+            <a:pPr algn="l">
+              <a:spcAft>
+                <a:spcPts val="700"/>
+              </a:spcAft>
+            </a:pPr>
+            <a:r>
+              <a:rPr sz="2700" b="1">
+                <a:solidFill>
+                  <a:srgbClr val="1F4E79"/>
+                </a:solidFill>
+                <a:latin typeface="Calibri"/>
+              </a:rPr>
+              <a:t>Result 6 — Held-Out Evaluation: Gains, Transfer, and an Honest Boundary</a:t>
+            </a:r>
+          </a:p>
+        </p:txBody>
+      </p:sp>
+      <p:sp>
+        <p:nvSpPr>
+          <p:cNvPr id="3" name="TextBox 2"/>
+          <p:cNvSpPr txBox="1"/>
+          <p:nvPr/>
+        </p:nvSpPr>
+        <p:spPr>
+          <a:xfrm>
+            <a:off x="11430000" y="6446520"/>
+            <a:ext cx="548640" cy="320040"/>
+          </a:xfrm>
+          <a:prstGeom prst="rect">
+            <a:avLst/>
+          </a:prstGeom>
+          <a:noFill/>
+        </p:spPr>
+        <p:txBody>
+          <a:bodyPr wrap="none">
+            <a:spAutoFit/>
+          </a:bodyPr>
+          <a:lstStyle/>
+          <a:p>
+            <a:pPr algn="l">
+              <a:spcAft>
+                <a:spcPts val="700"/>
+              </a:spcAft>
+            </a:pPr>
+            <a:r>
+              <a:rPr sz="1100" b="0">
+                <a:solidFill>
+                  <a:srgbClr val="5A5A5A"/>
+                </a:solidFill>
+                <a:latin typeface="Calibri"/>
+              </a:rPr>
+              <a:t>12</a:t>
+            </a:r>
+          </a:p>
+        </p:txBody>
+      </p:sp>
+      <p:sp>
+        <p:nvSpPr>
+          <p:cNvPr id="4" name="TextBox 3"/>
+          <p:cNvSpPr txBox="1"/>
+          <p:nvPr/>
+        </p:nvSpPr>
+        <p:spPr>
+          <a:xfrm>
+            <a:off x="731520" y="1143000"/>
+            <a:ext cx="10789920" cy="5212080"/>
+          </a:xfrm>
+          <a:prstGeom prst="rect">
+            <a:avLst/>
+          </a:prstGeom>
+          <a:noFill/>
+        </p:spPr>
+        <p:txBody>
+          <a:bodyPr wrap="square">
+            <a:spAutoFit/>
+          </a:bodyPr>
+          <a:lstStyle/>
+          <a:p>
+            <a:pPr algn="l">
+              <a:spcAft>
+                <a:spcPts val="700"/>
+              </a:spcAft>
+            </a:pPr>
+            <a:r>
+              <a:rPr sz="1500" b="1">
+                <a:solidFill>
+                  <a:srgbClr val="212121"/>
+                </a:solidFill>
+                <a:latin typeface="Calibri"/>
+              </a:rPr>
+              <a:t>•  Baseline capability (200 problems, n=32, clustered bootstrap): pass@1 30.4% [27.5, 33.1] but pass@32 91.0% — GSM8K is nearly saturated at k=32; ~9 points of headroom bounds what training can claim here.</a:t>
+            </a:r>
+          </a:p>
+          <a:p>
+            <a:pPr algn="l">
+              <a:spcAft>
+                <a:spcPts val="700"/>
+              </a:spcAft>
+            </a:pPr>
+            <a:r>
+              <a:rPr sz="1500" b="0">
+                <a:solidFill>
+                  <a:srgbClr val="212121"/>
+                </a:solidFill>
+                <a:latin typeface="Calibri"/>
+              </a:rPr>
+              <a:t>•  Transfer: post-RL adapters show zero forgetting and mild positive transfer on MBPP (pass@32 within noise of or above base for all G); pass@1-only reporting would misread the G=2 arm as a regression.</a:t>
+            </a:r>
+          </a:p>
+          <a:p>
+            <a:pPr algn="l">
+              <a:spcAft>
+                <a:spcPts val="700"/>
+              </a:spcAft>
+            </a:pPr>
+            <a:r>
+              <a:rPr sz="1500" b="1">
+                <a:solidFill>
+                  <a:srgbClr val="212121"/>
+                </a:solidFill>
+                <a:latin typeface="Calibri"/>
+              </a:rPr>
+              <a:t>•  Hard-task boundary (MATH-500, partial): GSM8K-trained frontier gains do not carry — consistent with distribution sharpening rather than capability expansion. Stated as a non-claim in the thesis.</a:t>
+            </a:r>
+          </a:p>
+          <a:p>
+            <a:pPr algn="l">
+              <a:spcAft>
+                <a:spcPts val="700"/>
+              </a:spcAft>
+            </a:pPr>
+            <a:r>
+              <a:rPr sz="1500" b="0">
+                <a:solidFill>
+                  <a:srgbClr val="212121"/>
+                </a:solidFill>
+                <a:latin typeface="Calibri"/>
+              </a:rPr>
+              <a:t>•  Cross-scale observations (70+ curated runs, 7 libraries, 0.6B–671B): scale does not uniformly reduce ZVF; starvation is (difficulty × G × phase) geometry, not something scale buys you out of.</a:t>
+            </a:r>
+          </a:p>
+        </p:txBody>
+      </p:sp>
+    </p:spTree>
+  </p:cSld>
+  <p:clrMapOvr>
+    <a:masterClrMapping/>
+  </p:clrMapOvr>
+</p:sld>
+</file>
+
+<file path=ppt/slides/slide14.xml><?xml version="1.0" encoding="utf-8"?>
 <p:sld xmlns:a="http://schemas.openxmlformats.org/drawingml/2006/main" xmlns:p="http://schemas.openxmlformats.org/presentationml/2006/main" xmlns:r="http://schemas.openxmlformats.org/officeDocument/2006/relationships">
   <p:cSld>
     <p:spTree>
@@ -5497,189 +5781,6 @@
 </p:sld>
 </file>
 
-<file path=ppt/slides/slide14.xml><?xml version="1.0" encoding="utf-8"?>
-<p:sld xmlns:a="http://schemas.openxmlformats.org/drawingml/2006/main" xmlns:p="http://schemas.openxmlformats.org/presentationml/2006/main" xmlns:r="http://schemas.openxmlformats.org/officeDocument/2006/relationships">
-  <p:cSld>
-    <p:spTree>
-      <p:nvGrpSpPr>
-        <p:cNvPr id="1" name=""/>
-        <p:cNvGrpSpPr/>
-        <p:nvPr/>
-      </p:nvGrpSpPr>
-      <p:grpSpPr/>
-      <p:sp>
-        <p:nvSpPr>
-          <p:cNvPr id="2" name="TextBox 1"/>
-          <p:cNvSpPr txBox="1"/>
-          <p:nvPr/>
-        </p:nvSpPr>
-        <p:spPr>
-          <a:xfrm>
-            <a:off x="548640" y="274320"/>
-            <a:ext cx="11064240" cy="731520"/>
-          </a:xfrm>
-          <a:prstGeom prst="rect">
-            <a:avLst/>
-          </a:prstGeom>
-          <a:noFill/>
-        </p:spPr>
-        <p:txBody>
-          <a:bodyPr wrap="none">
-            <a:spAutoFit/>
-          </a:bodyPr>
-          <a:lstStyle/>
-          <a:p>
-            <a:pPr algn="l">
-              <a:spcAft>
-                <a:spcPts val="700"/>
-              </a:spcAft>
-            </a:pPr>
-            <a:r>
-              <a:rPr sz="2700" b="1">
-                <a:solidFill>
-                  <a:srgbClr val="1F4E79"/>
-                </a:solidFill>
-                <a:latin typeface="Calibri"/>
-              </a:rPr>
-              <a:t>Demo (Live)</a:t>
-            </a:r>
-          </a:p>
-        </p:txBody>
-      </p:sp>
-      <p:sp>
-        <p:nvSpPr>
-          <p:cNvPr id="3" name="TextBox 2"/>
-          <p:cNvSpPr txBox="1"/>
-          <p:nvPr/>
-        </p:nvSpPr>
-        <p:spPr>
-          <a:xfrm>
-            <a:off x="11430000" y="6446520"/>
-            <a:ext cx="548640" cy="320040"/>
-          </a:xfrm>
-          <a:prstGeom prst="rect">
-            <a:avLst/>
-          </a:prstGeom>
-          <a:noFill/>
-        </p:spPr>
-        <p:txBody>
-          <a:bodyPr wrap="none">
-            <a:spAutoFit/>
-          </a:bodyPr>
-          <a:lstStyle/>
-          <a:p>
-            <a:pPr algn="l">
-              <a:spcAft>
-                <a:spcPts val="700"/>
-              </a:spcAft>
-            </a:pPr>
-            <a:r>
-              <a:rPr sz="1100" b="0">
-                <a:solidFill>
-                  <a:srgbClr val="5A5A5A"/>
-                </a:solidFill>
-                <a:latin typeface="Calibri"/>
-              </a:rPr>
-              <a:t>14</a:t>
-            </a:r>
-          </a:p>
-        </p:txBody>
-      </p:sp>
-      <p:sp>
-        <p:nvSpPr>
-          <p:cNvPr id="4" name="TextBox 3"/>
-          <p:cNvSpPr txBox="1"/>
-          <p:nvPr/>
-        </p:nvSpPr>
-        <p:spPr>
-          <a:xfrm>
-            <a:off x="731520" y="1143000"/>
-            <a:ext cx="10789920" cy="5212080"/>
-          </a:xfrm>
-          <a:prstGeom prst="rect">
-            <a:avLst/>
-          </a:prstGeom>
-          <a:noFill/>
-        </p:spPr>
-        <p:txBody>
-          <a:bodyPr wrap="square">
-            <a:spAutoFit/>
-          </a:bodyPr>
-          <a:lstStyle/>
-          <a:p>
-            <a:pPr algn="l">
-              <a:spcAft>
-                <a:spcPts val="700"/>
-              </a:spcAft>
-            </a:pPr>
-            <a:r>
-              <a:rPr sz="1500" b="1">
-                <a:solidFill>
-                  <a:srgbClr val="212121"/>
-                </a:solidFill>
-                <a:latin typeface="Calibri"/>
-              </a:rPr>
-              <a:t>•  One command, fully offline: ./submission/demo/demo.sh — mechanism fixture (4 groups → ZVF=0.500, GU=0.500), recorded artifact check (80 rewards, mean 0.6875, ZVF 0.3000), SHA-256 integrity, JSON + HTML dashboard. Status: PASS (re-verified today).</a:t>
-            </a:r>
-          </a:p>
-          <a:p>
-            <a:pPr algn="l">
-              <a:spcAft>
-                <a:spcPts val="700"/>
-              </a:spcAft>
-            </a:pPr>
-            <a:r>
-              <a:rPr sz="1500" b="0">
-                <a:solidFill>
-                  <a:srgbClr val="212121"/>
-                </a:solidFill>
-                <a:latin typeface="Calibri"/>
-              </a:rPr>
-              <a:t>•  Live artifact tour: W&amp;B zvf-training — the (reward, ZVF) pair diverging on the real E-R2b arms; audit workbook key_runs sheet — every claim-critical run traceable in two clicks.</a:t>
-            </a:r>
-          </a:p>
-          <a:p>
-            <a:pPr algn="l">
-              <a:spcAft>
-                <a:spcPts val="700"/>
-              </a:spcAft>
-            </a:pPr>
-            <a:r>
-              <a:rPr sz="1500" b="0">
-                <a:solidFill>
-                  <a:srgbClr val="212121"/>
-                </a:solidFill>
-                <a:latin typeface="Calibri"/>
-              </a:rPr>
-              <a:t>•  zvf-triage quickstart: pip-installable package, examples/quickstart.py — the diagnostic as a reusable library, not a one-off script.</a:t>
-            </a:r>
-          </a:p>
-          <a:p>
-            <a:pPr algn="l">
-              <a:spcAft>
-                <a:spcPts val="700"/>
-              </a:spcAft>
-            </a:pPr>
-            <a:r>
-              <a:rPr sz="1500" b="0">
-                <a:solidFill>
-                  <a:srgbClr val="212121"/>
-                </a:solidFill>
-                <a:latin typeface="Calibri"/>
-              </a:rPr>
-              <a:t>•  Fallback if connectivity fails: 86-second recorded walkthrough (thesis/viva/demo_walkthrough.mp4).</a:t>
-            </a:r>
-          </a:p>
-        </p:txBody>
-      </p:sp>
-    </p:spTree>
-  </p:cSld>
-  <p:clrMapOvr>
-    <a:masterClrMapping/>
-  </p:clrMapOvr>
-</p:sld>
-</file>
-
 <file path=ppt/slides/slide15.xml><?xml version="1.0" encoding="utf-8"?>
 <p:sld xmlns:a="http://schemas.openxmlformats.org/drawingml/2006/main" xmlns:p="http://schemas.openxmlformats.org/presentationml/2006/main" xmlns:r="http://schemas.openxmlformats.org/officeDocument/2006/relationships">
   <p:cSld>
@@ -5724,7 +5825,7 @@
                 </a:solidFill>
                 <a:latin typeface="Calibri"/>
               </a:rPr>
-              <a:t>Scope, Limitations &amp; Roadmap</a:t>
+              <a:t>Demo (Live)</a:t>
             </a:r>
           </a:p>
         </p:txBody>
@@ -5763,7 +5864,7 @@
                 </a:solidFill>
                 <a:latin typeface="Calibri"/>
               </a:rPr>
-              <a:t>15</a:t>
+              <a:t>14</a:t>
             </a:r>
           </a:p>
         </p:txBody>
@@ -5802,7 +5903,7 @@
                 </a:solidFill>
                 <a:latin typeface="Calibri"/>
               </a:rPr>
-              <a:t>•  Declared scope: Qwen3-8B, GSM8K-family binary rewards, Tinker managed API (LoRA rank 4), 1–3 seeds per result — claims are stated at the stack level and nowhere above it.</a:t>
+              <a:t>•  One command, fully offline: ./submission/demo/demo.sh — mechanism fixture (4 groups → ZVF=0.500, GU=0.500), recorded artifact check (80 rewards, mean 0.6875, ZVF 0.3000), SHA-256 integrity, JSON + HTML dashboard. Status: PASS (re-verified today).</a:t>
             </a:r>
           </a:p>
           <a:p>
@@ -5818,7 +5919,7 @@
                 </a:solidFill>
                 <a:latin typeface="Calibri"/>
               </a:rPr>
-              <a:t>•  No causal or predictive power is claimed for ZVF beyond diagnosis; controller efficacy is explicitly gated on a pre-registered, compute-matched comparison (≥3 seeds, held-out metrics).</a:t>
+              <a:t>•  Live artifact tour: W&amp;B zvf-training — the (reward, ZVF) pair diverging on the real E-R2b arms; audit workbook key_runs sheet — every claim-critical run traceable in two clicks.</a:t>
             </a:r>
           </a:p>
           <a:p>
@@ -5834,7 +5935,7 @@
                 </a:solidFill>
                 <a:latin typeface="Calibri"/>
               </a:rPr>
-              <a:t>•  Roadmap (gated): bounded diagnostic paper (Claims 1–2) → controller paper (needs the win) → survival audit (needs an open stack). Thesis consolidates all 17 working documents.</a:t>
+              <a:t>•  zvf-triage quickstart: pip-installable package, examples/quickstart.py — the diagnostic as a reusable library, not a one-off script.</a:t>
             </a:r>
           </a:p>
           <a:p>
@@ -5844,13 +5945,13 @@
               </a:spcAft>
             </a:pPr>
             <a:r>
-              <a:rPr sz="1500" b="1">
+              <a:rPr sz="1500" b="0">
                 <a:solidFill>
                   <a:srgbClr val="212121"/>
                 </a:solidFill>
                 <a:latin typeface="Calibri"/>
               </a:rPr>
-              <a:t>•  The transferable lesson: at this scale the binding constraint is not compute or novelty — it is certainty about what actually ran.</a:t>
+              <a:t>•  Fallback if connectivity fails: 86-second recorded walkthrough (thesis/viva/demo_walkthrough.mp4).</a:t>
             </a:r>
           </a:p>
         </p:txBody>
@@ -5881,6 +5982,189 @@
         </p:nvSpPr>
         <p:spPr>
           <a:xfrm>
+            <a:off x="548640" y="274320"/>
+            <a:ext cx="11064240" cy="731520"/>
+          </a:xfrm>
+          <a:prstGeom prst="rect">
+            <a:avLst/>
+          </a:prstGeom>
+          <a:noFill/>
+        </p:spPr>
+        <p:txBody>
+          <a:bodyPr wrap="none">
+            <a:spAutoFit/>
+          </a:bodyPr>
+          <a:lstStyle/>
+          <a:p>
+            <a:pPr algn="l">
+              <a:spcAft>
+                <a:spcPts val="700"/>
+              </a:spcAft>
+            </a:pPr>
+            <a:r>
+              <a:rPr sz="2700" b="1">
+                <a:solidFill>
+                  <a:srgbClr val="1F4E79"/>
+                </a:solidFill>
+                <a:latin typeface="Calibri"/>
+              </a:rPr>
+              <a:t>Scope, Limitations &amp; Roadmap</a:t>
+            </a:r>
+          </a:p>
+        </p:txBody>
+      </p:sp>
+      <p:sp>
+        <p:nvSpPr>
+          <p:cNvPr id="3" name="TextBox 2"/>
+          <p:cNvSpPr txBox="1"/>
+          <p:nvPr/>
+        </p:nvSpPr>
+        <p:spPr>
+          <a:xfrm>
+            <a:off x="11430000" y="6446520"/>
+            <a:ext cx="548640" cy="320040"/>
+          </a:xfrm>
+          <a:prstGeom prst="rect">
+            <a:avLst/>
+          </a:prstGeom>
+          <a:noFill/>
+        </p:spPr>
+        <p:txBody>
+          <a:bodyPr wrap="none">
+            <a:spAutoFit/>
+          </a:bodyPr>
+          <a:lstStyle/>
+          <a:p>
+            <a:pPr algn="l">
+              <a:spcAft>
+                <a:spcPts val="700"/>
+              </a:spcAft>
+            </a:pPr>
+            <a:r>
+              <a:rPr sz="1100" b="0">
+                <a:solidFill>
+                  <a:srgbClr val="5A5A5A"/>
+                </a:solidFill>
+                <a:latin typeface="Calibri"/>
+              </a:rPr>
+              <a:t>15</a:t>
+            </a:r>
+          </a:p>
+        </p:txBody>
+      </p:sp>
+      <p:sp>
+        <p:nvSpPr>
+          <p:cNvPr id="4" name="TextBox 3"/>
+          <p:cNvSpPr txBox="1"/>
+          <p:nvPr/>
+        </p:nvSpPr>
+        <p:spPr>
+          <a:xfrm>
+            <a:off x="731520" y="1143000"/>
+            <a:ext cx="10789920" cy="5212080"/>
+          </a:xfrm>
+          <a:prstGeom prst="rect">
+            <a:avLst/>
+          </a:prstGeom>
+          <a:noFill/>
+        </p:spPr>
+        <p:txBody>
+          <a:bodyPr wrap="square">
+            <a:spAutoFit/>
+          </a:bodyPr>
+          <a:lstStyle/>
+          <a:p>
+            <a:pPr algn="l">
+              <a:spcAft>
+                <a:spcPts val="700"/>
+              </a:spcAft>
+            </a:pPr>
+            <a:r>
+              <a:rPr sz="1500" b="1">
+                <a:solidFill>
+                  <a:srgbClr val="212121"/>
+                </a:solidFill>
+                <a:latin typeface="Calibri"/>
+              </a:rPr>
+              <a:t>•  Declared scope: Qwen3-8B, GSM8K-family binary rewards, Tinker managed API (LoRA rank 4), 1–3 seeds per result — claims are stated at the stack level and nowhere above it.</a:t>
+            </a:r>
+          </a:p>
+          <a:p>
+            <a:pPr algn="l">
+              <a:spcAft>
+                <a:spcPts val="700"/>
+              </a:spcAft>
+            </a:pPr>
+            <a:r>
+              <a:rPr sz="1500" b="0">
+                <a:solidFill>
+                  <a:srgbClr val="212121"/>
+                </a:solidFill>
+                <a:latin typeface="Calibri"/>
+              </a:rPr>
+              <a:t>•  No causal or predictive power is claimed for ZVF beyond diagnosis; controller efficacy is explicitly gated on a pre-registered, compute-matched comparison (≥3 seeds, held-out metrics).</a:t>
+            </a:r>
+          </a:p>
+          <a:p>
+            <a:pPr algn="l">
+              <a:spcAft>
+                <a:spcPts val="700"/>
+              </a:spcAft>
+            </a:pPr>
+            <a:r>
+              <a:rPr sz="1500" b="0">
+                <a:solidFill>
+                  <a:srgbClr val="212121"/>
+                </a:solidFill>
+                <a:latin typeface="Calibri"/>
+              </a:rPr>
+              <a:t>•  Roadmap (gated): bounded diagnostic paper (Claims 1–2) → controller paper (needs the win) → survival audit (needs an open stack). Thesis consolidates all 17 working documents.</a:t>
+            </a:r>
+          </a:p>
+          <a:p>
+            <a:pPr algn="l">
+              <a:spcAft>
+                <a:spcPts val="700"/>
+              </a:spcAft>
+            </a:pPr>
+            <a:r>
+              <a:rPr sz="1500" b="1">
+                <a:solidFill>
+                  <a:srgbClr val="212121"/>
+                </a:solidFill>
+                <a:latin typeface="Calibri"/>
+              </a:rPr>
+              <a:t>•  The transferable lesson: at this scale the binding constraint is not compute or novelty — it is certainty about what actually ran.</a:t>
+            </a:r>
+          </a:p>
+        </p:txBody>
+      </p:sp>
+    </p:spTree>
+  </p:cSld>
+  <p:clrMapOvr>
+    <a:masterClrMapping/>
+  </p:clrMapOvr>
+</p:sld>
+</file>
+
+<file path=ppt/slides/slide17.xml><?xml version="1.0" encoding="utf-8"?>
+<p:sld xmlns:a="http://schemas.openxmlformats.org/drawingml/2006/main" xmlns:p="http://schemas.openxmlformats.org/presentationml/2006/main" xmlns:r="http://schemas.openxmlformats.org/officeDocument/2006/relationships">
+  <p:cSld>
+    <p:spTree>
+      <p:nvGrpSpPr>
+        <p:cNvPr id="1" name=""/>
+        <p:cNvGrpSpPr/>
+        <p:nvPr/>
+      </p:nvGrpSpPr>
+      <p:grpSpPr/>
+      <p:sp>
+        <p:nvSpPr>
+          <p:cNvPr id="2" name="TextBox 1"/>
+          <p:cNvSpPr txBox="1"/>
+          <p:nvPr/>
+        </p:nvSpPr>
+        <p:spPr>
+          <a:xfrm>
             <a:off x="914400" y="2468880"/>
             <a:ext cx="10332720" cy="1828800"/>
           </a:xfrm>
@@ -5954,8 +6238,8 @@
         </p:nvSpPr>
         <p:spPr>
           <a:xfrm>
-            <a:off x="548640" y="274320"/>
-            <a:ext cx="11064240" cy="731520"/>
+            <a:off x="914400" y="1554480"/>
+            <a:ext cx="10332720" cy="3840480"/>
           </a:xfrm>
           <a:prstGeom prst="rect">
             <a:avLst/>
@@ -5963,191 +6247,42 @@
           <a:noFill/>
         </p:spPr>
         <p:txBody>
-          <a:bodyPr wrap="none">
-            <a:spAutoFit/>
-          </a:bodyPr>
-          <a:lstStyle/>
-          <a:p>
-            <a:pPr algn="l">
-              <a:spcAft>
-                <a:spcPts val="700"/>
-              </a:spcAft>
-            </a:pPr>
-            <a:r>
-              <a:rPr sz="2700" b="1">
-                <a:solidFill>
-                  <a:srgbClr val="1F4E79"/>
-                </a:solidFill>
-                <a:latin typeface="Calibri"/>
-              </a:rPr>
-              <a:t>Base Paper &amp; My Understanding of It</a:t>
-            </a:r>
-          </a:p>
-        </p:txBody>
-      </p:sp>
-      <p:sp>
-        <p:nvSpPr>
-          <p:cNvPr id="3" name="TextBox 2"/>
-          <p:cNvSpPr txBox="1"/>
-          <p:nvPr/>
-        </p:nvSpPr>
-        <p:spPr>
-          <a:xfrm>
-            <a:off x="11430000" y="6446520"/>
-            <a:ext cx="548640" cy="320040"/>
-          </a:xfrm>
-          <a:prstGeom prst="rect">
-            <a:avLst/>
-          </a:prstGeom>
-          <a:noFill/>
-        </p:spPr>
-        <p:txBody>
-          <a:bodyPr wrap="none">
-            <a:spAutoFit/>
-          </a:bodyPr>
-          <a:lstStyle/>
-          <a:p>
-            <a:pPr algn="l">
-              <a:spcAft>
-                <a:spcPts val="700"/>
-              </a:spcAft>
-            </a:pPr>
-            <a:r>
-              <a:rPr sz="1100" b="0">
-                <a:solidFill>
-                  <a:srgbClr val="5A5A5A"/>
-                </a:solidFill>
-                <a:latin typeface="Calibri"/>
-              </a:rPr>
-              <a:t>2</a:t>
-            </a:r>
-          </a:p>
-        </p:txBody>
-      </p:sp>
-      <p:sp>
-        <p:nvSpPr>
-          <p:cNvPr id="4" name="TextBox 3"/>
-          <p:cNvSpPr txBox="1"/>
-          <p:nvPr/>
-        </p:nvSpPr>
-        <p:spPr>
-          <a:xfrm>
-            <a:off x="731520" y="1143000"/>
-            <a:ext cx="6858000" cy="5212080"/>
-          </a:xfrm>
-          <a:prstGeom prst="rect">
-            <a:avLst/>
-          </a:prstGeom>
-          <a:noFill/>
-        </p:spPr>
-        <p:txBody>
           <a:bodyPr wrap="square">
             <a:spAutoFit/>
           </a:bodyPr>
           <a:lstStyle/>
           <a:p>
-            <a:pPr algn="l">
-              <a:spcAft>
-                <a:spcPts val="700"/>
-              </a:spcAft>
-            </a:pPr>
-            <a:r>
-              <a:rPr sz="1300" b="1">
+            <a:pPr algn="ctr">
+              <a:spcAft>
+                <a:spcPts val="700"/>
+              </a:spcAft>
+            </a:pPr>
+            <a:r>
+              <a:rPr sz="3000" b="1">
+                <a:solidFill>
+                  <a:srgbClr val="1F4E79"/>
+                </a:solidFill>
+                <a:latin typeface="Calibri"/>
+              </a:rPr>
+              <a:t>M.Tech Project — Phase 1 Review (Defense Format)</a:t>
+            </a:r>
+          </a:p>
+          <a:p>
+            <a:pPr algn="ctr">
+              <a:spcAft>
+                <a:spcPts val="700"/>
+              </a:spcAft>
+            </a:pPr>
+            <a:r>
+              <a:rPr sz="2100" b="1">
                 <a:solidFill>
                   <a:srgbClr val="212121"/>
                 </a:solidFill>
                 <a:latin typeface="Calibri"/>
               </a:rPr>
-              <a:t>•  Base paper — GRPO, from "DeepSeekMath" (Shao et al., 2024; basis of DeepSeek-R1): replaces PPO's learned critic with a group-relative baseline — sample G completions per prompt, advantage = own reward − group mean.</a:t>
-            </a:r>
-          </a:p>
-          <a:p>
-            <a:pPr algn="l">
-              <a:spcAft>
-                <a:spcPts val="700"/>
-              </a:spcAft>
-            </a:pPr>
-            <a:r>
-              <a:rPr sz="1300" b="0">
-                <a:solidFill>
-                  <a:srgbClr val="212121"/>
-                </a:solidFill>
-                <a:latin typeface="Calibri"/>
-              </a:rPr>
-              <a:t>•  Why it matters: critic-free means cheap and stable at LLM scale with verifiable (binary) rewards; it is now the default RL post-training family. The study runs GRPO against PPO, REINFORCE, DPO, GSPO, Dr.GRPO and audited variant labels (slide 5).</a:t>
-            </a:r>
-          </a:p>
-          <a:p>
-            <a:pPr algn="l">
-              <a:spcAft>
-                <a:spcPts val="700"/>
-              </a:spcAft>
-            </a:pPr>
-            <a:r>
-              <a:rPr sz="1300" b="1">
-                <a:solidFill>
-                  <a:srgbClr val="212121"/>
-                </a:solidFill>
-                <a:latin typeface="Calibri"/>
-              </a:rPr>
-              <a:t>•  My understanding — the structural blind spot: if all G completions earn the SAME reward (all-correct or all-wrong), every centred advantage is exactly zero: the group consumes compute but contributes zero gradient. The reward curve cannot show this; it can read "success" precisely while learning has stopped.</a:t>
-            </a:r>
-          </a:p>
-          <a:p>
-            <a:pPr algn="l">
-              <a:spcAft>
-                <a:spcPts val="700"/>
-              </a:spcAft>
-            </a:pPr>
-            <a:r>
-              <a:rPr sz="1300" b="0">
-                <a:solidFill>
-                  <a:srgbClr val="212121"/>
-                </a:solidFill>
-                <a:latin typeface="Calibri"/>
-              </a:rPr>
-              <a:t>•  Secondary anchor — Dr.GRPO (Liu et al., 2025): claims GRPO's per-length/std normalisation biases updates toward verbosity. I test this claim under controlled conditions (Result 4).</a:t>
-            </a:r>
-          </a:p>
-          <a:p>
-            <a:pPr algn="l">
-              <a:spcAft>
-                <a:spcPts val="700"/>
-              </a:spcAft>
-            </a:pPr>
-            <a:r>
-              <a:rPr sz="1300" b="1">
-                <a:solidFill>
-                  <a:srgbClr val="212121"/>
-                </a:solidFill>
-                <a:latin typeface="Calibri"/>
-              </a:rPr>
-              <a:t>•  Thesis position: measure the blind spot (Zero-Variance Fraction, ZVF), calibrate it, budget it, and show what it changes in practice.</a:t>
-            </a:r>
-          </a:p>
-        </p:txBody>
-      </p:sp>
-      <p:sp>
-        <p:nvSpPr>
-          <p:cNvPr id="5" name="TextBox 4"/>
-          <p:cNvSpPr txBox="1"/>
-          <p:nvPr/>
-        </p:nvSpPr>
-        <p:spPr>
-          <a:xfrm>
-            <a:off x="7818120" y="1051560"/>
-            <a:ext cx="3931920" cy="365760"/>
-          </a:xfrm>
-          <a:prstGeom prst="rect">
-            <a:avLst/>
-          </a:prstGeom>
-          <a:noFill/>
-        </p:spPr>
-        <p:txBody>
-          <a:bodyPr wrap="none">
-            <a:spAutoFit/>
-          </a:bodyPr>
-          <a:lstStyle/>
+              <a:t>RL Post-Training of LLMs: Signal Starvation and Stack-Conditioned GRPO</a:t>
+            </a:r>
+          </a:p>
           <a:p>
             <a:pPr algn="ctr">
               <a:spcAft>
@@ -6155,96 +6290,15 @@
               </a:spcAft>
             </a:pPr>
             <a:r>
-              <a:rPr sz="1100" b="0">
+              <a:rPr sz="1400" b="0">
                 <a:solidFill>
                   <a:srgbClr val="5A5A5A"/>
                 </a:solidFill>
                 <a:latin typeface="Calibri"/>
               </a:rPr>
-              <a:t>one prompt → G=4 completions, reward r ∈ {0,1}</a:t>
-            </a:r>
-          </a:p>
-        </p:txBody>
-      </p:sp>
-      <p:sp>
-        <p:nvSpPr>
-          <p:cNvPr id="6" name="TextBox 5"/>
-          <p:cNvSpPr txBox="1"/>
-          <p:nvPr/>
-        </p:nvSpPr>
-        <p:spPr>
-          <a:xfrm>
-            <a:off x="7818120" y="1481328"/>
-            <a:ext cx="3931920" cy="320040"/>
-          </a:xfrm>
-          <a:prstGeom prst="rect">
-            <a:avLst/>
-          </a:prstGeom>
-          <a:noFill/>
-        </p:spPr>
-        <p:txBody>
-          <a:bodyPr wrap="none">
-            <a:spAutoFit/>
-          </a:bodyPr>
-          <a:lstStyle/>
-          <a:p>
-            <a:pPr algn="l">
-              <a:spcAft>
-                <a:spcPts val="700"/>
-              </a:spcAft>
-            </a:pPr>
-            <a:r>
-              <a:rPr sz="1100" b="1">
-                <a:solidFill>
-                  <a:srgbClr val="212121"/>
-                </a:solidFill>
-                <a:latin typeface="Calibri"/>
-              </a:rPr>
-              <a:t>group with contrast</a:t>
-            </a:r>
-          </a:p>
-        </p:txBody>
-      </p:sp>
-      <p:sp>
-        <p:nvSpPr>
-          <p:cNvPr id="7" name="Rounded Rectangle 6"/>
-          <p:cNvSpPr/>
-          <p:nvPr/>
-        </p:nvSpPr>
-        <p:spPr>
-          <a:xfrm>
-            <a:off x="7818120" y="1828800"/>
-            <a:ext cx="457200" cy="457200"/>
-          </a:xfrm>
-          <a:prstGeom prst="roundRect">
-            <a:avLst/>
-          </a:prstGeom>
-          <a:solidFill>
-            <a:srgbClr val="1F4E79"/>
-          </a:solidFill>
-          <a:ln>
-            <a:solidFill>
-              <a:srgbClr val="1F4E79"/>
-            </a:solidFill>
-          </a:ln>
-        </p:spPr>
-        <p:style>
-          <a:lnRef idx="1">
-            <a:schemeClr val="accent1"/>
-          </a:lnRef>
-          <a:fillRef idx="3">
-            <a:schemeClr val="accent1"/>
-          </a:fillRef>
-          <a:effectRef idx="2">
-            <a:schemeClr val="accent1"/>
-          </a:effectRef>
-          <a:fontRef idx="minor">
-            <a:schemeClr val="lt1"/>
-          </a:fontRef>
-        </p:style>
-        <p:txBody>
-          <a:bodyPr rtlCol="0" anchor="ctr" wrap="square" lIns="45720" rIns="45720"/>
-          <a:lstStyle/>
+              <a:t>Title decoded: GRPO learns from reward contrast inside groups of completions; when a group is all-correct or all-wrong it teaches nothing (signal starvation, measured by the Zero-Variance Fraction), and what a run "shows" depends on the software stack it ran on (stack-conditioned).</a:t>
+            </a:r>
+          </a:p>
           <a:p>
             <a:pPr algn="ctr">
               <a:spcAft>
@@ -6252,57 +6306,15 @@
               </a:spcAft>
             </a:pPr>
             <a:r>
-              <a:rPr sz="1300" b="1">
-                <a:solidFill>
-                  <a:srgbClr val="FFFFFF"/>
-                </a:solidFill>
-                <a:latin typeface="Calibri"/>
-              </a:rPr>
-              <a:t>1</a:t>
-            </a:r>
-          </a:p>
-        </p:txBody>
-      </p:sp>
-      <p:sp>
-        <p:nvSpPr>
-          <p:cNvPr id="8" name="Rounded Rectangle 7"/>
-          <p:cNvSpPr/>
-          <p:nvPr/>
-        </p:nvSpPr>
-        <p:spPr>
-          <a:xfrm>
-            <a:off x="8385048" y="1828800"/>
-            <a:ext cx="457200" cy="457200"/>
-          </a:xfrm>
-          <a:prstGeom prst="roundRect">
-            <a:avLst/>
-          </a:prstGeom>
-          <a:solidFill>
-            <a:srgbClr val="B0B7C0"/>
-          </a:solidFill>
-          <a:ln>
-            <a:solidFill>
-              <a:srgbClr val="B0B7C0"/>
-            </a:solidFill>
-          </a:ln>
-        </p:spPr>
-        <p:style>
-          <a:lnRef idx="1">
-            <a:schemeClr val="accent1"/>
-          </a:lnRef>
-          <a:fillRef idx="3">
-            <a:schemeClr val="accent1"/>
-          </a:fillRef>
-          <a:effectRef idx="2">
-            <a:schemeClr val="accent1"/>
-          </a:effectRef>
-          <a:fontRef idx="minor">
-            <a:schemeClr val="lt1"/>
-          </a:fontRef>
-        </p:style>
-        <p:txBody>
-          <a:bodyPr rtlCol="0" anchor="ctr" wrap="square" lIns="45720" rIns="45720"/>
-          <a:lstStyle/>
+              <a:rPr sz="1500" b="0">
+                <a:solidFill>
+                  <a:srgbClr val="5A5A5A"/>
+                </a:solidFill>
+                <a:latin typeface="Calibri"/>
+              </a:rPr>
+              <a:t>Arvind C R (Arvind Chitra Rajasekaran)  ·  SRN: PES2PGE24DS140</a:t>
+            </a:r>
+          </a:p>
           <a:p>
             <a:pPr algn="ctr">
               <a:spcAft>
@@ -6310,628 +6322,13 @@
               </a:spcAft>
             </a:pPr>
             <a:r>
-              <a:rPr sz="1300" b="1">
-                <a:solidFill>
-                  <a:srgbClr val="FFFFFF"/>
-                </a:solidFill>
-                <a:latin typeface="Calibri"/>
-              </a:rPr>
-              <a:t>0</a:t>
-            </a:r>
-          </a:p>
-        </p:txBody>
-      </p:sp>
-      <p:sp>
-        <p:nvSpPr>
-          <p:cNvPr id="9" name="Rounded Rectangle 8"/>
-          <p:cNvSpPr/>
-          <p:nvPr/>
-        </p:nvSpPr>
-        <p:spPr>
-          <a:xfrm>
-            <a:off x="8951976" y="1828800"/>
-            <a:ext cx="457200" cy="457200"/>
-          </a:xfrm>
-          <a:prstGeom prst="roundRect">
-            <a:avLst/>
-          </a:prstGeom>
-          <a:solidFill>
-            <a:srgbClr val="1F4E79"/>
-          </a:solidFill>
-          <a:ln>
-            <a:solidFill>
-              <a:srgbClr val="1F4E79"/>
-            </a:solidFill>
-          </a:ln>
-        </p:spPr>
-        <p:style>
-          <a:lnRef idx="1">
-            <a:schemeClr val="accent1"/>
-          </a:lnRef>
-          <a:fillRef idx="3">
-            <a:schemeClr val="accent1"/>
-          </a:fillRef>
-          <a:effectRef idx="2">
-            <a:schemeClr val="accent1"/>
-          </a:effectRef>
-          <a:fontRef idx="minor">
-            <a:schemeClr val="lt1"/>
-          </a:fontRef>
-        </p:style>
-        <p:txBody>
-          <a:bodyPr rtlCol="0" anchor="ctr" wrap="square" lIns="45720" rIns="45720"/>
-          <a:lstStyle/>
-          <a:p>
-            <a:pPr algn="ctr">
-              <a:spcAft>
-                <a:spcPts val="700"/>
-              </a:spcAft>
-            </a:pPr>
-            <a:r>
-              <a:rPr sz="1300" b="1">
-                <a:solidFill>
-                  <a:srgbClr val="FFFFFF"/>
-                </a:solidFill>
-                <a:latin typeface="Calibri"/>
-              </a:rPr>
-              <a:t>1</a:t>
-            </a:r>
-          </a:p>
-        </p:txBody>
-      </p:sp>
-      <p:sp>
-        <p:nvSpPr>
-          <p:cNvPr id="10" name="Rounded Rectangle 9"/>
-          <p:cNvSpPr/>
-          <p:nvPr/>
-        </p:nvSpPr>
-        <p:spPr>
-          <a:xfrm>
-            <a:off x="9518904" y="1828800"/>
-            <a:ext cx="457200" cy="457200"/>
-          </a:xfrm>
-          <a:prstGeom prst="roundRect">
-            <a:avLst/>
-          </a:prstGeom>
-          <a:solidFill>
-            <a:srgbClr val="B0B7C0"/>
-          </a:solidFill>
-          <a:ln>
-            <a:solidFill>
-              <a:srgbClr val="B0B7C0"/>
-            </a:solidFill>
-          </a:ln>
-        </p:spPr>
-        <p:style>
-          <a:lnRef idx="1">
-            <a:schemeClr val="accent1"/>
-          </a:lnRef>
-          <a:fillRef idx="3">
-            <a:schemeClr val="accent1"/>
-          </a:fillRef>
-          <a:effectRef idx="2">
-            <a:schemeClr val="accent1"/>
-          </a:effectRef>
-          <a:fontRef idx="minor">
-            <a:schemeClr val="lt1"/>
-          </a:fontRef>
-        </p:style>
-        <p:txBody>
-          <a:bodyPr rtlCol="0" anchor="ctr" wrap="square" lIns="45720" rIns="45720"/>
-          <a:lstStyle/>
-          <a:p>
-            <a:pPr algn="ctr">
-              <a:spcAft>
-                <a:spcPts val="700"/>
-              </a:spcAft>
-            </a:pPr>
-            <a:r>
-              <a:rPr sz="1300" b="1">
-                <a:solidFill>
-                  <a:srgbClr val="FFFFFF"/>
-                </a:solidFill>
-                <a:latin typeface="Calibri"/>
-              </a:rPr>
-              <a:t>0</a:t>
-            </a:r>
-          </a:p>
-        </p:txBody>
-      </p:sp>
-      <p:cxnSp>
-        <p:nvCxnSpPr>
-          <p:cNvPr id="11" name="Connector 10"/>
-          <p:cNvCxnSpPr/>
-          <p:nvPr/>
-        </p:nvCxnSpPr>
-        <p:spPr>
-          <a:xfrm>
-            <a:off x="10195560" y="2057400"/>
-            <a:ext cx="502920" cy="0"/>
-          </a:xfrm>
-          <a:prstGeom prst="line">
-            <a:avLst/>
-          </a:prstGeom>
-          <a:ln w="25400">
-            <a:solidFill>
-              <a:srgbClr val="5A5A5A"/>
-            </a:solidFill>
-          </a:ln>
-        </p:spPr>
-        <p:style>
-          <a:lnRef idx="2">
-            <a:schemeClr val="accent1"/>
-          </a:lnRef>
-          <a:fillRef idx="0">
-            <a:schemeClr val="accent1"/>
-          </a:fillRef>
-          <a:effectRef idx="1">
-            <a:schemeClr val="accent1"/>
-          </a:effectRef>
-          <a:fontRef idx="minor">
-            <a:schemeClr val="tx1"/>
-          </a:fontRef>
-        </p:style>
-      </p:cxnSp>
-      <p:sp>
-        <p:nvSpPr>
-          <p:cNvPr id="12" name="Rounded Rectangle 11"/>
-          <p:cNvSpPr/>
-          <p:nvPr/>
-        </p:nvSpPr>
-        <p:spPr>
-          <a:xfrm>
-            <a:off x="10744200" y="1783080"/>
-            <a:ext cx="1051560" cy="566928"/>
-          </a:xfrm>
-          <a:prstGeom prst="roundRect">
-            <a:avLst/>
-          </a:prstGeom>
-          <a:solidFill>
-            <a:srgbClr val="2E7D32"/>
-          </a:solidFill>
-          <a:ln>
-            <a:solidFill>
-              <a:srgbClr val="2E7D32"/>
-            </a:solidFill>
-          </a:ln>
-        </p:spPr>
-        <p:style>
-          <a:lnRef idx="1">
-            <a:schemeClr val="accent1"/>
-          </a:lnRef>
-          <a:fillRef idx="3">
-            <a:schemeClr val="accent1"/>
-          </a:fillRef>
-          <a:effectRef idx="2">
-            <a:schemeClr val="accent1"/>
-          </a:effectRef>
-          <a:fontRef idx="minor">
-            <a:schemeClr val="lt1"/>
-          </a:fontRef>
-        </p:style>
-        <p:txBody>
-          <a:bodyPr rtlCol="0" anchor="ctr" wrap="square" lIns="45720" rIns="45720"/>
-          <a:lstStyle/>
-          <a:p>
-            <a:pPr algn="ctr">
-              <a:spcAft>
-                <a:spcPts val="700"/>
-              </a:spcAft>
-            </a:pPr>
-            <a:r>
-              <a:rPr sz="900" b="1">
-                <a:solidFill>
-                  <a:srgbClr val="FFFFFF"/>
-                </a:solidFill>
-                <a:latin typeface="Calibri"/>
-              </a:rPr>
-              <a:t>A = ±0.5
-gradient flows</a:t>
-            </a:r>
-          </a:p>
-        </p:txBody>
-      </p:sp>
-      <p:sp>
-        <p:nvSpPr>
-          <p:cNvPr id="13" name="TextBox 12"/>
-          <p:cNvSpPr txBox="1"/>
-          <p:nvPr/>
-        </p:nvSpPr>
-        <p:spPr>
-          <a:xfrm>
-            <a:off x="7818120" y="2606040"/>
-            <a:ext cx="3931920" cy="320040"/>
-          </a:xfrm>
-          <a:prstGeom prst="rect">
-            <a:avLst/>
-          </a:prstGeom>
-          <a:noFill/>
-        </p:spPr>
-        <p:txBody>
-          <a:bodyPr wrap="none">
-            <a:spAutoFit/>
-          </a:bodyPr>
-          <a:lstStyle/>
-          <a:p>
-            <a:pPr algn="l">
-              <a:spcAft>
-                <a:spcPts val="700"/>
-              </a:spcAft>
-            </a:pPr>
-            <a:r>
-              <a:rPr sz="1100" b="1">
-                <a:solidFill>
-                  <a:srgbClr val="212121"/>
-                </a:solidFill>
-                <a:latin typeface="Calibri"/>
-              </a:rPr>
-              <a:t>all-correct group (the blind spot)</a:t>
-            </a:r>
-          </a:p>
-        </p:txBody>
-      </p:sp>
-      <p:sp>
-        <p:nvSpPr>
-          <p:cNvPr id="14" name="Rounded Rectangle 13"/>
-          <p:cNvSpPr/>
-          <p:nvPr/>
-        </p:nvSpPr>
-        <p:spPr>
-          <a:xfrm>
-            <a:off x="7818120" y="2944368"/>
-            <a:ext cx="457200" cy="457200"/>
-          </a:xfrm>
-          <a:prstGeom prst="roundRect">
-            <a:avLst/>
-          </a:prstGeom>
-          <a:solidFill>
-            <a:srgbClr val="1F4E79"/>
-          </a:solidFill>
-          <a:ln>
-            <a:solidFill>
-              <a:srgbClr val="1F4E79"/>
-            </a:solidFill>
-          </a:ln>
-        </p:spPr>
-        <p:style>
-          <a:lnRef idx="1">
-            <a:schemeClr val="accent1"/>
-          </a:lnRef>
-          <a:fillRef idx="3">
-            <a:schemeClr val="accent1"/>
-          </a:fillRef>
-          <a:effectRef idx="2">
-            <a:schemeClr val="accent1"/>
-          </a:effectRef>
-          <a:fontRef idx="minor">
-            <a:schemeClr val="lt1"/>
-          </a:fontRef>
-        </p:style>
-        <p:txBody>
-          <a:bodyPr rtlCol="0" anchor="ctr" wrap="square" lIns="45720" rIns="45720"/>
-          <a:lstStyle/>
-          <a:p>
-            <a:pPr algn="ctr">
-              <a:spcAft>
-                <a:spcPts val="700"/>
-              </a:spcAft>
-            </a:pPr>
-            <a:r>
-              <a:rPr sz="1300" b="1">
-                <a:solidFill>
-                  <a:srgbClr val="FFFFFF"/>
-                </a:solidFill>
-                <a:latin typeface="Calibri"/>
-              </a:rPr>
-              <a:t>1</a:t>
-            </a:r>
-          </a:p>
-        </p:txBody>
-      </p:sp>
-      <p:sp>
-        <p:nvSpPr>
-          <p:cNvPr id="15" name="Rounded Rectangle 14"/>
-          <p:cNvSpPr/>
-          <p:nvPr/>
-        </p:nvSpPr>
-        <p:spPr>
-          <a:xfrm>
-            <a:off x="8385048" y="2944368"/>
-            <a:ext cx="457200" cy="457200"/>
-          </a:xfrm>
-          <a:prstGeom prst="roundRect">
-            <a:avLst/>
-          </a:prstGeom>
-          <a:solidFill>
-            <a:srgbClr val="1F4E79"/>
-          </a:solidFill>
-          <a:ln>
-            <a:solidFill>
-              <a:srgbClr val="1F4E79"/>
-            </a:solidFill>
-          </a:ln>
-        </p:spPr>
-        <p:style>
-          <a:lnRef idx="1">
-            <a:schemeClr val="accent1"/>
-          </a:lnRef>
-          <a:fillRef idx="3">
-            <a:schemeClr val="accent1"/>
-          </a:fillRef>
-          <a:effectRef idx="2">
-            <a:schemeClr val="accent1"/>
-          </a:effectRef>
-          <a:fontRef idx="minor">
-            <a:schemeClr val="lt1"/>
-          </a:fontRef>
-        </p:style>
-        <p:txBody>
-          <a:bodyPr rtlCol="0" anchor="ctr" wrap="square" lIns="45720" rIns="45720"/>
-          <a:lstStyle/>
-          <a:p>
-            <a:pPr algn="ctr">
-              <a:spcAft>
-                <a:spcPts val="700"/>
-              </a:spcAft>
-            </a:pPr>
-            <a:r>
-              <a:rPr sz="1300" b="1">
-                <a:solidFill>
-                  <a:srgbClr val="FFFFFF"/>
-                </a:solidFill>
-                <a:latin typeface="Calibri"/>
-              </a:rPr>
-              <a:t>1</a:t>
-            </a:r>
-          </a:p>
-        </p:txBody>
-      </p:sp>
-      <p:sp>
-        <p:nvSpPr>
-          <p:cNvPr id="16" name="Rounded Rectangle 15"/>
-          <p:cNvSpPr/>
-          <p:nvPr/>
-        </p:nvSpPr>
-        <p:spPr>
-          <a:xfrm>
-            <a:off x="8951976" y="2944368"/>
-            <a:ext cx="457200" cy="457200"/>
-          </a:xfrm>
-          <a:prstGeom prst="roundRect">
-            <a:avLst/>
-          </a:prstGeom>
-          <a:solidFill>
-            <a:srgbClr val="1F4E79"/>
-          </a:solidFill>
-          <a:ln>
-            <a:solidFill>
-              <a:srgbClr val="1F4E79"/>
-            </a:solidFill>
-          </a:ln>
-        </p:spPr>
-        <p:style>
-          <a:lnRef idx="1">
-            <a:schemeClr val="accent1"/>
-          </a:lnRef>
-          <a:fillRef idx="3">
-            <a:schemeClr val="accent1"/>
-          </a:fillRef>
-          <a:effectRef idx="2">
-            <a:schemeClr val="accent1"/>
-          </a:effectRef>
-          <a:fontRef idx="minor">
-            <a:schemeClr val="lt1"/>
-          </a:fontRef>
-        </p:style>
-        <p:txBody>
-          <a:bodyPr rtlCol="0" anchor="ctr" wrap="square" lIns="45720" rIns="45720"/>
-          <a:lstStyle/>
-          <a:p>
-            <a:pPr algn="ctr">
-              <a:spcAft>
-                <a:spcPts val="700"/>
-              </a:spcAft>
-            </a:pPr>
-            <a:r>
-              <a:rPr sz="1300" b="1">
-                <a:solidFill>
-                  <a:srgbClr val="FFFFFF"/>
-                </a:solidFill>
-                <a:latin typeface="Calibri"/>
-              </a:rPr>
-              <a:t>1</a:t>
-            </a:r>
-          </a:p>
-        </p:txBody>
-      </p:sp>
-      <p:sp>
-        <p:nvSpPr>
-          <p:cNvPr id="17" name="Rounded Rectangle 16"/>
-          <p:cNvSpPr/>
-          <p:nvPr/>
-        </p:nvSpPr>
-        <p:spPr>
-          <a:xfrm>
-            <a:off x="9518904" y="2944368"/>
-            <a:ext cx="457200" cy="457200"/>
-          </a:xfrm>
-          <a:prstGeom prst="roundRect">
-            <a:avLst/>
-          </a:prstGeom>
-          <a:solidFill>
-            <a:srgbClr val="1F4E79"/>
-          </a:solidFill>
-          <a:ln>
-            <a:solidFill>
-              <a:srgbClr val="1F4E79"/>
-            </a:solidFill>
-          </a:ln>
-        </p:spPr>
-        <p:style>
-          <a:lnRef idx="1">
-            <a:schemeClr val="accent1"/>
-          </a:lnRef>
-          <a:fillRef idx="3">
-            <a:schemeClr val="accent1"/>
-          </a:fillRef>
-          <a:effectRef idx="2">
-            <a:schemeClr val="accent1"/>
-          </a:effectRef>
-          <a:fontRef idx="minor">
-            <a:schemeClr val="lt1"/>
-          </a:fontRef>
-        </p:style>
-        <p:txBody>
-          <a:bodyPr rtlCol="0" anchor="ctr" wrap="square" lIns="45720" rIns="45720"/>
-          <a:lstStyle/>
-          <a:p>
-            <a:pPr algn="ctr">
-              <a:spcAft>
-                <a:spcPts val="700"/>
-              </a:spcAft>
-            </a:pPr>
-            <a:r>
-              <a:rPr sz="1300" b="1">
-                <a:solidFill>
-                  <a:srgbClr val="FFFFFF"/>
-                </a:solidFill>
-                <a:latin typeface="Calibri"/>
-              </a:rPr>
-              <a:t>1</a:t>
-            </a:r>
-          </a:p>
-        </p:txBody>
-      </p:sp>
-      <p:cxnSp>
-        <p:nvCxnSpPr>
-          <p:cNvPr id="18" name="Connector 17"/>
-          <p:cNvCxnSpPr/>
-          <p:nvPr/>
-        </p:nvCxnSpPr>
-        <p:spPr>
-          <a:xfrm>
-            <a:off x="10195560" y="3172968"/>
-            <a:ext cx="502920" cy="0"/>
-          </a:xfrm>
-          <a:prstGeom prst="line">
-            <a:avLst/>
-          </a:prstGeom>
-          <a:ln w="25400">
-            <a:solidFill>
-              <a:srgbClr val="5A5A5A"/>
-            </a:solidFill>
-          </a:ln>
-        </p:spPr>
-        <p:style>
-          <a:lnRef idx="2">
-            <a:schemeClr val="accent1"/>
-          </a:lnRef>
-          <a:fillRef idx="0">
-            <a:schemeClr val="accent1"/>
-          </a:fillRef>
-          <a:effectRef idx="1">
-            <a:schemeClr val="accent1"/>
-          </a:effectRef>
-          <a:fontRef idx="minor">
-            <a:schemeClr val="tx1"/>
-          </a:fontRef>
-        </p:style>
-      </p:cxnSp>
-      <p:sp>
-        <p:nvSpPr>
-          <p:cNvPr id="19" name="Rounded Rectangle 18"/>
-          <p:cNvSpPr/>
-          <p:nvPr/>
-        </p:nvSpPr>
-        <p:spPr>
-          <a:xfrm>
-            <a:off x="10744200" y="2898648"/>
-            <a:ext cx="1051560" cy="566928"/>
-          </a:xfrm>
-          <a:prstGeom prst="roundRect">
-            <a:avLst/>
-          </a:prstGeom>
-          <a:solidFill>
-            <a:srgbClr val="B32D2D"/>
-          </a:solidFill>
-          <a:ln>
-            <a:solidFill>
-              <a:srgbClr val="B32D2D"/>
-            </a:solidFill>
-          </a:ln>
-        </p:spPr>
-        <p:style>
-          <a:lnRef idx="1">
-            <a:schemeClr val="accent1"/>
-          </a:lnRef>
-          <a:fillRef idx="3">
-            <a:schemeClr val="accent1"/>
-          </a:fillRef>
-          <a:effectRef idx="2">
-            <a:schemeClr val="accent1"/>
-          </a:effectRef>
-          <a:fontRef idx="minor">
-            <a:schemeClr val="lt1"/>
-          </a:fontRef>
-        </p:style>
-        <p:txBody>
-          <a:bodyPr rtlCol="0" anchor="ctr" wrap="square" lIns="45720" rIns="45720"/>
-          <a:lstStyle/>
-          <a:p>
-            <a:pPr algn="ctr">
-              <a:spcAft>
-                <a:spcPts val="700"/>
-              </a:spcAft>
-            </a:pPr>
-            <a:r>
-              <a:rPr sz="900" b="1">
-                <a:solidFill>
-                  <a:srgbClr val="FFFFFF"/>
-                </a:solidFill>
-                <a:latin typeface="Calibri"/>
-              </a:rPr>
-              <a:t>A = 0,0,0,0
-zero gradient</a:t>
-            </a:r>
-          </a:p>
-        </p:txBody>
-      </p:sp>
-      <p:sp>
-        <p:nvSpPr>
-          <p:cNvPr id="20" name="TextBox 19"/>
-          <p:cNvSpPr txBox="1"/>
-          <p:nvPr/>
-        </p:nvSpPr>
-        <p:spPr>
-          <a:xfrm>
-            <a:off x="7818120" y="3657600"/>
-            <a:ext cx="3977639" cy="1005840"/>
-          </a:xfrm>
-          <a:prstGeom prst="rect">
-            <a:avLst/>
-          </a:prstGeom>
-          <a:noFill/>
-        </p:spPr>
-        <p:txBody>
-          <a:bodyPr wrap="none">
-            <a:spAutoFit/>
-          </a:bodyPr>
-          <a:lstStyle/>
-          <a:p>
-            <a:pPr algn="l">
-              <a:spcAft>
-                <a:spcPts val="700"/>
-              </a:spcAft>
-            </a:pPr>
-            <a:r>
-              <a:rPr sz="1050" b="0">
+              <a:rPr sz="1400" b="0">
                 <a:solidFill>
                   <a:srgbClr val="5A5A5A"/>
                 </a:solidFill>
                 <a:latin typeface="Calibri"/>
               </a:rPr>
-              <a:t>A_i = r_i − mean(r): identical rewards zero every advantage.
-The reward curve still reads 1.0 — training has silently stopped.</a:t>
+              <a:t>Guide: Ramesh Prakash Guledgudd  ·  Dept. of CSE, PES University  ·  M.Tech Data Science &amp; AI</a:t>
             </a:r>
           </a:p>
         </p:txBody>
@@ -6988,7 +6385,7 @@
                 </a:solidFill>
                 <a:latin typeface="Calibri"/>
               </a:rPr>
-              <a:t>Problem &amp; Research Questions</a:t>
+              <a:t>Base Paper &amp; My Understanding of It</a:t>
             </a:r>
           </a:p>
         </p:txBody>
@@ -7027,7 +6424,7 @@
                 </a:solidFill>
                 <a:latin typeface="Calibri"/>
               </a:rPr>
-              <a:t>3</a:t>
+              <a:t>2</a:t>
             </a:r>
           </a:p>
         </p:txBody>
@@ -7041,7 +6438,7 @@
         <p:spPr>
           <a:xfrm>
             <a:off x="731520" y="1143000"/>
-            <a:ext cx="10789920" cy="5212080"/>
+            <a:ext cx="6858000" cy="5212080"/>
           </a:xfrm>
           <a:prstGeom prst="rect">
             <a:avLst/>
@@ -7060,13 +6457,13 @@
               </a:spcAft>
             </a:pPr>
             <a:r>
-              <a:rPr sz="1500" b="1">
+              <a:rPr sz="1300" b="1">
                 <a:solidFill>
                   <a:srgbClr val="212121"/>
                 </a:solidFill>
                 <a:latin typeface="Calibri"/>
               </a:rPr>
-              <a:t>•  Signal starvation is silent: mean reward reads "success" exactly when the all-correct wall starves training. You need a second coordinate.</a:t>
+              <a:t>•  Base paper — GRPO, from "DeepSeekMath" (Shao et al., 2024; basis of DeepSeek-R1): replaces PPO's learned critic with a group-relative baseline — sample G completions per prompt, advantage = own reward − group mean.</a:t>
             </a:r>
           </a:p>
           <a:p>
@@ -7076,13 +6473,13 @@
               </a:spcAft>
             </a:pPr>
             <a:r>
-              <a:rPr sz="1500" b="1">
+              <a:rPr sz="1300" b="0">
                 <a:solidFill>
                   <a:srgbClr val="212121"/>
                 </a:solidFill>
                 <a:latin typeface="Calibri"/>
               </a:rPr>
-              <a:t>•  Published results are stack-conditioned: same label, different stacks, different outcomes (measured: a 17× final-reward span from an undisclosed backend+checkpoint swap).</a:t>
+              <a:t>•  Why it matters: critic-free means cheap and stable at LLM scale with verifiable (binary) rewards; it is now the default RL post-training family. The study runs GRPO against PPO, REINFORCE, DPO, GSPO, Dr.GRPO and audited variant labels (slide 5).</a:t>
             </a:r>
           </a:p>
           <a:p>
@@ -7092,13 +6489,854 @@
               </a:spcAft>
             </a:pPr>
             <a:r>
-              <a:rPr sz="1500" b="0">
+              <a:rPr sz="1300" b="1">
                 <a:solidFill>
                   <a:srgbClr val="212121"/>
                 </a:solidFill>
                 <a:latin typeface="Calibri"/>
               </a:rPr>
-              <a:t>•  RQ1 same-stack control · RQ2 ZVF as practical diagnostic · RQ3 group size G as the starvation dial · RQ4 do training gains survive held-out evaluation?</a:t>
+              <a:t>•  My understanding — the structural blind spot: if all G completions earn the SAME reward (all-correct or all-wrong), every centred advantage is exactly zero: the group consumes compute but contributes zero gradient. The reward curve cannot show this; it can read "success" precisely while learning has stopped.</a:t>
+            </a:r>
+          </a:p>
+          <a:p>
+            <a:pPr algn="l">
+              <a:spcAft>
+                <a:spcPts val="700"/>
+              </a:spcAft>
+            </a:pPr>
+            <a:r>
+              <a:rPr sz="1300" b="0">
+                <a:solidFill>
+                  <a:srgbClr val="212121"/>
+                </a:solidFill>
+                <a:latin typeface="Calibri"/>
+              </a:rPr>
+              <a:t>•  Secondary anchor — Dr.GRPO (Liu et al., 2025): claims GRPO's per-length/std normalisation biases updates toward verbosity. I test this claim under controlled conditions (Result 4).</a:t>
+            </a:r>
+          </a:p>
+          <a:p>
+            <a:pPr algn="l">
+              <a:spcAft>
+                <a:spcPts val="700"/>
+              </a:spcAft>
+            </a:pPr>
+            <a:r>
+              <a:rPr sz="1300" b="1">
+                <a:solidFill>
+                  <a:srgbClr val="212121"/>
+                </a:solidFill>
+                <a:latin typeface="Calibri"/>
+              </a:rPr>
+              <a:t>•  Thesis position: measure the blind spot (Zero-Variance Fraction, ZVF), calibrate it, budget it, and show what it changes in practice.</a:t>
+            </a:r>
+          </a:p>
+        </p:txBody>
+      </p:sp>
+      <p:sp>
+        <p:nvSpPr>
+          <p:cNvPr id="5" name="TextBox 4"/>
+          <p:cNvSpPr txBox="1"/>
+          <p:nvPr/>
+        </p:nvSpPr>
+        <p:spPr>
+          <a:xfrm>
+            <a:off x="7818120" y="1051560"/>
+            <a:ext cx="3931920" cy="365760"/>
+          </a:xfrm>
+          <a:prstGeom prst="rect">
+            <a:avLst/>
+          </a:prstGeom>
+          <a:noFill/>
+        </p:spPr>
+        <p:txBody>
+          <a:bodyPr wrap="none">
+            <a:spAutoFit/>
+          </a:bodyPr>
+          <a:lstStyle/>
+          <a:p>
+            <a:pPr algn="ctr">
+              <a:spcAft>
+                <a:spcPts val="700"/>
+              </a:spcAft>
+            </a:pPr>
+            <a:r>
+              <a:rPr sz="1100" b="0">
+                <a:solidFill>
+                  <a:srgbClr val="5A5A5A"/>
+                </a:solidFill>
+                <a:latin typeface="Calibri"/>
+              </a:rPr>
+              <a:t>one prompt → G=4 completions, reward r ∈ {0,1}</a:t>
+            </a:r>
+          </a:p>
+        </p:txBody>
+      </p:sp>
+      <p:sp>
+        <p:nvSpPr>
+          <p:cNvPr id="6" name="TextBox 5"/>
+          <p:cNvSpPr txBox="1"/>
+          <p:nvPr/>
+        </p:nvSpPr>
+        <p:spPr>
+          <a:xfrm>
+            <a:off x="7818120" y="1481328"/>
+            <a:ext cx="3931920" cy="320040"/>
+          </a:xfrm>
+          <a:prstGeom prst="rect">
+            <a:avLst/>
+          </a:prstGeom>
+          <a:noFill/>
+        </p:spPr>
+        <p:txBody>
+          <a:bodyPr wrap="none">
+            <a:spAutoFit/>
+          </a:bodyPr>
+          <a:lstStyle/>
+          <a:p>
+            <a:pPr algn="l">
+              <a:spcAft>
+                <a:spcPts val="700"/>
+              </a:spcAft>
+            </a:pPr>
+            <a:r>
+              <a:rPr sz="1100" b="1">
+                <a:solidFill>
+                  <a:srgbClr val="212121"/>
+                </a:solidFill>
+                <a:latin typeface="Calibri"/>
+              </a:rPr>
+              <a:t>group with contrast</a:t>
+            </a:r>
+          </a:p>
+        </p:txBody>
+      </p:sp>
+      <p:sp>
+        <p:nvSpPr>
+          <p:cNvPr id="7" name="Rounded Rectangle 6"/>
+          <p:cNvSpPr/>
+          <p:nvPr/>
+        </p:nvSpPr>
+        <p:spPr>
+          <a:xfrm>
+            <a:off x="7818120" y="1828800"/>
+            <a:ext cx="457200" cy="457200"/>
+          </a:xfrm>
+          <a:prstGeom prst="roundRect">
+            <a:avLst/>
+          </a:prstGeom>
+          <a:solidFill>
+            <a:srgbClr val="1F4E79"/>
+          </a:solidFill>
+          <a:ln>
+            <a:solidFill>
+              <a:srgbClr val="1F4E79"/>
+            </a:solidFill>
+          </a:ln>
+        </p:spPr>
+        <p:style>
+          <a:lnRef idx="1">
+            <a:schemeClr val="accent1"/>
+          </a:lnRef>
+          <a:fillRef idx="3">
+            <a:schemeClr val="accent1"/>
+          </a:fillRef>
+          <a:effectRef idx="2">
+            <a:schemeClr val="accent1"/>
+          </a:effectRef>
+          <a:fontRef idx="minor">
+            <a:schemeClr val="lt1"/>
+          </a:fontRef>
+        </p:style>
+        <p:txBody>
+          <a:bodyPr rtlCol="0" anchor="ctr" wrap="square" lIns="45720" rIns="45720"/>
+          <a:lstStyle/>
+          <a:p>
+            <a:pPr algn="ctr">
+              <a:spcAft>
+                <a:spcPts val="700"/>
+              </a:spcAft>
+            </a:pPr>
+            <a:r>
+              <a:rPr sz="1300" b="1">
+                <a:solidFill>
+                  <a:srgbClr val="FFFFFF"/>
+                </a:solidFill>
+                <a:latin typeface="Calibri"/>
+              </a:rPr>
+              <a:t>1</a:t>
+            </a:r>
+          </a:p>
+        </p:txBody>
+      </p:sp>
+      <p:sp>
+        <p:nvSpPr>
+          <p:cNvPr id="8" name="Rounded Rectangle 7"/>
+          <p:cNvSpPr/>
+          <p:nvPr/>
+        </p:nvSpPr>
+        <p:spPr>
+          <a:xfrm>
+            <a:off x="8385048" y="1828800"/>
+            <a:ext cx="457200" cy="457200"/>
+          </a:xfrm>
+          <a:prstGeom prst="roundRect">
+            <a:avLst/>
+          </a:prstGeom>
+          <a:solidFill>
+            <a:srgbClr val="B0B7C0"/>
+          </a:solidFill>
+          <a:ln>
+            <a:solidFill>
+              <a:srgbClr val="B0B7C0"/>
+            </a:solidFill>
+          </a:ln>
+        </p:spPr>
+        <p:style>
+          <a:lnRef idx="1">
+            <a:schemeClr val="accent1"/>
+          </a:lnRef>
+          <a:fillRef idx="3">
+            <a:schemeClr val="accent1"/>
+          </a:fillRef>
+          <a:effectRef idx="2">
+            <a:schemeClr val="accent1"/>
+          </a:effectRef>
+          <a:fontRef idx="minor">
+            <a:schemeClr val="lt1"/>
+          </a:fontRef>
+        </p:style>
+        <p:txBody>
+          <a:bodyPr rtlCol="0" anchor="ctr" wrap="square" lIns="45720" rIns="45720"/>
+          <a:lstStyle/>
+          <a:p>
+            <a:pPr algn="ctr">
+              <a:spcAft>
+                <a:spcPts val="700"/>
+              </a:spcAft>
+            </a:pPr>
+            <a:r>
+              <a:rPr sz="1300" b="1">
+                <a:solidFill>
+                  <a:srgbClr val="FFFFFF"/>
+                </a:solidFill>
+                <a:latin typeface="Calibri"/>
+              </a:rPr>
+              <a:t>0</a:t>
+            </a:r>
+          </a:p>
+        </p:txBody>
+      </p:sp>
+      <p:sp>
+        <p:nvSpPr>
+          <p:cNvPr id="9" name="Rounded Rectangle 8"/>
+          <p:cNvSpPr/>
+          <p:nvPr/>
+        </p:nvSpPr>
+        <p:spPr>
+          <a:xfrm>
+            <a:off x="8951976" y="1828800"/>
+            <a:ext cx="457200" cy="457200"/>
+          </a:xfrm>
+          <a:prstGeom prst="roundRect">
+            <a:avLst/>
+          </a:prstGeom>
+          <a:solidFill>
+            <a:srgbClr val="1F4E79"/>
+          </a:solidFill>
+          <a:ln>
+            <a:solidFill>
+              <a:srgbClr val="1F4E79"/>
+            </a:solidFill>
+          </a:ln>
+        </p:spPr>
+        <p:style>
+          <a:lnRef idx="1">
+            <a:schemeClr val="accent1"/>
+          </a:lnRef>
+          <a:fillRef idx="3">
+            <a:schemeClr val="accent1"/>
+          </a:fillRef>
+          <a:effectRef idx="2">
+            <a:schemeClr val="accent1"/>
+          </a:effectRef>
+          <a:fontRef idx="minor">
+            <a:schemeClr val="lt1"/>
+          </a:fontRef>
+        </p:style>
+        <p:txBody>
+          <a:bodyPr rtlCol="0" anchor="ctr" wrap="square" lIns="45720" rIns="45720"/>
+          <a:lstStyle/>
+          <a:p>
+            <a:pPr algn="ctr">
+              <a:spcAft>
+                <a:spcPts val="700"/>
+              </a:spcAft>
+            </a:pPr>
+            <a:r>
+              <a:rPr sz="1300" b="1">
+                <a:solidFill>
+                  <a:srgbClr val="FFFFFF"/>
+                </a:solidFill>
+                <a:latin typeface="Calibri"/>
+              </a:rPr>
+              <a:t>1</a:t>
+            </a:r>
+          </a:p>
+        </p:txBody>
+      </p:sp>
+      <p:sp>
+        <p:nvSpPr>
+          <p:cNvPr id="10" name="Rounded Rectangle 9"/>
+          <p:cNvSpPr/>
+          <p:nvPr/>
+        </p:nvSpPr>
+        <p:spPr>
+          <a:xfrm>
+            <a:off x="9518904" y="1828800"/>
+            <a:ext cx="457200" cy="457200"/>
+          </a:xfrm>
+          <a:prstGeom prst="roundRect">
+            <a:avLst/>
+          </a:prstGeom>
+          <a:solidFill>
+            <a:srgbClr val="B0B7C0"/>
+          </a:solidFill>
+          <a:ln>
+            <a:solidFill>
+              <a:srgbClr val="B0B7C0"/>
+            </a:solidFill>
+          </a:ln>
+        </p:spPr>
+        <p:style>
+          <a:lnRef idx="1">
+            <a:schemeClr val="accent1"/>
+          </a:lnRef>
+          <a:fillRef idx="3">
+            <a:schemeClr val="accent1"/>
+          </a:fillRef>
+          <a:effectRef idx="2">
+            <a:schemeClr val="accent1"/>
+          </a:effectRef>
+          <a:fontRef idx="minor">
+            <a:schemeClr val="lt1"/>
+          </a:fontRef>
+        </p:style>
+        <p:txBody>
+          <a:bodyPr rtlCol="0" anchor="ctr" wrap="square" lIns="45720" rIns="45720"/>
+          <a:lstStyle/>
+          <a:p>
+            <a:pPr algn="ctr">
+              <a:spcAft>
+                <a:spcPts val="700"/>
+              </a:spcAft>
+            </a:pPr>
+            <a:r>
+              <a:rPr sz="1300" b="1">
+                <a:solidFill>
+                  <a:srgbClr val="FFFFFF"/>
+                </a:solidFill>
+                <a:latin typeface="Calibri"/>
+              </a:rPr>
+              <a:t>0</a:t>
+            </a:r>
+          </a:p>
+        </p:txBody>
+      </p:sp>
+      <p:cxnSp>
+        <p:nvCxnSpPr>
+          <p:cNvPr id="11" name="Connector 10"/>
+          <p:cNvCxnSpPr/>
+          <p:nvPr/>
+        </p:nvCxnSpPr>
+        <p:spPr>
+          <a:xfrm>
+            <a:off x="10195560" y="2057400"/>
+            <a:ext cx="502920" cy="0"/>
+          </a:xfrm>
+          <a:prstGeom prst="line">
+            <a:avLst/>
+          </a:prstGeom>
+          <a:ln w="25400">
+            <a:solidFill>
+              <a:srgbClr val="5A5A5A"/>
+            </a:solidFill>
+          </a:ln>
+        </p:spPr>
+        <p:style>
+          <a:lnRef idx="2">
+            <a:schemeClr val="accent1"/>
+          </a:lnRef>
+          <a:fillRef idx="0">
+            <a:schemeClr val="accent1"/>
+          </a:fillRef>
+          <a:effectRef idx="1">
+            <a:schemeClr val="accent1"/>
+          </a:effectRef>
+          <a:fontRef idx="minor">
+            <a:schemeClr val="tx1"/>
+          </a:fontRef>
+        </p:style>
+      </p:cxnSp>
+      <p:sp>
+        <p:nvSpPr>
+          <p:cNvPr id="12" name="Rounded Rectangle 11"/>
+          <p:cNvSpPr/>
+          <p:nvPr/>
+        </p:nvSpPr>
+        <p:spPr>
+          <a:xfrm>
+            <a:off x="10744200" y="1783080"/>
+            <a:ext cx="1051560" cy="566928"/>
+          </a:xfrm>
+          <a:prstGeom prst="roundRect">
+            <a:avLst/>
+          </a:prstGeom>
+          <a:solidFill>
+            <a:srgbClr val="2E7D32"/>
+          </a:solidFill>
+          <a:ln>
+            <a:solidFill>
+              <a:srgbClr val="2E7D32"/>
+            </a:solidFill>
+          </a:ln>
+        </p:spPr>
+        <p:style>
+          <a:lnRef idx="1">
+            <a:schemeClr val="accent1"/>
+          </a:lnRef>
+          <a:fillRef idx="3">
+            <a:schemeClr val="accent1"/>
+          </a:fillRef>
+          <a:effectRef idx="2">
+            <a:schemeClr val="accent1"/>
+          </a:effectRef>
+          <a:fontRef idx="minor">
+            <a:schemeClr val="lt1"/>
+          </a:fontRef>
+        </p:style>
+        <p:txBody>
+          <a:bodyPr rtlCol="0" anchor="ctr" wrap="square" lIns="45720" rIns="45720"/>
+          <a:lstStyle/>
+          <a:p>
+            <a:pPr algn="ctr">
+              <a:spcAft>
+                <a:spcPts val="700"/>
+              </a:spcAft>
+            </a:pPr>
+            <a:r>
+              <a:rPr sz="900" b="1">
+                <a:solidFill>
+                  <a:srgbClr val="FFFFFF"/>
+                </a:solidFill>
+                <a:latin typeface="Calibri"/>
+              </a:rPr>
+              <a:t>A = ±0.5
+gradient flows</a:t>
+            </a:r>
+          </a:p>
+        </p:txBody>
+      </p:sp>
+      <p:sp>
+        <p:nvSpPr>
+          <p:cNvPr id="13" name="TextBox 12"/>
+          <p:cNvSpPr txBox="1"/>
+          <p:nvPr/>
+        </p:nvSpPr>
+        <p:spPr>
+          <a:xfrm>
+            <a:off x="7818120" y="2606040"/>
+            <a:ext cx="3931920" cy="320040"/>
+          </a:xfrm>
+          <a:prstGeom prst="rect">
+            <a:avLst/>
+          </a:prstGeom>
+          <a:noFill/>
+        </p:spPr>
+        <p:txBody>
+          <a:bodyPr wrap="none">
+            <a:spAutoFit/>
+          </a:bodyPr>
+          <a:lstStyle/>
+          <a:p>
+            <a:pPr algn="l">
+              <a:spcAft>
+                <a:spcPts val="700"/>
+              </a:spcAft>
+            </a:pPr>
+            <a:r>
+              <a:rPr sz="1100" b="1">
+                <a:solidFill>
+                  <a:srgbClr val="212121"/>
+                </a:solidFill>
+                <a:latin typeface="Calibri"/>
+              </a:rPr>
+              <a:t>all-correct group (the blind spot)</a:t>
+            </a:r>
+          </a:p>
+        </p:txBody>
+      </p:sp>
+      <p:sp>
+        <p:nvSpPr>
+          <p:cNvPr id="14" name="Rounded Rectangle 13"/>
+          <p:cNvSpPr/>
+          <p:nvPr/>
+        </p:nvSpPr>
+        <p:spPr>
+          <a:xfrm>
+            <a:off x="7818120" y="2944368"/>
+            <a:ext cx="457200" cy="457200"/>
+          </a:xfrm>
+          <a:prstGeom prst="roundRect">
+            <a:avLst/>
+          </a:prstGeom>
+          <a:solidFill>
+            <a:srgbClr val="1F4E79"/>
+          </a:solidFill>
+          <a:ln>
+            <a:solidFill>
+              <a:srgbClr val="1F4E79"/>
+            </a:solidFill>
+          </a:ln>
+        </p:spPr>
+        <p:style>
+          <a:lnRef idx="1">
+            <a:schemeClr val="accent1"/>
+          </a:lnRef>
+          <a:fillRef idx="3">
+            <a:schemeClr val="accent1"/>
+          </a:fillRef>
+          <a:effectRef idx="2">
+            <a:schemeClr val="accent1"/>
+          </a:effectRef>
+          <a:fontRef idx="minor">
+            <a:schemeClr val="lt1"/>
+          </a:fontRef>
+        </p:style>
+        <p:txBody>
+          <a:bodyPr rtlCol="0" anchor="ctr" wrap="square" lIns="45720" rIns="45720"/>
+          <a:lstStyle/>
+          <a:p>
+            <a:pPr algn="ctr">
+              <a:spcAft>
+                <a:spcPts val="700"/>
+              </a:spcAft>
+            </a:pPr>
+            <a:r>
+              <a:rPr sz="1300" b="1">
+                <a:solidFill>
+                  <a:srgbClr val="FFFFFF"/>
+                </a:solidFill>
+                <a:latin typeface="Calibri"/>
+              </a:rPr>
+              <a:t>1</a:t>
+            </a:r>
+          </a:p>
+        </p:txBody>
+      </p:sp>
+      <p:sp>
+        <p:nvSpPr>
+          <p:cNvPr id="15" name="Rounded Rectangle 14"/>
+          <p:cNvSpPr/>
+          <p:nvPr/>
+        </p:nvSpPr>
+        <p:spPr>
+          <a:xfrm>
+            <a:off x="8385048" y="2944368"/>
+            <a:ext cx="457200" cy="457200"/>
+          </a:xfrm>
+          <a:prstGeom prst="roundRect">
+            <a:avLst/>
+          </a:prstGeom>
+          <a:solidFill>
+            <a:srgbClr val="1F4E79"/>
+          </a:solidFill>
+          <a:ln>
+            <a:solidFill>
+              <a:srgbClr val="1F4E79"/>
+            </a:solidFill>
+          </a:ln>
+        </p:spPr>
+        <p:style>
+          <a:lnRef idx="1">
+            <a:schemeClr val="accent1"/>
+          </a:lnRef>
+          <a:fillRef idx="3">
+            <a:schemeClr val="accent1"/>
+          </a:fillRef>
+          <a:effectRef idx="2">
+            <a:schemeClr val="accent1"/>
+          </a:effectRef>
+          <a:fontRef idx="minor">
+            <a:schemeClr val="lt1"/>
+          </a:fontRef>
+        </p:style>
+        <p:txBody>
+          <a:bodyPr rtlCol="0" anchor="ctr" wrap="square" lIns="45720" rIns="45720"/>
+          <a:lstStyle/>
+          <a:p>
+            <a:pPr algn="ctr">
+              <a:spcAft>
+                <a:spcPts val="700"/>
+              </a:spcAft>
+            </a:pPr>
+            <a:r>
+              <a:rPr sz="1300" b="1">
+                <a:solidFill>
+                  <a:srgbClr val="FFFFFF"/>
+                </a:solidFill>
+                <a:latin typeface="Calibri"/>
+              </a:rPr>
+              <a:t>1</a:t>
+            </a:r>
+          </a:p>
+        </p:txBody>
+      </p:sp>
+      <p:sp>
+        <p:nvSpPr>
+          <p:cNvPr id="16" name="Rounded Rectangle 15"/>
+          <p:cNvSpPr/>
+          <p:nvPr/>
+        </p:nvSpPr>
+        <p:spPr>
+          <a:xfrm>
+            <a:off x="8951976" y="2944368"/>
+            <a:ext cx="457200" cy="457200"/>
+          </a:xfrm>
+          <a:prstGeom prst="roundRect">
+            <a:avLst/>
+          </a:prstGeom>
+          <a:solidFill>
+            <a:srgbClr val="1F4E79"/>
+          </a:solidFill>
+          <a:ln>
+            <a:solidFill>
+              <a:srgbClr val="1F4E79"/>
+            </a:solidFill>
+          </a:ln>
+        </p:spPr>
+        <p:style>
+          <a:lnRef idx="1">
+            <a:schemeClr val="accent1"/>
+          </a:lnRef>
+          <a:fillRef idx="3">
+            <a:schemeClr val="accent1"/>
+          </a:fillRef>
+          <a:effectRef idx="2">
+            <a:schemeClr val="accent1"/>
+          </a:effectRef>
+          <a:fontRef idx="minor">
+            <a:schemeClr val="lt1"/>
+          </a:fontRef>
+        </p:style>
+        <p:txBody>
+          <a:bodyPr rtlCol="0" anchor="ctr" wrap="square" lIns="45720" rIns="45720"/>
+          <a:lstStyle/>
+          <a:p>
+            <a:pPr algn="ctr">
+              <a:spcAft>
+                <a:spcPts val="700"/>
+              </a:spcAft>
+            </a:pPr>
+            <a:r>
+              <a:rPr sz="1300" b="1">
+                <a:solidFill>
+                  <a:srgbClr val="FFFFFF"/>
+                </a:solidFill>
+                <a:latin typeface="Calibri"/>
+              </a:rPr>
+              <a:t>1</a:t>
+            </a:r>
+          </a:p>
+        </p:txBody>
+      </p:sp>
+      <p:sp>
+        <p:nvSpPr>
+          <p:cNvPr id="17" name="Rounded Rectangle 16"/>
+          <p:cNvSpPr/>
+          <p:nvPr/>
+        </p:nvSpPr>
+        <p:spPr>
+          <a:xfrm>
+            <a:off x="9518904" y="2944368"/>
+            <a:ext cx="457200" cy="457200"/>
+          </a:xfrm>
+          <a:prstGeom prst="roundRect">
+            <a:avLst/>
+          </a:prstGeom>
+          <a:solidFill>
+            <a:srgbClr val="1F4E79"/>
+          </a:solidFill>
+          <a:ln>
+            <a:solidFill>
+              <a:srgbClr val="1F4E79"/>
+            </a:solidFill>
+          </a:ln>
+        </p:spPr>
+        <p:style>
+          <a:lnRef idx="1">
+            <a:schemeClr val="accent1"/>
+          </a:lnRef>
+          <a:fillRef idx="3">
+            <a:schemeClr val="accent1"/>
+          </a:fillRef>
+          <a:effectRef idx="2">
+            <a:schemeClr val="accent1"/>
+          </a:effectRef>
+          <a:fontRef idx="minor">
+            <a:schemeClr val="lt1"/>
+          </a:fontRef>
+        </p:style>
+        <p:txBody>
+          <a:bodyPr rtlCol="0" anchor="ctr" wrap="square" lIns="45720" rIns="45720"/>
+          <a:lstStyle/>
+          <a:p>
+            <a:pPr algn="ctr">
+              <a:spcAft>
+                <a:spcPts val="700"/>
+              </a:spcAft>
+            </a:pPr>
+            <a:r>
+              <a:rPr sz="1300" b="1">
+                <a:solidFill>
+                  <a:srgbClr val="FFFFFF"/>
+                </a:solidFill>
+                <a:latin typeface="Calibri"/>
+              </a:rPr>
+              <a:t>1</a:t>
+            </a:r>
+          </a:p>
+        </p:txBody>
+      </p:sp>
+      <p:cxnSp>
+        <p:nvCxnSpPr>
+          <p:cNvPr id="18" name="Connector 17"/>
+          <p:cNvCxnSpPr/>
+          <p:nvPr/>
+        </p:nvCxnSpPr>
+        <p:spPr>
+          <a:xfrm>
+            <a:off x="10195560" y="3172968"/>
+            <a:ext cx="502920" cy="0"/>
+          </a:xfrm>
+          <a:prstGeom prst="line">
+            <a:avLst/>
+          </a:prstGeom>
+          <a:ln w="25400">
+            <a:solidFill>
+              <a:srgbClr val="5A5A5A"/>
+            </a:solidFill>
+          </a:ln>
+        </p:spPr>
+        <p:style>
+          <a:lnRef idx="2">
+            <a:schemeClr val="accent1"/>
+          </a:lnRef>
+          <a:fillRef idx="0">
+            <a:schemeClr val="accent1"/>
+          </a:fillRef>
+          <a:effectRef idx="1">
+            <a:schemeClr val="accent1"/>
+          </a:effectRef>
+          <a:fontRef idx="minor">
+            <a:schemeClr val="tx1"/>
+          </a:fontRef>
+        </p:style>
+      </p:cxnSp>
+      <p:sp>
+        <p:nvSpPr>
+          <p:cNvPr id="19" name="Rounded Rectangle 18"/>
+          <p:cNvSpPr/>
+          <p:nvPr/>
+        </p:nvSpPr>
+        <p:spPr>
+          <a:xfrm>
+            <a:off x="10744200" y="2898648"/>
+            <a:ext cx="1051560" cy="566928"/>
+          </a:xfrm>
+          <a:prstGeom prst="roundRect">
+            <a:avLst/>
+          </a:prstGeom>
+          <a:solidFill>
+            <a:srgbClr val="B32D2D"/>
+          </a:solidFill>
+          <a:ln>
+            <a:solidFill>
+              <a:srgbClr val="B32D2D"/>
+            </a:solidFill>
+          </a:ln>
+        </p:spPr>
+        <p:style>
+          <a:lnRef idx="1">
+            <a:schemeClr val="accent1"/>
+          </a:lnRef>
+          <a:fillRef idx="3">
+            <a:schemeClr val="accent1"/>
+          </a:fillRef>
+          <a:effectRef idx="2">
+            <a:schemeClr val="accent1"/>
+          </a:effectRef>
+          <a:fontRef idx="minor">
+            <a:schemeClr val="lt1"/>
+          </a:fontRef>
+        </p:style>
+        <p:txBody>
+          <a:bodyPr rtlCol="0" anchor="ctr" wrap="square" lIns="45720" rIns="45720"/>
+          <a:lstStyle/>
+          <a:p>
+            <a:pPr algn="ctr">
+              <a:spcAft>
+                <a:spcPts val="700"/>
+              </a:spcAft>
+            </a:pPr>
+            <a:r>
+              <a:rPr sz="900" b="1">
+                <a:solidFill>
+                  <a:srgbClr val="FFFFFF"/>
+                </a:solidFill>
+                <a:latin typeface="Calibri"/>
+              </a:rPr>
+              <a:t>A = 0,0,0,0
+zero gradient</a:t>
+            </a:r>
+          </a:p>
+        </p:txBody>
+      </p:sp>
+      <p:sp>
+        <p:nvSpPr>
+          <p:cNvPr id="20" name="TextBox 19"/>
+          <p:cNvSpPr txBox="1"/>
+          <p:nvPr/>
+        </p:nvSpPr>
+        <p:spPr>
+          <a:xfrm>
+            <a:off x="7818120" y="3657600"/>
+            <a:ext cx="3977639" cy="1005840"/>
+          </a:xfrm>
+          <a:prstGeom prst="rect">
+            <a:avLst/>
+          </a:prstGeom>
+          <a:noFill/>
+        </p:spPr>
+        <p:txBody>
+          <a:bodyPr wrap="none">
+            <a:spAutoFit/>
+          </a:bodyPr>
+          <a:lstStyle/>
+          <a:p>
+            <a:pPr algn="l">
+              <a:spcAft>
+                <a:spcPts val="700"/>
+              </a:spcAft>
+            </a:pPr>
+            <a:r>
+              <a:rPr sz="1050" b="0">
+                <a:solidFill>
+                  <a:srgbClr val="5A5A5A"/>
+                </a:solidFill>
+                <a:latin typeface="Calibri"/>
+              </a:rPr>
+              <a:t>A_i = r_i − mean(r): identical rewards zero every advantage.
+The reward curve still reads 1.0 — training has silently stopped.</a:t>
             </a:r>
           </a:p>
         </p:txBody>
@@ -7112,6 +7350,173 @@
 </file>
 
 <file path=ppt/slides/slide4.xml><?xml version="1.0" encoding="utf-8"?>
+<p:sld xmlns:a="http://schemas.openxmlformats.org/drawingml/2006/main" xmlns:p="http://schemas.openxmlformats.org/presentationml/2006/main" xmlns:r="http://schemas.openxmlformats.org/officeDocument/2006/relationships">
+  <p:cSld>
+    <p:spTree>
+      <p:nvGrpSpPr>
+        <p:cNvPr id="1" name=""/>
+        <p:cNvGrpSpPr/>
+        <p:nvPr/>
+      </p:nvGrpSpPr>
+      <p:grpSpPr/>
+      <p:sp>
+        <p:nvSpPr>
+          <p:cNvPr id="2" name="TextBox 1"/>
+          <p:cNvSpPr txBox="1"/>
+          <p:nvPr/>
+        </p:nvSpPr>
+        <p:spPr>
+          <a:xfrm>
+            <a:off x="548640" y="274320"/>
+            <a:ext cx="11064240" cy="731520"/>
+          </a:xfrm>
+          <a:prstGeom prst="rect">
+            <a:avLst/>
+          </a:prstGeom>
+          <a:noFill/>
+        </p:spPr>
+        <p:txBody>
+          <a:bodyPr wrap="none">
+            <a:spAutoFit/>
+          </a:bodyPr>
+          <a:lstStyle/>
+          <a:p>
+            <a:pPr algn="l">
+              <a:spcAft>
+                <a:spcPts val="700"/>
+              </a:spcAft>
+            </a:pPr>
+            <a:r>
+              <a:rPr sz="2700" b="1">
+                <a:solidFill>
+                  <a:srgbClr val="1F4E79"/>
+                </a:solidFill>
+                <a:latin typeface="Calibri"/>
+              </a:rPr>
+              <a:t>Problem &amp; Research Questions</a:t>
+            </a:r>
+          </a:p>
+        </p:txBody>
+      </p:sp>
+      <p:sp>
+        <p:nvSpPr>
+          <p:cNvPr id="3" name="TextBox 2"/>
+          <p:cNvSpPr txBox="1"/>
+          <p:nvPr/>
+        </p:nvSpPr>
+        <p:spPr>
+          <a:xfrm>
+            <a:off x="11430000" y="6446520"/>
+            <a:ext cx="548640" cy="320040"/>
+          </a:xfrm>
+          <a:prstGeom prst="rect">
+            <a:avLst/>
+          </a:prstGeom>
+          <a:noFill/>
+        </p:spPr>
+        <p:txBody>
+          <a:bodyPr wrap="none">
+            <a:spAutoFit/>
+          </a:bodyPr>
+          <a:lstStyle/>
+          <a:p>
+            <a:pPr algn="l">
+              <a:spcAft>
+                <a:spcPts val="700"/>
+              </a:spcAft>
+            </a:pPr>
+            <a:r>
+              <a:rPr sz="1100" b="0">
+                <a:solidFill>
+                  <a:srgbClr val="5A5A5A"/>
+                </a:solidFill>
+                <a:latin typeface="Calibri"/>
+              </a:rPr>
+              <a:t>3</a:t>
+            </a:r>
+          </a:p>
+        </p:txBody>
+      </p:sp>
+      <p:sp>
+        <p:nvSpPr>
+          <p:cNvPr id="4" name="TextBox 3"/>
+          <p:cNvSpPr txBox="1"/>
+          <p:nvPr/>
+        </p:nvSpPr>
+        <p:spPr>
+          <a:xfrm>
+            <a:off x="731520" y="1143000"/>
+            <a:ext cx="10789920" cy="5212080"/>
+          </a:xfrm>
+          <a:prstGeom prst="rect">
+            <a:avLst/>
+          </a:prstGeom>
+          <a:noFill/>
+        </p:spPr>
+        <p:txBody>
+          <a:bodyPr wrap="square">
+            <a:spAutoFit/>
+          </a:bodyPr>
+          <a:lstStyle/>
+          <a:p>
+            <a:pPr algn="l">
+              <a:spcAft>
+                <a:spcPts val="700"/>
+              </a:spcAft>
+            </a:pPr>
+            <a:r>
+              <a:rPr sz="1500" b="1">
+                <a:solidFill>
+                  <a:srgbClr val="212121"/>
+                </a:solidFill>
+                <a:latin typeface="Calibri"/>
+              </a:rPr>
+              <a:t>•  Signal starvation is silent: mean reward reads "success" exactly when the all-correct wall starves training. You need a second coordinate.</a:t>
+            </a:r>
+          </a:p>
+          <a:p>
+            <a:pPr algn="l">
+              <a:spcAft>
+                <a:spcPts val="700"/>
+              </a:spcAft>
+            </a:pPr>
+            <a:r>
+              <a:rPr sz="1500" b="1">
+                <a:solidFill>
+                  <a:srgbClr val="212121"/>
+                </a:solidFill>
+                <a:latin typeface="Calibri"/>
+              </a:rPr>
+              <a:t>•  Published results are stack-conditioned: same label, different stacks, different outcomes (measured: a 17× final-reward span from an undisclosed backend+checkpoint swap).</a:t>
+            </a:r>
+          </a:p>
+          <a:p>
+            <a:pPr algn="l">
+              <a:spcAft>
+                <a:spcPts val="700"/>
+              </a:spcAft>
+            </a:pPr>
+            <a:r>
+              <a:rPr sz="1500" b="0">
+                <a:solidFill>
+                  <a:srgbClr val="212121"/>
+                </a:solidFill>
+                <a:latin typeface="Calibri"/>
+              </a:rPr>
+              <a:t>•  RQ1 same-stack control · RQ2 ZVF as practical diagnostic · RQ3 group size G as the starvation dial · RQ4 do training gains survive held-out evaluation?</a:t>
+            </a:r>
+          </a:p>
+        </p:txBody>
+      </p:sp>
+    </p:spTree>
+  </p:cSld>
+  <p:clrMapOvr>
+    <a:masterClrMapping/>
+  </p:clrMapOvr>
+</p:sld>
+</file>
+
+<file path=ppt/slides/slide5.xml><?xml version="1.0" encoding="utf-8"?>
 <p:sld xmlns:a="http://schemas.openxmlformats.org/drawingml/2006/main" xmlns:p="http://schemas.openxmlformats.org/presentationml/2006/main" xmlns:r="http://schemas.openxmlformats.org/officeDocument/2006/relationships">
   <p:cSld>
     <p:spTree>
@@ -7777,7 +8182,7 @@
 </p:sld>
 </file>
 
-<file path=ppt/slides/slide5.xml><?xml version="1.0" encoding="utf-8"?>
+<file path=ppt/slides/slide6.xml><?xml version="1.0" encoding="utf-8"?>
 <p:sld xmlns:a="http://schemas.openxmlformats.org/drawingml/2006/main" xmlns:p="http://schemas.openxmlformats.org/presentationml/2006/main" xmlns:r="http://schemas.openxmlformats.org/officeDocument/2006/relationships">
   <p:cSld>
     <p:spTree>
@@ -8460,7 +8865,7 @@
 </p:sld>
 </file>
 
-<file path=ppt/slides/slide6.xml><?xml version="1.0" encoding="utf-8"?>
+<file path=ppt/slides/slide7.xml><?xml version="1.0" encoding="utf-8"?>
 <p:sld xmlns:a="http://schemas.openxmlformats.org/drawingml/2006/main" xmlns:p="http://schemas.openxmlformats.org/presentationml/2006/main" xmlns:r="http://schemas.openxmlformats.org/officeDocument/2006/relationships">
   <p:cSld>
     <p:spTree>
@@ -8675,7 +9080,7 @@
 </p:sld>
 </file>
 
-<file path=ppt/slides/slide7.xml><?xml version="1.0" encoding="utf-8"?>
+<file path=ppt/slides/slide8.xml><?xml version="1.0" encoding="utf-8"?>
 <p:sld xmlns:a="http://schemas.openxmlformats.org/drawingml/2006/main" xmlns:p="http://schemas.openxmlformats.org/presentationml/2006/main" xmlns:r="http://schemas.openxmlformats.org/officeDocument/2006/relationships">
   <p:cSld>
     <p:spTree>
@@ -9106,7 +9511,7 @@
 </p:sld>
 </file>
 
-<file path=ppt/slides/slide8.xml><?xml version="1.0" encoding="utf-8"?>
+<file path=ppt/slides/slide9.xml><?xml version="1.0" encoding="utf-8"?>
 <p:sld xmlns:a="http://schemas.openxmlformats.org/drawingml/2006/main" xmlns:p="http://schemas.openxmlformats.org/presentationml/2006/main" xmlns:r="http://schemas.openxmlformats.org/officeDocument/2006/relationships">
   <p:cSld>
     <p:spTree>
@@ -9305,189 +9710,6 @@
           </a:prstGeom>
         </p:spPr>
       </p:pic>
-    </p:spTree>
-  </p:cSld>
-  <p:clrMapOvr>
-    <a:masterClrMapping/>
-  </p:clrMapOvr>
-</p:sld>
-</file>
-
-<file path=ppt/slides/slide9.xml><?xml version="1.0" encoding="utf-8"?>
-<p:sld xmlns:a="http://schemas.openxmlformats.org/drawingml/2006/main" xmlns:p="http://schemas.openxmlformats.org/presentationml/2006/main" xmlns:r="http://schemas.openxmlformats.org/officeDocument/2006/relationships">
-  <p:cSld>
-    <p:spTree>
-      <p:nvGrpSpPr>
-        <p:cNvPr id="1" name=""/>
-        <p:cNvGrpSpPr/>
-        <p:nvPr/>
-      </p:nvGrpSpPr>
-      <p:grpSpPr/>
-      <p:sp>
-        <p:nvSpPr>
-          <p:cNvPr id="2" name="TextBox 1"/>
-          <p:cNvSpPr txBox="1"/>
-          <p:nvPr/>
-        </p:nvSpPr>
-        <p:spPr>
-          <a:xfrm>
-            <a:off x="548640" y="274320"/>
-            <a:ext cx="11064240" cy="731520"/>
-          </a:xfrm>
-          <a:prstGeom prst="rect">
-            <a:avLst/>
-          </a:prstGeom>
-          <a:noFill/>
-        </p:spPr>
-        <p:txBody>
-          <a:bodyPr wrap="none">
-            <a:spAutoFit/>
-          </a:bodyPr>
-          <a:lstStyle/>
-          <a:p>
-            <a:pPr algn="l">
-              <a:spcAft>
-                <a:spcPts val="700"/>
-              </a:spcAft>
-            </a:pPr>
-            <a:r>
-              <a:rPr sz="2700" b="1">
-                <a:solidFill>
-                  <a:srgbClr val="1F4E79"/>
-                </a:solidFill>
-                <a:latin typeface="Calibri"/>
-              </a:rPr>
-              <a:t>Result 3 — The Estimator Is Calibrated, the Budget Is Exact</a:t>
-            </a:r>
-          </a:p>
-        </p:txBody>
-      </p:sp>
-      <p:sp>
-        <p:nvSpPr>
-          <p:cNvPr id="3" name="TextBox 2"/>
-          <p:cNvSpPr txBox="1"/>
-          <p:nvPr/>
-        </p:nvSpPr>
-        <p:spPr>
-          <a:xfrm>
-            <a:off x="11430000" y="6446520"/>
-            <a:ext cx="548640" cy="320040"/>
-          </a:xfrm>
-          <a:prstGeom prst="rect">
-            <a:avLst/>
-          </a:prstGeom>
-          <a:noFill/>
-        </p:spPr>
-        <p:txBody>
-          <a:bodyPr wrap="none">
-            <a:spAutoFit/>
-          </a:bodyPr>
-          <a:lstStyle/>
-          <a:p>
-            <a:pPr algn="l">
-              <a:spcAft>
-                <a:spcPts val="700"/>
-              </a:spcAft>
-            </a:pPr>
-            <a:r>
-              <a:rPr sz="1100" b="0">
-                <a:solidFill>
-                  <a:srgbClr val="5A5A5A"/>
-                </a:solidFill>
-                <a:latin typeface="Calibri"/>
-              </a:rPr>
-              <a:t>9</a:t>
-            </a:r>
-          </a:p>
-        </p:txBody>
-      </p:sp>
-      <p:sp>
-        <p:nvSpPr>
-          <p:cNvPr id="4" name="TextBox 3"/>
-          <p:cNvSpPr txBox="1"/>
-          <p:nvPr/>
-        </p:nvSpPr>
-        <p:spPr>
-          <a:xfrm>
-            <a:off x="731520" y="1143000"/>
-            <a:ext cx="10789920" cy="5212080"/>
-          </a:xfrm>
-          <a:prstGeom prst="rect">
-            <a:avLst/>
-          </a:prstGeom>
-          <a:noFill/>
-        </p:spPr>
-        <p:txBody>
-          <a:bodyPr wrap="square">
-            <a:spAutoFit/>
-          </a:bodyPr>
-          <a:lstStyle/>
-          <a:p>
-            <a:pPr algn="l">
-              <a:spcAft>
-                <a:spcPts val="700"/>
-              </a:spcAft>
-            </a:pPr>
-            <a:r>
-              <a:rPr sz="1500" b="1">
-                <a:solidFill>
-                  <a:srgbClr val="212121"/>
-                </a:solidFill>
-                <a:latin typeface="Calibri"/>
-              </a:rPr>
-              <a:t>•  T1 (calibration): ZVF_t is an unbiased binomial-proportion estimator; Wilson CI covers 0.95–0.98 in every tested setting (Wald marginal at m=32). Curriculum ordering is an estimand-labelling requirement, not an invalidation.</a:t>
-            </a:r>
-          </a:p>
-          <a:p>
-            <a:pPr algn="l">
-              <a:spcAft>
-                <a:spcPts val="700"/>
-              </a:spcAft>
-            </a:pPr>
-            <a:r>
-              <a:rPr sz="1500" b="1">
-                <a:solidFill>
-                  <a:srgbClr val="212121"/>
-                </a:solidFill>
-                <a:latin typeface="Calibri"/>
-              </a:rPr>
-              <a:t>•  T2 (reliability budget): rollouts-to-next-informative-group is geometric; N(ZVF)=G⌈ln δ/ln ZVF⌉ matched observed quantiles at ratio 1.00 across all six difficulty strata (hardest: ZVF=0.886 ⇒ 160 rollouts). A budget, NOT an impossibility bound.</a:t>
-            </a:r>
-          </a:p>
-          <a:p>
-            <a:pPr algn="l">
-              <a:spcAft>
-                <a:spcPts val="700"/>
-              </a:spcAft>
-            </a:pPr>
-            <a:r>
-              <a:rPr sz="1500" b="1">
-                <a:solidFill>
-                  <a:srgbClr val="212121"/>
-                </a:solidFill>
-                <a:latin typeface="Calibri"/>
-              </a:rPr>
-              <a:t>•  T3 (honest negative): the signal-per-rollout objective satisfies J(2)=J(3) for EVERY difficulty prior — its argmax is universally {2,3}, so it cannot yield a data-adaptive G. Found by adversarial review; reported as a result, not buried.</a:t>
-            </a:r>
-          </a:p>
-          <a:p>
-            <a:pPr algn="l">
-              <a:spcAft>
-                <a:spcPts val="700"/>
-              </a:spcAft>
-            </a:pPr>
-            <a:r>
-              <a:rPr sz="1500" b="0">
-                <a:solidFill>
-                  <a:srgbClr val="212121"/>
-                </a:solidFill>
-                <a:latin typeface="Calibri"/>
-              </a:rPr>
-              <a:t>•  Two earlier statement errors (a quantifier confusion in T2; a GU sign slip) were caught by external review, corrected, re-validated — and are documented in the thesis as part of the method.</a:t>
-            </a:r>
-          </a:p>
-        </p:txBody>
-      </p:sp>
     </p:spTree>
   </p:cSld>
   <p:clrMapOvr>

</xml_diff>

<commit_message>
feat(deck): clickable evidence links on the Demo slide + linked closing slide
Six click-to-open links (real URLs, verified against the live W&B API):
the E-R2b G=2 and G=16 headline arms, the preserved invalidated P4 run,
the full zvf-training project, the public HF bench adapter
(tinker-rl-bench-ppo_gsm8k_Qwen3-8B_s42), and the GitHub repo. Closing
slide repo link is now a hyperlink too.
</commit_message>
<xml_diff>
--- a/outputs/PESU_MTech_Phase1_Session1_Review_ArvindCR.pptx
+++ b/outputs/PESU_MTech_Phase1_Session1_Review_ArvindCR.pptx
@@ -5897,7 +5897,7 @@
               </a:spcAft>
             </a:pPr>
             <a:r>
-              <a:rPr sz="1500" b="1">
+              <a:rPr sz="1400" b="1">
                 <a:solidFill>
                   <a:srgbClr val="212121"/>
                 </a:solidFill>
@@ -5913,7 +5913,7 @@
               </a:spcAft>
             </a:pPr>
             <a:r>
-              <a:rPr sz="1500" b="0">
+              <a:rPr sz="1400" b="0">
                 <a:solidFill>
                   <a:srgbClr val="212121"/>
                 </a:solidFill>
@@ -5929,7 +5929,7 @@
               </a:spcAft>
             </a:pPr>
             <a:r>
-              <a:rPr sz="1500" b="0">
+              <a:rPr sz="1400" b="0">
                 <a:solidFill>
                   <a:srgbClr val="212121"/>
                 </a:solidFill>
@@ -5945,13 +5945,154 @@
               </a:spcAft>
             </a:pPr>
             <a:r>
-              <a:rPr sz="1500" b="0">
+              <a:rPr sz="1400" b="0">
                 <a:solidFill>
                   <a:srgbClr val="212121"/>
                 </a:solidFill>
                 <a:latin typeface="Calibri"/>
               </a:rPr>
               <a:t>•  Fallback if connectivity fails: 86-second recorded walkthrough (thesis/viva/demo_walkthrough.mp4).</a:t>
+            </a:r>
+          </a:p>
+        </p:txBody>
+      </p:sp>
+      <p:sp>
+        <p:nvSpPr>
+          <p:cNvPr id="5" name="TextBox 4"/>
+          <p:cNvSpPr txBox="1"/>
+          <p:nvPr/>
+        </p:nvSpPr>
+        <p:spPr>
+          <a:xfrm>
+            <a:off x="777240" y="4160520"/>
+            <a:ext cx="10789920" cy="2103120"/>
+          </a:xfrm>
+          <a:prstGeom prst="rect">
+            <a:avLst/>
+          </a:prstGeom>
+          <a:noFill/>
+        </p:spPr>
+        <p:txBody>
+          <a:bodyPr wrap="square">
+            <a:spAutoFit/>
+          </a:bodyPr>
+          <a:lstStyle/>
+          <a:p>
+            <a:pPr algn="l">
+              <a:spcAft>
+                <a:spcPts val="700"/>
+              </a:spcAft>
+            </a:pPr>
+            <a:r>
+              <a:rPr sz="1400" b="1">
+                <a:solidFill>
+                  <a:srgbClr val="212121"/>
+                </a:solidFill>
+                <a:latin typeface="Calibri"/>
+              </a:rPr>
+              <a:t>Click-to-open evidence (live):</a:t>
+            </a:r>
+          </a:p>
+          <a:p>
+            <a:pPr>
+              <a:spcAft>
+                <a:spcPts val="600"/>
+              </a:spcAft>
+            </a:pPr>
+            <a:r>
+              <a:rPr sz="1300" u="sng">
+                <a:solidFill>
+                  <a:srgbClr val="0B5CAB"/>
+                </a:solidFill>
+                <a:latin typeface="Calibri"/>
+                <a:hlinkClick r:id="rId3"/>
+              </a:rPr>
+              <a:t>↗  W&amp;B: E-R2b G=2 arm — reward hits ~1.0 while ZVF climbs into the wall (er2b_g2_s123)</a:t>
+            </a:r>
+          </a:p>
+          <a:p>
+            <a:pPr>
+              <a:spcAft>
+                <a:spcPts val="600"/>
+              </a:spcAft>
+            </a:pPr>
+            <a:r>
+              <a:rPr sz="1300" u="sng">
+                <a:solidFill>
+                  <a:srgbClr val="0B5CAB"/>
+                </a:solidFill>
+                <a:latin typeface="Calibri"/>
+                <a:hlinkClick r:id="rId4"/>
+              </a:rPr>
+              <a:t>↗  W&amp;B: E-R2b G=16 arm — mid-learning, ZVF low, signal intact (er2b_g16_s123)</a:t>
+            </a:r>
+          </a:p>
+          <a:p>
+            <a:pPr>
+              <a:spcAft>
+                <a:spcPts val="600"/>
+              </a:spcAft>
+            </a:pPr>
+            <a:r>
+              <a:rPr sz="1300" u="sng">
+                <a:solidFill>
+                  <a:srgbClr val="0B5CAB"/>
+                </a:solidFill>
+                <a:latin typeface="Calibri"/>
+                <a:hlinkClick r:id="rId5"/>
+              </a:rPr>
+              <a:t>↗  W&amp;B: the invalidated P4 arm, preserved (p4uncap_drgrpo_s42.invalid_actually_grpo)</a:t>
+            </a:r>
+          </a:p>
+          <a:p>
+            <a:pPr>
+              <a:spcAft>
+                <a:spcPts val="600"/>
+              </a:spcAft>
+            </a:pPr>
+            <a:r>
+              <a:rPr sz="1300" u="sng">
+                <a:solidFill>
+                  <a:srgbClr val="0B5CAB"/>
+                </a:solidFill>
+                <a:latin typeface="Calibri"/>
+                <a:hlinkClick r:id="rId6"/>
+              </a:rPr>
+              <a:t>↗  W&amp;B: full zvf-training project (45 runs)</a:t>
+            </a:r>
+          </a:p>
+          <a:p>
+            <a:pPr>
+              <a:spcAft>
+                <a:spcPts val="600"/>
+              </a:spcAft>
+            </a:pPr>
+            <a:r>
+              <a:rPr sz="1300" u="sng">
+                <a:solidFill>
+                  <a:srgbClr val="0B5CAB"/>
+                </a:solidFill>
+                <a:latin typeface="Calibri"/>
+                <a:hlinkClick r:id="rId7"/>
+              </a:rPr>
+              <a:t>↗  HuggingFace: published bench adapters (e.g. tinker-rl-bench-ppo_gsm8k_Qwen3-8B_s42)</a:t>
+            </a:r>
+          </a:p>
+          <a:p>
+            <a:pPr>
+              <a:spcAft>
+                <a:spcPts val="600"/>
+              </a:spcAft>
+            </a:pPr>
+            <a:r>
+              <a:rPr sz="1300" u="sng">
+                <a:solidFill>
+                  <a:srgbClr val="0B5CAB"/>
+                </a:solidFill>
+                <a:latin typeface="Calibri"/>
+                <a:hlinkClick r:id="rId8"/>
+              </a:rPr>
+              <a:t>↗  GitHub: arvindcr4/tinker-rl-lab (code, artifacts, audit workbook)</a:t>
             </a:r>
           </a:p>
         </p:txBody>
@@ -6207,7 +6348,26 @@
                 </a:solidFill>
                 <a:latin typeface="Calibri"/>
               </a:rPr>
-              <a:t>github.com/arvindcr4/tinker-rl-lab  ·  arvindcr4@gmail.com</a:t>
+              <a:t/>
+            </a:r>
+            <a:r>
+              <a:rPr sz="1500" u="sng">
+                <a:solidFill>
+                  <a:srgbClr val="0B5CAB"/>
+                </a:solidFill>
+                <a:latin typeface="Calibri"/>
+                <a:hlinkClick r:id="rId3"/>
+              </a:rPr>
+              <a:t>github.com/arvindcr4/tinker-rl-lab</a:t>
+            </a:r>
+            <a:r>
+              <a:rPr sz="1500">
+                <a:solidFill>
+                  <a:srgbClr val="5A5A5A"/>
+                </a:solidFill>
+                <a:latin typeface="Calibri"/>
+              </a:rPr>
+              <a:t>   ·   arvindcr4@gmail.com</a:t>
             </a:r>
           </a:p>
         </p:txBody>

</xml_diff>